<commit_message>
Add ungrouped slide to group transform fixture
</commit_message>
<xml_diff>
--- a/test/read/fixtures/group-transform.pptx
+++ b/test/read/fixtures/group-transform.pptx
@@ -6,6 +6,7 @@
   </p:sldMasterIdLst>
   <p:sldIdLst>
     <p:sldId id="256" r:id="rId2"/>
+    <p:sldId id="257" r:id="rId3"/>
   </p:sldIdLst>
   <p:sldSz cx="12192000" cy="6858000"/>
   <p:notesSz cx="6858000" cy="9144000"/>
@@ -104,6 +105,11 @@
       </a:defRPr>
     </a:lvl9pPr>
   </p:defaultTextStyle>
+  <p:extLst>
+    <p:ext uri="{EFAFB233-063F-42B5-8137-9DF3F51BA10A}">
+      <p15:sldGuideLst xmlns:p15="http://schemas.microsoft.com/office/powerpoint/2012/main"/>
+    </p:ext>
+  </p:extLst>
 </p:presentation>
 </file>
 
@@ -4315,6 +4321,942 @@
     <p:extLst>
       <p:ext uri="{BB962C8B-B14F-4D97-AF65-F5344CB8AC3E}">
         <p14:creationId xmlns:p14="http://schemas.microsoft.com/office/powerpoint/2010/main" val="2349191783"/>
+      </p:ext>
+    </p:extLst>
+  </p:cSld>
+  <p:clrMapOvr>
+    <a:masterClrMapping/>
+  </p:clrMapOvr>
+</p:sld>
+</file>
+
+<file path=ppt/slides/slide2.xml><?xml version="1.0" encoding="utf-8"?>
+<p:sld xmlns:a="http://schemas.openxmlformats.org/drawingml/2006/main" xmlns:r="http://schemas.openxmlformats.org/officeDocument/2006/relationships" xmlns:p="http://schemas.openxmlformats.org/presentationml/2006/main">
+  <p:cSld name="group-transform-ungrouped">
+    <p:spTree>
+      <p:nvGrpSpPr>
+        <p:cNvPr id="1" name=""/>
+        <p:cNvGrpSpPr/>
+        <p:nvPr/>
+      </p:nvGrpSpPr>
+      <p:grpSpPr>
+        <a:xfrm>
+          <a:off x="0" y="0"/>
+          <a:ext cx="0" cy="0"/>
+          <a:chOff x="0" y="0"/>
+          <a:chExt cx="0" cy="0"/>
+        </a:xfrm>
+      </p:grpSpPr>
+      <p:sp>
+        <p:nvSpPr>
+          <p:cNvPr id="2" name="TextBox 1">
+            <a:extLst>
+              <a:ext uri="{FF2B5EF4-FFF2-40B4-BE49-F238E27FC236}">
+                <a16:creationId xmlns:a16="http://schemas.microsoft.com/office/drawing/2014/main" id="{65E2148E-E34D-70F4-F3C6-5BA4B5CEC6B7}"/>
+              </a:ext>
+            </a:extLst>
+          </p:cNvPr>
+          <p:cNvSpPr txBox="1"/>
+          <p:nvPr/>
+        </p:nvSpPr>
+        <p:spPr>
+          <a:xfrm>
+            <a:off x="304800" y="203200"/>
+            <a:ext cx="11430000" cy="338554"/>
+          </a:xfrm>
+          <a:prstGeom prst="rect">
+            <a:avLst/>
+          </a:prstGeom>
+          <a:noFill/>
+        </p:spPr>
+        <p:txBody>
+          <a:bodyPr vert="horz" rtlCol="0">
+            <a:spAutoFit/>
+          </a:bodyPr>
+          <a:lstStyle/>
+          <a:p>
+            <a:r>
+              <a:rPr lang="en-US" sz="1600">
+                <a:latin typeface="Aptos" panose="020B0004020202020204" pitchFamily="34" charset="0"/>
+              </a:rPr>
+              <a:t>PowerPoint-authored group transform fixture: same shapes ungrouped by PowerPoint</a:t>
+            </a:r>
+          </a:p>
+        </p:txBody>
+      </p:sp>
+      <p:sp>
+        <p:nvSpPr>
+          <p:cNvPr id="3" name="TextBox 2">
+            <a:extLst>
+              <a:ext uri="{FF2B5EF4-FFF2-40B4-BE49-F238E27FC236}">
+                <a16:creationId xmlns:a16="http://schemas.microsoft.com/office/drawing/2014/main" id="{C855E3B3-D906-3AFA-FC15-F98A633D147B}"/>
+              </a:ext>
+            </a:extLst>
+          </p:cNvPr>
+          <p:cNvSpPr txBox="1"/>
+          <p:nvPr/>
+        </p:nvSpPr>
+        <p:spPr>
+          <a:xfrm>
+            <a:off x="889000" y="850900"/>
+            <a:ext cx="2667000" cy="246221"/>
+          </a:xfrm>
+          <a:prstGeom prst="rect">
+            <a:avLst/>
+          </a:prstGeom>
+          <a:noFill/>
+        </p:spPr>
+        <p:txBody>
+          <a:bodyPr vert="horz" rtlCol="0">
+            <a:spAutoFit/>
+          </a:bodyPr>
+          <a:lstStyle/>
+          <a:p>
+            <a:r>
+              <a:rPr lang="en-US" sz="1000">
+                <a:latin typeface="Aptos" panose="020B0004020202020204" pitchFamily="34" charset="0"/>
+              </a:rPr>
+              <a:t>rot30</a:t>
+            </a:r>
+          </a:p>
+        </p:txBody>
+      </p:sp>
+      <p:sp>
+        <p:nvSpPr>
+          <p:cNvPr id="4" name="rot30-ungrouped child blue rect">
+            <a:extLst>
+              <a:ext uri="{FF2B5EF4-FFF2-40B4-BE49-F238E27FC236}">
+                <a16:creationId xmlns:a16="http://schemas.microsoft.com/office/drawing/2014/main" id="{26E23C0F-C529-A01B-802A-2DFA1202F33E}"/>
+              </a:ext>
+            </a:extLst>
+          </p:cNvPr>
+          <p:cNvSpPr/>
+          <p:nvPr/>
+        </p:nvSpPr>
+        <p:spPr>
+          <a:xfrm rot="1800000">
+            <a:off x="1300415" y="1017278"/>
+            <a:ext cx="1219200" cy="609600"/>
+          </a:xfrm>
+          <a:prstGeom prst="rect">
+            <a:avLst/>
+          </a:prstGeom>
+          <a:solidFill>
+            <a:srgbClr val="3F95D9"/>
+          </a:solidFill>
+          <a:ln>
+            <a:solidFill>
+              <a:srgbClr val="004B7A"/>
+            </a:solidFill>
+          </a:ln>
+        </p:spPr>
+        <p:style>
+          <a:lnRef idx="2">
+            <a:schemeClr val="accent1">
+              <a:shade val="15000"/>
+            </a:schemeClr>
+          </a:lnRef>
+          <a:fillRef idx="1">
+            <a:schemeClr val="accent1"/>
+          </a:fillRef>
+          <a:effectRef idx="0">
+            <a:schemeClr val="accent1"/>
+          </a:effectRef>
+          <a:fontRef idx="minor">
+            <a:schemeClr val="lt1"/>
+          </a:fontRef>
+        </p:style>
+        <p:txBody>
+          <a:bodyPr rtlCol="0" anchor="ctr"/>
+          <a:lstStyle/>
+          <a:p>
+            <a:pPr algn="ctr"/>
+            <a:r>
+              <a:rPr lang="en-US" sz="1400"/>
+              <a:t>A</a:t>
+            </a:r>
+          </a:p>
+        </p:txBody>
+      </p:sp>
+      <p:sp>
+        <p:nvSpPr>
+          <p:cNvPr id="5" name="rot30-ungrouped child green oval">
+            <a:extLst>
+              <a:ext uri="{FF2B5EF4-FFF2-40B4-BE49-F238E27FC236}">
+                <a16:creationId xmlns:a16="http://schemas.microsoft.com/office/drawing/2014/main" id="{E79BE68F-B5BA-730A-F387-77E645AFCB4F}"/>
+              </a:ext>
+            </a:extLst>
+          </p:cNvPr>
+          <p:cNvSpPr/>
+          <p:nvPr/>
+        </p:nvSpPr>
+        <p:spPr>
+          <a:xfrm rot="1800000">
+            <a:off x="2445507" y="2106165"/>
+            <a:ext cx="736600" cy="736600"/>
+          </a:xfrm>
+          <a:prstGeom prst="ellipse">
+            <a:avLst/>
+          </a:prstGeom>
+          <a:solidFill>
+            <a:srgbClr val="32A865"/>
+          </a:solidFill>
+          <a:ln>
+            <a:solidFill>
+              <a:srgbClr val="225522"/>
+            </a:solidFill>
+          </a:ln>
+        </p:spPr>
+        <p:style>
+          <a:lnRef idx="2">
+            <a:schemeClr val="accent1">
+              <a:shade val="15000"/>
+            </a:schemeClr>
+          </a:lnRef>
+          <a:fillRef idx="1">
+            <a:schemeClr val="accent1"/>
+          </a:fillRef>
+          <a:effectRef idx="0">
+            <a:schemeClr val="accent1"/>
+          </a:effectRef>
+          <a:fontRef idx="minor">
+            <a:schemeClr val="lt1"/>
+          </a:fontRef>
+        </p:style>
+        <p:txBody>
+          <a:bodyPr rtlCol="0" anchor="ctr"/>
+          <a:lstStyle/>
+          <a:p>
+            <a:pPr algn="ctr"/>
+            <a:r>
+              <a:rPr lang="en-US" sz="1400"/>
+              <a:t>B</a:t>
+            </a:r>
+          </a:p>
+        </p:txBody>
+      </p:sp>
+      <p:sp>
+        <p:nvSpPr>
+          <p:cNvPr id="6" name="rot30-ungrouped child purple triangle">
+            <a:extLst>
+              <a:ext uri="{FF2B5EF4-FFF2-40B4-BE49-F238E27FC236}">
+                <a16:creationId xmlns:a16="http://schemas.microsoft.com/office/drawing/2014/main" id="{76B87BD2-A84C-382B-82E8-926AB585440A}"/>
+              </a:ext>
+            </a:extLst>
+          </p:cNvPr>
+          <p:cNvSpPr/>
+          <p:nvPr/>
+        </p:nvSpPr>
+        <p:spPr>
+          <a:xfrm rot="1800000">
+            <a:off x="1159103" y="2283932"/>
+            <a:ext cx="1168400" cy="787400"/>
+          </a:xfrm>
+          <a:prstGeom prst="triangle">
+            <a:avLst/>
+          </a:prstGeom>
+          <a:solidFill>
+            <a:srgbClr val="C25FB1"/>
+          </a:solidFill>
+          <a:ln>
+            <a:solidFill>
+              <a:srgbClr val="69215E"/>
+            </a:solidFill>
+          </a:ln>
+        </p:spPr>
+        <p:style>
+          <a:lnRef idx="2">
+            <a:schemeClr val="accent1">
+              <a:shade val="15000"/>
+            </a:schemeClr>
+          </a:lnRef>
+          <a:fillRef idx="1">
+            <a:schemeClr val="accent1"/>
+          </a:fillRef>
+          <a:effectRef idx="0">
+            <a:schemeClr val="accent1"/>
+          </a:effectRef>
+          <a:fontRef idx="minor">
+            <a:schemeClr val="lt1"/>
+          </a:fontRef>
+        </p:style>
+        <p:txBody>
+          <a:bodyPr rtlCol="0" anchor="ctr"/>
+          <a:lstStyle/>
+          <a:p>
+            <a:pPr algn="ctr"/>
+            <a:r>
+              <a:rPr lang="en-US" sz="1400"/>
+              <a:t>C</a:t>
+            </a:r>
+          </a:p>
+        </p:txBody>
+      </p:sp>
+      <p:sp>
+        <p:nvSpPr>
+          <p:cNvPr id="8" name="TextBox 7">
+            <a:extLst>
+              <a:ext uri="{FF2B5EF4-FFF2-40B4-BE49-F238E27FC236}">
+                <a16:creationId xmlns:a16="http://schemas.microsoft.com/office/drawing/2014/main" id="{D2311652-763A-1754-2EEA-5812C3FD6550}"/>
+              </a:ext>
+            </a:extLst>
+          </p:cNvPr>
+          <p:cNvSpPr txBox="1"/>
+          <p:nvPr/>
+        </p:nvSpPr>
+        <p:spPr>
+          <a:xfrm>
+            <a:off x="4635500" y="850900"/>
+            <a:ext cx="2667000" cy="246221"/>
+          </a:xfrm>
+          <a:prstGeom prst="rect">
+            <a:avLst/>
+          </a:prstGeom>
+          <a:noFill/>
+        </p:spPr>
+        <p:txBody>
+          <a:bodyPr vert="horz" rtlCol="0">
+            <a:spAutoFit/>
+          </a:bodyPr>
+          <a:lstStyle/>
+          <a:p>
+            <a:r>
+              <a:rPr lang="en-US" sz="1000">
+                <a:latin typeface="Aptos" panose="020B0004020202020204" pitchFamily="34" charset="0"/>
+              </a:rPr>
+              <a:t>flipH</a:t>
+            </a:r>
+          </a:p>
+        </p:txBody>
+      </p:sp>
+      <p:sp>
+        <p:nvSpPr>
+          <p:cNvPr id="9" name="flipH-ungrouped child blue rect">
+            <a:extLst>
+              <a:ext uri="{FF2B5EF4-FFF2-40B4-BE49-F238E27FC236}">
+                <a16:creationId xmlns:a16="http://schemas.microsoft.com/office/drawing/2014/main" id="{ACEDDEF8-39ED-A7D9-79C2-D5492BEFFDCF}"/>
+              </a:ext>
+            </a:extLst>
+          </p:cNvPr>
+          <p:cNvSpPr/>
+          <p:nvPr/>
+        </p:nvSpPr>
+        <p:spPr>
+          <a:xfrm flipH="1">
+            <a:off x="5753100" y="1206500"/>
+            <a:ext cx="1219200" cy="609600"/>
+          </a:xfrm>
+          <a:prstGeom prst="rect">
+            <a:avLst/>
+          </a:prstGeom>
+          <a:solidFill>
+            <a:srgbClr val="3F95D9"/>
+          </a:solidFill>
+          <a:ln>
+            <a:solidFill>
+              <a:srgbClr val="004B7A"/>
+            </a:solidFill>
+          </a:ln>
+        </p:spPr>
+        <p:style>
+          <a:lnRef idx="2">
+            <a:schemeClr val="accent1">
+              <a:shade val="15000"/>
+            </a:schemeClr>
+          </a:lnRef>
+          <a:fillRef idx="1">
+            <a:schemeClr val="accent1"/>
+          </a:fillRef>
+          <a:effectRef idx="0">
+            <a:schemeClr val="accent1"/>
+          </a:effectRef>
+          <a:fontRef idx="minor">
+            <a:schemeClr val="lt1"/>
+          </a:fontRef>
+        </p:style>
+        <p:txBody>
+          <a:bodyPr rtlCol="0" anchor="ctr"/>
+          <a:lstStyle/>
+          <a:p>
+            <a:pPr algn="ctr"/>
+            <a:r>
+              <a:rPr lang="en-US" sz="1400"/>
+              <a:t>A</a:t>
+            </a:r>
+          </a:p>
+        </p:txBody>
+      </p:sp>
+      <p:sp>
+        <p:nvSpPr>
+          <p:cNvPr id="10" name="flipH-ungrouped child green oval">
+            <a:extLst>
+              <a:ext uri="{FF2B5EF4-FFF2-40B4-BE49-F238E27FC236}">
+                <a16:creationId xmlns:a16="http://schemas.microsoft.com/office/drawing/2014/main" id="{22AB09C7-B29B-7312-BCFC-863E141B1E5E}"/>
+              </a:ext>
+            </a:extLst>
+          </p:cNvPr>
+          <p:cNvSpPr/>
+          <p:nvPr/>
+        </p:nvSpPr>
+        <p:spPr>
+          <a:xfrm flipH="1">
+            <a:off x="4635500" y="1689100"/>
+            <a:ext cx="736600" cy="736600"/>
+          </a:xfrm>
+          <a:prstGeom prst="ellipse">
+            <a:avLst/>
+          </a:prstGeom>
+          <a:solidFill>
+            <a:srgbClr val="32A865"/>
+          </a:solidFill>
+          <a:ln>
+            <a:solidFill>
+              <a:srgbClr val="225522"/>
+            </a:solidFill>
+          </a:ln>
+        </p:spPr>
+        <p:style>
+          <a:lnRef idx="2">
+            <a:schemeClr val="accent1">
+              <a:shade val="15000"/>
+            </a:schemeClr>
+          </a:lnRef>
+          <a:fillRef idx="1">
+            <a:schemeClr val="accent1"/>
+          </a:fillRef>
+          <a:effectRef idx="0">
+            <a:schemeClr val="accent1"/>
+          </a:effectRef>
+          <a:fontRef idx="minor">
+            <a:schemeClr val="lt1"/>
+          </a:fontRef>
+        </p:style>
+        <p:txBody>
+          <a:bodyPr rtlCol="0" anchor="ctr"/>
+          <a:lstStyle/>
+          <a:p>
+            <a:pPr algn="ctr"/>
+            <a:r>
+              <a:rPr lang="en-US" sz="1400"/>
+              <a:t>B</a:t>
+            </a:r>
+          </a:p>
+        </p:txBody>
+      </p:sp>
+      <p:sp>
+        <p:nvSpPr>
+          <p:cNvPr id="11" name="flipH-ungrouped child purple triangle">
+            <a:extLst>
+              <a:ext uri="{FF2B5EF4-FFF2-40B4-BE49-F238E27FC236}">
+                <a16:creationId xmlns:a16="http://schemas.microsoft.com/office/drawing/2014/main" id="{E67ACAE3-F74C-B9AD-2372-F58E589AEB55}"/>
+              </a:ext>
+            </a:extLst>
+          </p:cNvPr>
+          <p:cNvSpPr/>
+          <p:nvPr/>
+        </p:nvSpPr>
+        <p:spPr>
+          <a:xfrm flipH="1">
+            <a:off x="5245100" y="2374900"/>
+            <a:ext cx="1168400" cy="787400"/>
+          </a:xfrm>
+          <a:prstGeom prst="triangle">
+            <a:avLst/>
+          </a:prstGeom>
+          <a:solidFill>
+            <a:srgbClr val="C25FB1"/>
+          </a:solidFill>
+          <a:ln>
+            <a:solidFill>
+              <a:srgbClr val="69215E"/>
+            </a:solidFill>
+          </a:ln>
+        </p:spPr>
+        <p:style>
+          <a:lnRef idx="2">
+            <a:schemeClr val="accent1">
+              <a:shade val="15000"/>
+            </a:schemeClr>
+          </a:lnRef>
+          <a:fillRef idx="1">
+            <a:schemeClr val="accent1"/>
+          </a:fillRef>
+          <a:effectRef idx="0">
+            <a:schemeClr val="accent1"/>
+          </a:effectRef>
+          <a:fontRef idx="minor">
+            <a:schemeClr val="lt1"/>
+          </a:fontRef>
+        </p:style>
+        <p:txBody>
+          <a:bodyPr rtlCol="0" anchor="ctr"/>
+          <a:lstStyle/>
+          <a:p>
+            <a:pPr algn="ctr"/>
+            <a:r>
+              <a:rPr lang="en-US" sz="1400"/>
+              <a:t>C</a:t>
+            </a:r>
+          </a:p>
+        </p:txBody>
+      </p:sp>
+      <p:sp>
+        <p:nvSpPr>
+          <p:cNvPr id="13" name="TextBox 12">
+            <a:extLst>
+              <a:ext uri="{FF2B5EF4-FFF2-40B4-BE49-F238E27FC236}">
+                <a16:creationId xmlns:a16="http://schemas.microsoft.com/office/drawing/2014/main" id="{0DBDF40C-2CC2-7F90-6D09-BD5A33C85E56}"/>
+              </a:ext>
+            </a:extLst>
+          </p:cNvPr>
+          <p:cNvSpPr txBox="1"/>
+          <p:nvPr/>
+        </p:nvSpPr>
+        <p:spPr>
+          <a:xfrm>
+            <a:off x="8382000" y="850900"/>
+            <a:ext cx="2667000" cy="246221"/>
+          </a:xfrm>
+          <a:prstGeom prst="rect">
+            <a:avLst/>
+          </a:prstGeom>
+          <a:noFill/>
+        </p:spPr>
+        <p:txBody>
+          <a:bodyPr vert="horz" rtlCol="0">
+            <a:spAutoFit/>
+          </a:bodyPr>
+          <a:lstStyle/>
+          <a:p>
+            <a:r>
+              <a:rPr lang="en-US" sz="1000">
+                <a:latin typeface="Aptos" panose="020B0004020202020204" pitchFamily="34" charset="0"/>
+              </a:rPr>
+              <a:t>flipV</a:t>
+            </a:r>
+          </a:p>
+        </p:txBody>
+      </p:sp>
+      <p:sp>
+        <p:nvSpPr>
+          <p:cNvPr id="14" name="flipV-ungrouped child blue rect">
+            <a:extLst>
+              <a:ext uri="{FF2B5EF4-FFF2-40B4-BE49-F238E27FC236}">
+                <a16:creationId xmlns:a16="http://schemas.microsoft.com/office/drawing/2014/main" id="{97411D60-6256-9DBC-A401-C54153057FDB}"/>
+              </a:ext>
+            </a:extLst>
+          </p:cNvPr>
+          <p:cNvSpPr/>
+          <p:nvPr/>
+        </p:nvSpPr>
+        <p:spPr>
+          <a:xfrm flipV="1">
+            <a:off x="8382000" y="2552700"/>
+            <a:ext cx="1219200" cy="609600"/>
+          </a:xfrm>
+          <a:prstGeom prst="rect">
+            <a:avLst/>
+          </a:prstGeom>
+          <a:solidFill>
+            <a:srgbClr val="3F95D9"/>
+          </a:solidFill>
+          <a:ln>
+            <a:solidFill>
+              <a:srgbClr val="004B7A"/>
+            </a:solidFill>
+          </a:ln>
+        </p:spPr>
+        <p:style>
+          <a:lnRef idx="2">
+            <a:schemeClr val="accent1">
+              <a:shade val="15000"/>
+            </a:schemeClr>
+          </a:lnRef>
+          <a:fillRef idx="1">
+            <a:schemeClr val="accent1"/>
+          </a:fillRef>
+          <a:effectRef idx="0">
+            <a:schemeClr val="accent1"/>
+          </a:effectRef>
+          <a:fontRef idx="minor">
+            <a:schemeClr val="lt1"/>
+          </a:fontRef>
+        </p:style>
+        <p:txBody>
+          <a:bodyPr rtlCol="0" anchor="ctr"/>
+          <a:lstStyle/>
+          <a:p>
+            <a:pPr algn="ctr"/>
+            <a:r>
+              <a:rPr lang="en-US" sz="1400"/>
+              <a:t>A</a:t>
+            </a:r>
+          </a:p>
+        </p:txBody>
+      </p:sp>
+      <p:sp>
+        <p:nvSpPr>
+          <p:cNvPr id="15" name="flipV-ungrouped child green oval">
+            <a:extLst>
+              <a:ext uri="{FF2B5EF4-FFF2-40B4-BE49-F238E27FC236}">
+                <a16:creationId xmlns:a16="http://schemas.microsoft.com/office/drawing/2014/main" id="{7FA854AB-946A-137D-6E09-BAF668F9DB6D}"/>
+              </a:ext>
+            </a:extLst>
+          </p:cNvPr>
+          <p:cNvSpPr/>
+          <p:nvPr/>
+        </p:nvSpPr>
+        <p:spPr>
+          <a:xfrm flipV="1">
+            <a:off x="9982200" y="1943100"/>
+            <a:ext cx="736600" cy="736600"/>
+          </a:xfrm>
+          <a:prstGeom prst="ellipse">
+            <a:avLst/>
+          </a:prstGeom>
+          <a:solidFill>
+            <a:srgbClr val="32A865"/>
+          </a:solidFill>
+          <a:ln>
+            <a:solidFill>
+              <a:srgbClr val="225522"/>
+            </a:solidFill>
+          </a:ln>
+        </p:spPr>
+        <p:style>
+          <a:lnRef idx="2">
+            <a:schemeClr val="accent1">
+              <a:shade val="15000"/>
+            </a:schemeClr>
+          </a:lnRef>
+          <a:fillRef idx="1">
+            <a:schemeClr val="accent1"/>
+          </a:fillRef>
+          <a:effectRef idx="0">
+            <a:schemeClr val="accent1"/>
+          </a:effectRef>
+          <a:fontRef idx="minor">
+            <a:schemeClr val="lt1"/>
+          </a:fontRef>
+        </p:style>
+        <p:txBody>
+          <a:bodyPr rtlCol="0" anchor="ctr"/>
+          <a:lstStyle/>
+          <a:p>
+            <a:pPr algn="ctr"/>
+            <a:r>
+              <a:rPr lang="en-US" sz="1400"/>
+              <a:t>B</a:t>
+            </a:r>
+          </a:p>
+        </p:txBody>
+      </p:sp>
+      <p:sp>
+        <p:nvSpPr>
+          <p:cNvPr id="16" name="flipV-ungrouped child purple triangle">
+            <a:extLst>
+              <a:ext uri="{FF2B5EF4-FFF2-40B4-BE49-F238E27FC236}">
+                <a16:creationId xmlns:a16="http://schemas.microsoft.com/office/drawing/2014/main" id="{5E25060E-D50D-8F9A-DF57-393ACA1C57C9}"/>
+              </a:ext>
+            </a:extLst>
+          </p:cNvPr>
+          <p:cNvSpPr/>
+          <p:nvPr/>
+        </p:nvSpPr>
+        <p:spPr>
+          <a:xfrm flipV="1">
+            <a:off x="8940800" y="1206500"/>
+            <a:ext cx="1168400" cy="787400"/>
+          </a:xfrm>
+          <a:prstGeom prst="triangle">
+            <a:avLst/>
+          </a:prstGeom>
+          <a:solidFill>
+            <a:srgbClr val="C25FB1"/>
+          </a:solidFill>
+          <a:ln>
+            <a:solidFill>
+              <a:srgbClr val="69215E"/>
+            </a:solidFill>
+          </a:ln>
+        </p:spPr>
+        <p:style>
+          <a:lnRef idx="2">
+            <a:schemeClr val="accent1">
+              <a:shade val="15000"/>
+            </a:schemeClr>
+          </a:lnRef>
+          <a:fillRef idx="1">
+            <a:schemeClr val="accent1"/>
+          </a:fillRef>
+          <a:effectRef idx="0">
+            <a:schemeClr val="accent1"/>
+          </a:effectRef>
+          <a:fontRef idx="minor">
+            <a:schemeClr val="lt1"/>
+          </a:fontRef>
+        </p:style>
+        <p:txBody>
+          <a:bodyPr rtlCol="0" anchor="ctr"/>
+          <a:lstStyle/>
+          <a:p>
+            <a:pPr algn="ctr"/>
+            <a:r>
+              <a:rPr lang="en-US" sz="1400"/>
+              <a:t>C</a:t>
+            </a:r>
+          </a:p>
+        </p:txBody>
+      </p:sp>
+      <p:sp>
+        <p:nvSpPr>
+          <p:cNvPr id="18" name="TextBox 17">
+            <a:extLst>
+              <a:ext uri="{FF2B5EF4-FFF2-40B4-BE49-F238E27FC236}">
+                <a16:creationId xmlns:a16="http://schemas.microsoft.com/office/drawing/2014/main" id="{E00AC11B-92EF-CDCF-A447-560552FBA89D}"/>
+              </a:ext>
+            </a:extLst>
+          </p:cNvPr>
+          <p:cNvSpPr txBox="1"/>
+          <p:nvPr/>
+        </p:nvSpPr>
+        <p:spPr>
+          <a:xfrm>
+            <a:off x="4445000" y="3898900"/>
+            <a:ext cx="2667000" cy="246221"/>
+          </a:xfrm>
+          <a:prstGeom prst="rect">
+            <a:avLst/>
+          </a:prstGeom>
+          <a:noFill/>
+        </p:spPr>
+        <p:txBody>
+          <a:bodyPr vert="horz" rtlCol="0">
+            <a:spAutoFit/>
+          </a:bodyPr>
+          <a:lstStyle/>
+          <a:p>
+            <a:r>
+              <a:rPr lang="en-US" sz="1000">
+                <a:latin typeface="Aptos" panose="020B0004020202020204" pitchFamily="34" charset="0"/>
+              </a:rPr>
+              <a:t>rot330-flipHV</a:t>
+            </a:r>
+          </a:p>
+        </p:txBody>
+      </p:sp>
+      <p:sp>
+        <p:nvSpPr>
+          <p:cNvPr id="19" name="rot330-flipHV-ungrouped child blue rect">
+            <a:extLst>
+              <a:ext uri="{FF2B5EF4-FFF2-40B4-BE49-F238E27FC236}">
+                <a16:creationId xmlns:a16="http://schemas.microsoft.com/office/drawing/2014/main" id="{9BB0E20F-8E09-A14A-3C87-94382C0102D0}"/>
+              </a:ext>
+            </a:extLst>
+          </p:cNvPr>
+          <p:cNvSpPr/>
+          <p:nvPr/>
+        </p:nvSpPr>
+        <p:spPr>
+          <a:xfrm rot="19800000" flipH="1" flipV="1">
+            <a:off x="5824285" y="5231122"/>
+            <a:ext cx="1219200" cy="609600"/>
+          </a:xfrm>
+          <a:prstGeom prst="rect">
+            <a:avLst/>
+          </a:prstGeom>
+          <a:solidFill>
+            <a:srgbClr val="3F95D9"/>
+          </a:solidFill>
+          <a:ln>
+            <a:solidFill>
+              <a:srgbClr val="004B7A"/>
+            </a:solidFill>
+          </a:ln>
+        </p:spPr>
+        <p:style>
+          <a:lnRef idx="2">
+            <a:schemeClr val="accent1">
+              <a:shade val="15000"/>
+            </a:schemeClr>
+          </a:lnRef>
+          <a:fillRef idx="1">
+            <a:schemeClr val="accent1"/>
+          </a:fillRef>
+          <a:effectRef idx="0">
+            <a:schemeClr val="accent1"/>
+          </a:effectRef>
+          <a:fontRef idx="minor">
+            <a:schemeClr val="lt1"/>
+          </a:fontRef>
+        </p:style>
+        <p:txBody>
+          <a:bodyPr rtlCol="0" anchor="ctr"/>
+          <a:lstStyle/>
+          <a:p>
+            <a:pPr algn="ctr"/>
+            <a:r>
+              <a:rPr lang="en-US" sz="1400"/>
+              <a:t>A</a:t>
+            </a:r>
+          </a:p>
+        </p:txBody>
+      </p:sp>
+      <p:sp>
+        <p:nvSpPr>
+          <p:cNvPr id="20" name="rot330-flipHV-ungrouped child green oval">
+            <a:extLst>
+              <a:ext uri="{FF2B5EF4-FFF2-40B4-BE49-F238E27FC236}">
+                <a16:creationId xmlns:a16="http://schemas.microsoft.com/office/drawing/2014/main" id="{A72FCF45-C0B9-2C0A-3ACC-8C7AB6C790AB}"/>
+              </a:ext>
+            </a:extLst>
+          </p:cNvPr>
+          <p:cNvSpPr/>
+          <p:nvPr/>
+        </p:nvSpPr>
+        <p:spPr>
+          <a:xfrm rot="19800000" flipH="1" flipV="1">
+            <a:off x="4615693" y="5374135"/>
+            <a:ext cx="736600" cy="736600"/>
+          </a:xfrm>
+          <a:prstGeom prst="ellipse">
+            <a:avLst/>
+          </a:prstGeom>
+          <a:solidFill>
+            <a:srgbClr val="32A865"/>
+          </a:solidFill>
+          <a:ln>
+            <a:solidFill>
+              <a:srgbClr val="225522"/>
+            </a:solidFill>
+          </a:ln>
+        </p:spPr>
+        <p:style>
+          <a:lnRef idx="2">
+            <a:schemeClr val="accent1">
+              <a:shade val="15000"/>
+            </a:schemeClr>
+          </a:lnRef>
+          <a:fillRef idx="1">
+            <a:schemeClr val="accent1"/>
+          </a:fillRef>
+          <a:effectRef idx="0">
+            <a:schemeClr val="accent1"/>
+          </a:effectRef>
+          <a:fontRef idx="minor">
+            <a:schemeClr val="lt1"/>
+          </a:fontRef>
+        </p:style>
+        <p:txBody>
+          <a:bodyPr rtlCol="0" anchor="ctr"/>
+          <a:lstStyle/>
+          <a:p>
+            <a:pPr algn="ctr"/>
+            <a:r>
+              <a:rPr lang="en-US" sz="1400"/>
+              <a:t>B</a:t>
+            </a:r>
+          </a:p>
+        </p:txBody>
+      </p:sp>
+      <p:sp>
+        <p:nvSpPr>
+          <p:cNvPr id="21" name="rot330-flipHV-ungrouped child purple triangle">
+            <a:extLst>
+              <a:ext uri="{FF2B5EF4-FFF2-40B4-BE49-F238E27FC236}">
+                <a16:creationId xmlns:a16="http://schemas.microsoft.com/office/drawing/2014/main" id="{5B171739-31EC-00B3-18FF-8C6AF2B3BC36}"/>
+              </a:ext>
+            </a:extLst>
+          </p:cNvPr>
+          <p:cNvSpPr/>
+          <p:nvPr/>
+        </p:nvSpPr>
+        <p:spPr>
+          <a:xfrm rot="19800000" flipH="1" flipV="1">
+            <a:off x="4759097" y="4320068"/>
+            <a:ext cx="1168400" cy="787400"/>
+          </a:xfrm>
+          <a:prstGeom prst="triangle">
+            <a:avLst/>
+          </a:prstGeom>
+          <a:solidFill>
+            <a:srgbClr val="C25FB1"/>
+          </a:solidFill>
+          <a:ln>
+            <a:solidFill>
+              <a:srgbClr val="69215E"/>
+            </a:solidFill>
+          </a:ln>
+        </p:spPr>
+        <p:style>
+          <a:lnRef idx="2">
+            <a:schemeClr val="accent1">
+              <a:shade val="15000"/>
+            </a:schemeClr>
+          </a:lnRef>
+          <a:fillRef idx="1">
+            <a:schemeClr val="accent1"/>
+          </a:fillRef>
+          <a:effectRef idx="0">
+            <a:schemeClr val="accent1"/>
+          </a:effectRef>
+          <a:fontRef idx="minor">
+            <a:schemeClr val="lt1"/>
+          </a:fontRef>
+        </p:style>
+        <p:txBody>
+          <a:bodyPr rtlCol="0" anchor="ctr"/>
+          <a:lstStyle/>
+          <a:p>
+            <a:pPr algn="ctr"/>
+            <a:r>
+              <a:rPr lang="en-US" sz="1400"/>
+              <a:t>C</a:t>
+            </a:r>
+          </a:p>
+        </p:txBody>
+      </p:sp>
+      <p:sp>
+        <p:nvSpPr>
+          <p:cNvPr id="23" name="TextBox 22">
+            <a:extLst>
+              <a:ext uri="{FF2B5EF4-FFF2-40B4-BE49-F238E27FC236}">
+                <a16:creationId xmlns:a16="http://schemas.microsoft.com/office/drawing/2014/main" id="{6D0936B8-8BA1-5BC4-E1A9-4FB54E5A9B3D}"/>
+              </a:ext>
+            </a:extLst>
+          </p:cNvPr>
+          <p:cNvSpPr txBox="1"/>
+          <p:nvPr/>
+        </p:nvSpPr>
+        <p:spPr>
+          <a:xfrm>
+            <a:off x="304800" y="6350000"/>
+            <a:ext cx="11176000" cy="230832"/>
+          </a:xfrm>
+          <a:prstGeom prst="rect">
+            <a:avLst/>
+          </a:prstGeom>
+          <a:noFill/>
+        </p:spPr>
+        <p:txBody>
+          <a:bodyPr vert="horz" rtlCol="0">
+            <a:spAutoFit/>
+          </a:bodyPr>
+          <a:lstStyle/>
+          <a:p>
+            <a:r>
+              <a:rPr lang="en-US" sz="900">
+                <a:latin typeface="Aptos" panose="020B0004020202020204" pitchFamily="34" charset="0"/>
+              </a:rPr>
+              <a:t>Fixture intent: child absolute frames must account for enclosing group rot/flipH/flipV, not only off/ext scaling.</a:t>
+            </a:r>
+          </a:p>
+        </p:txBody>
+      </p:sp>
+    </p:spTree>
+    <p:extLst>
+      <p:ext uri="{BB962C8B-B14F-4D97-AF65-F5344CB8AC3E}">
+        <p14:creationId xmlns:p14="http://schemas.microsoft.com/office/powerpoint/2010/main" val="123277934"/>
       </p:ext>
     </p:extLst>
   </p:cSld>

</xml_diff>

<commit_message>
fix(read): compose group rotations in absolute frames
</commit_message>
<xml_diff>
--- a/test/read/fixtures/group-transform.pptx
+++ b/test/read/fixtures/group-transform.pptx
@@ -105,11 +105,6 @@
       </a:defRPr>
     </a:lvl9pPr>
   </p:defaultTextStyle>
-  <p:extLst>
-    <p:ext uri="{EFAFB233-063F-42B5-8137-9DF3F51BA10A}">
-      <p15:sldGuideLst xmlns:p15="http://schemas.microsoft.com/office/powerpoint/2012/main"/>
-    </p:ext>
-  </p:extLst>
 </p:presentation>
 </file>
 
@@ -135,7 +130,7 @@
           <p:cNvPr id="2" name="Title 1">
             <a:extLst>
               <a:ext uri="{FF2B5EF4-FFF2-40B4-BE49-F238E27FC236}">
-                <a16:creationId xmlns:a16="http://schemas.microsoft.com/office/drawing/2014/main" id="{36312F11-EB26-CBE7-EAE0-CB05EA08852B}"/>
+                <a16:creationId xmlns:a16="http://schemas.microsoft.com/office/drawing/2014/main" id="{5D67CCB2-A67D-296A-7A8A-273DA904B1B3}"/>
               </a:ext>
             </a:extLst>
           </p:cNvPr>
@@ -172,7 +167,7 @@
           <p:cNvPr id="3" name="Subtitle 2">
             <a:extLst>
               <a:ext uri="{FF2B5EF4-FFF2-40B4-BE49-F238E27FC236}">
-                <a16:creationId xmlns:a16="http://schemas.microsoft.com/office/drawing/2014/main" id="{F4E496CF-A0CC-4D18-3FB0-2073CF8DD832}"/>
+                <a16:creationId xmlns:a16="http://schemas.microsoft.com/office/drawing/2014/main" id="{4FC5D7E7-2045-96AD-1A43-43A5E4B47C41}"/>
               </a:ext>
             </a:extLst>
           </p:cNvPr>
@@ -242,7 +237,7 @@
           <p:cNvPr id="4" name="Date Placeholder 3">
             <a:extLst>
               <a:ext uri="{FF2B5EF4-FFF2-40B4-BE49-F238E27FC236}">
-                <a16:creationId xmlns:a16="http://schemas.microsoft.com/office/drawing/2014/main" id="{2D748C5D-018C-71A4-AE5F-D0128294A124}"/>
+                <a16:creationId xmlns:a16="http://schemas.microsoft.com/office/drawing/2014/main" id="{89BEA847-575B-78D9-5EC6-0F608C15ADE0}"/>
               </a:ext>
             </a:extLst>
           </p:cNvPr>
@@ -258,7 +253,7 @@
           <a:bodyPr/>
           <a:lstStyle/>
           <a:p>
-            <a:fld id="{1B861488-9A07-47B0-8A65-547563D70F6D}" type="datetimeFigureOut">
+            <a:fld id="{3AE6D4E1-CC08-42F1-B88F-E048070B7A93}" type="datetimeFigureOut">
               <a:rPr lang="en-US" smtClean="0"/>
               <a:t>6/18/2026</a:t>
             </a:fld>
@@ -271,7 +266,7 @@
           <p:cNvPr id="5" name="Footer Placeholder 4">
             <a:extLst>
               <a:ext uri="{FF2B5EF4-FFF2-40B4-BE49-F238E27FC236}">
-                <a16:creationId xmlns:a16="http://schemas.microsoft.com/office/drawing/2014/main" id="{D3590EA9-425F-0BEE-64E9-DDE5A0ABFCE4}"/>
+                <a16:creationId xmlns:a16="http://schemas.microsoft.com/office/drawing/2014/main" id="{A8268BD3-F3D8-448C-80DA-C6CB91D06654}"/>
               </a:ext>
             </a:extLst>
           </p:cNvPr>
@@ -296,7 +291,7 @@
           <p:cNvPr id="6" name="Slide Number Placeholder 5">
             <a:extLst>
               <a:ext uri="{FF2B5EF4-FFF2-40B4-BE49-F238E27FC236}">
-                <a16:creationId xmlns:a16="http://schemas.microsoft.com/office/drawing/2014/main" id="{64BA4BF8-BF2B-B390-6886-319B21350B8A}"/>
+                <a16:creationId xmlns:a16="http://schemas.microsoft.com/office/drawing/2014/main" id="{5C40357F-2DFE-6DEF-B377-05EDAFE89936}"/>
               </a:ext>
             </a:extLst>
           </p:cNvPr>
@@ -312,7 +307,7 @@
           <a:bodyPr/>
           <a:lstStyle/>
           <a:p>
-            <a:fld id="{BD658C21-2D09-4E88-AF00-E69567C0170A}" type="slidenum">
+            <a:fld id="{9A219F65-89E2-4C01-9CB9-1B657DB643AD}" type="slidenum">
               <a:rPr lang="en-US" smtClean="0"/>
               <a:t>‹#›</a:t>
             </a:fld>
@@ -323,7 +318,7 @@
     </p:spTree>
     <p:extLst>
       <p:ext uri="{BB962C8B-B14F-4D97-AF65-F5344CB8AC3E}">
-        <p14:creationId xmlns:p14="http://schemas.microsoft.com/office/powerpoint/2010/main" val="2496968216"/>
+        <p14:creationId xmlns:p14="http://schemas.microsoft.com/office/powerpoint/2010/main" val="885732708"/>
       </p:ext>
     </p:extLst>
   </p:cSld>
@@ -355,7 +350,7 @@
           <p:cNvPr id="2" name="Title 1">
             <a:extLst>
               <a:ext uri="{FF2B5EF4-FFF2-40B4-BE49-F238E27FC236}">
-                <a16:creationId xmlns:a16="http://schemas.microsoft.com/office/drawing/2014/main" id="{DF9D44B6-97D5-E1AF-B85C-FE4A2DF9AE30}"/>
+                <a16:creationId xmlns:a16="http://schemas.microsoft.com/office/drawing/2014/main" id="{49EFABEA-B96B-4899-05D4-23160B86EF2B}"/>
               </a:ext>
             </a:extLst>
           </p:cNvPr>
@@ -383,7 +378,7 @@
           <p:cNvPr id="3" name="Vertical Text Placeholder 2">
             <a:extLst>
               <a:ext uri="{FF2B5EF4-FFF2-40B4-BE49-F238E27FC236}">
-                <a16:creationId xmlns:a16="http://schemas.microsoft.com/office/drawing/2014/main" id="{ECF3D5D7-A0C6-D179-D0B6-A6B50DDC3A7F}"/>
+                <a16:creationId xmlns:a16="http://schemas.microsoft.com/office/drawing/2014/main" id="{6DBF905E-B80B-DDB3-0173-05BB75365AE2}"/>
               </a:ext>
             </a:extLst>
           </p:cNvPr>
@@ -440,7 +435,7 @@
           <p:cNvPr id="4" name="Date Placeholder 3">
             <a:extLst>
               <a:ext uri="{FF2B5EF4-FFF2-40B4-BE49-F238E27FC236}">
-                <a16:creationId xmlns:a16="http://schemas.microsoft.com/office/drawing/2014/main" id="{1A6DEB54-BDD0-95FF-CB97-45F69C3AA8B3}"/>
+                <a16:creationId xmlns:a16="http://schemas.microsoft.com/office/drawing/2014/main" id="{B2075829-D276-B16D-CDDE-C32ED378D4CA}"/>
               </a:ext>
             </a:extLst>
           </p:cNvPr>
@@ -456,7 +451,7 @@
           <a:bodyPr/>
           <a:lstStyle/>
           <a:p>
-            <a:fld id="{1B861488-9A07-47B0-8A65-547563D70F6D}" type="datetimeFigureOut">
+            <a:fld id="{3AE6D4E1-CC08-42F1-B88F-E048070B7A93}" type="datetimeFigureOut">
               <a:rPr lang="en-US" smtClean="0"/>
               <a:t>6/18/2026</a:t>
             </a:fld>
@@ -469,7 +464,7 @@
           <p:cNvPr id="5" name="Footer Placeholder 4">
             <a:extLst>
               <a:ext uri="{FF2B5EF4-FFF2-40B4-BE49-F238E27FC236}">
-                <a16:creationId xmlns:a16="http://schemas.microsoft.com/office/drawing/2014/main" id="{4C09E490-2D11-2CC1-5832-517B7BDA08DA}"/>
+                <a16:creationId xmlns:a16="http://schemas.microsoft.com/office/drawing/2014/main" id="{6690C512-8AD5-4805-8319-B615ED86BB3B}"/>
               </a:ext>
             </a:extLst>
           </p:cNvPr>
@@ -494,7 +489,7 @@
           <p:cNvPr id="6" name="Slide Number Placeholder 5">
             <a:extLst>
               <a:ext uri="{FF2B5EF4-FFF2-40B4-BE49-F238E27FC236}">
-                <a16:creationId xmlns:a16="http://schemas.microsoft.com/office/drawing/2014/main" id="{1F2FA5BD-8FF6-B9A1-D7A0-59955FF7D7A6}"/>
+                <a16:creationId xmlns:a16="http://schemas.microsoft.com/office/drawing/2014/main" id="{C1BFEA34-9CB9-7CF8-C2DC-66348EEA8A1F}"/>
               </a:ext>
             </a:extLst>
           </p:cNvPr>
@@ -510,7 +505,7 @@
           <a:bodyPr/>
           <a:lstStyle/>
           <a:p>
-            <a:fld id="{BD658C21-2D09-4E88-AF00-E69567C0170A}" type="slidenum">
+            <a:fld id="{9A219F65-89E2-4C01-9CB9-1B657DB643AD}" type="slidenum">
               <a:rPr lang="en-US" smtClean="0"/>
               <a:t>‹#›</a:t>
             </a:fld>
@@ -521,7 +516,7 @@
     </p:spTree>
     <p:extLst>
       <p:ext uri="{BB962C8B-B14F-4D97-AF65-F5344CB8AC3E}">
-        <p14:creationId xmlns:p14="http://schemas.microsoft.com/office/powerpoint/2010/main" val="3136790339"/>
+        <p14:creationId xmlns:p14="http://schemas.microsoft.com/office/powerpoint/2010/main" val="1995180373"/>
       </p:ext>
     </p:extLst>
   </p:cSld>
@@ -553,7 +548,7 @@
           <p:cNvPr id="2" name="Vertical Title 1">
             <a:extLst>
               <a:ext uri="{FF2B5EF4-FFF2-40B4-BE49-F238E27FC236}">
-                <a16:creationId xmlns:a16="http://schemas.microsoft.com/office/drawing/2014/main" id="{7B920479-60FD-B198-EF65-65ED62BA459E}"/>
+                <a16:creationId xmlns:a16="http://schemas.microsoft.com/office/drawing/2014/main" id="{2D05120E-70E7-126D-D4E0-DED8D9DC91C5}"/>
               </a:ext>
             </a:extLst>
           </p:cNvPr>
@@ -586,7 +581,7 @@
           <p:cNvPr id="3" name="Vertical Text Placeholder 2">
             <a:extLst>
               <a:ext uri="{FF2B5EF4-FFF2-40B4-BE49-F238E27FC236}">
-                <a16:creationId xmlns:a16="http://schemas.microsoft.com/office/drawing/2014/main" id="{B7BC53AA-B677-FEA8-85A0-7DC229FE20E0}"/>
+                <a16:creationId xmlns:a16="http://schemas.microsoft.com/office/drawing/2014/main" id="{5AB8C021-AE9A-C77E-2201-53C41778763C}"/>
               </a:ext>
             </a:extLst>
           </p:cNvPr>
@@ -648,7 +643,7 @@
           <p:cNvPr id="4" name="Date Placeholder 3">
             <a:extLst>
               <a:ext uri="{FF2B5EF4-FFF2-40B4-BE49-F238E27FC236}">
-                <a16:creationId xmlns:a16="http://schemas.microsoft.com/office/drawing/2014/main" id="{9777D721-7483-B61B-A069-01E9632EED79}"/>
+                <a16:creationId xmlns:a16="http://schemas.microsoft.com/office/drawing/2014/main" id="{D0A4CEA5-5ABD-F731-F194-35818C70B4D6}"/>
               </a:ext>
             </a:extLst>
           </p:cNvPr>
@@ -664,7 +659,7 @@
           <a:bodyPr/>
           <a:lstStyle/>
           <a:p>
-            <a:fld id="{1B861488-9A07-47B0-8A65-547563D70F6D}" type="datetimeFigureOut">
+            <a:fld id="{3AE6D4E1-CC08-42F1-B88F-E048070B7A93}" type="datetimeFigureOut">
               <a:rPr lang="en-US" smtClean="0"/>
               <a:t>6/18/2026</a:t>
             </a:fld>
@@ -677,7 +672,7 @@
           <p:cNvPr id="5" name="Footer Placeholder 4">
             <a:extLst>
               <a:ext uri="{FF2B5EF4-FFF2-40B4-BE49-F238E27FC236}">
-                <a16:creationId xmlns:a16="http://schemas.microsoft.com/office/drawing/2014/main" id="{E32D8816-9625-A26D-F203-92371C6055A8}"/>
+                <a16:creationId xmlns:a16="http://schemas.microsoft.com/office/drawing/2014/main" id="{AA5F44DC-69F6-5239-19EB-031C01243496}"/>
               </a:ext>
             </a:extLst>
           </p:cNvPr>
@@ -702,7 +697,7 @@
           <p:cNvPr id="6" name="Slide Number Placeholder 5">
             <a:extLst>
               <a:ext uri="{FF2B5EF4-FFF2-40B4-BE49-F238E27FC236}">
-                <a16:creationId xmlns:a16="http://schemas.microsoft.com/office/drawing/2014/main" id="{AC319853-5608-55EA-C475-4EE5DF424FE0}"/>
+                <a16:creationId xmlns:a16="http://schemas.microsoft.com/office/drawing/2014/main" id="{A4DAFCAA-E562-AB83-8446-B2F7BBB7F19E}"/>
               </a:ext>
             </a:extLst>
           </p:cNvPr>
@@ -718,7 +713,7 @@
           <a:bodyPr/>
           <a:lstStyle/>
           <a:p>
-            <a:fld id="{BD658C21-2D09-4E88-AF00-E69567C0170A}" type="slidenum">
+            <a:fld id="{9A219F65-89E2-4C01-9CB9-1B657DB643AD}" type="slidenum">
               <a:rPr lang="en-US" smtClean="0"/>
               <a:t>‹#›</a:t>
             </a:fld>
@@ -729,7 +724,7 @@
     </p:spTree>
     <p:extLst>
       <p:ext uri="{BB962C8B-B14F-4D97-AF65-F5344CB8AC3E}">
-        <p14:creationId xmlns:p14="http://schemas.microsoft.com/office/powerpoint/2010/main" val="3421598004"/>
+        <p14:creationId xmlns:p14="http://schemas.microsoft.com/office/powerpoint/2010/main" val="1772945624"/>
       </p:ext>
     </p:extLst>
   </p:cSld>
@@ -761,7 +756,7 @@
           <p:cNvPr id="2" name="Title 1">
             <a:extLst>
               <a:ext uri="{FF2B5EF4-FFF2-40B4-BE49-F238E27FC236}">
-                <a16:creationId xmlns:a16="http://schemas.microsoft.com/office/drawing/2014/main" id="{96601CDA-2E54-4112-B042-233FDB71EFA7}"/>
+                <a16:creationId xmlns:a16="http://schemas.microsoft.com/office/drawing/2014/main" id="{263E6671-D2B0-F8D1-2902-BBD606BC96C6}"/>
               </a:ext>
             </a:extLst>
           </p:cNvPr>
@@ -789,7 +784,7 @@
           <p:cNvPr id="3" name="Content Placeholder 2">
             <a:extLst>
               <a:ext uri="{FF2B5EF4-FFF2-40B4-BE49-F238E27FC236}">
-                <a16:creationId xmlns:a16="http://schemas.microsoft.com/office/drawing/2014/main" id="{B3E139EB-61B0-DB08-822C-55766007FCE2}"/>
+                <a16:creationId xmlns:a16="http://schemas.microsoft.com/office/drawing/2014/main" id="{55C3CDFD-FC9F-76BF-C001-D64D2B54EC21}"/>
               </a:ext>
             </a:extLst>
           </p:cNvPr>
@@ -846,7 +841,7 @@
           <p:cNvPr id="4" name="Date Placeholder 3">
             <a:extLst>
               <a:ext uri="{FF2B5EF4-FFF2-40B4-BE49-F238E27FC236}">
-                <a16:creationId xmlns:a16="http://schemas.microsoft.com/office/drawing/2014/main" id="{A5304172-FD6A-D18D-4A01-72743AB3A9C2}"/>
+                <a16:creationId xmlns:a16="http://schemas.microsoft.com/office/drawing/2014/main" id="{701692CC-609F-2E52-0D7D-5B1A09EF7756}"/>
               </a:ext>
             </a:extLst>
           </p:cNvPr>
@@ -862,7 +857,7 @@
           <a:bodyPr/>
           <a:lstStyle/>
           <a:p>
-            <a:fld id="{1B861488-9A07-47B0-8A65-547563D70F6D}" type="datetimeFigureOut">
+            <a:fld id="{3AE6D4E1-CC08-42F1-B88F-E048070B7A93}" type="datetimeFigureOut">
               <a:rPr lang="en-US" smtClean="0"/>
               <a:t>6/18/2026</a:t>
             </a:fld>
@@ -875,7 +870,7 @@
           <p:cNvPr id="5" name="Footer Placeholder 4">
             <a:extLst>
               <a:ext uri="{FF2B5EF4-FFF2-40B4-BE49-F238E27FC236}">
-                <a16:creationId xmlns:a16="http://schemas.microsoft.com/office/drawing/2014/main" id="{ED616511-A325-090B-F903-9B52E8C114D1}"/>
+                <a16:creationId xmlns:a16="http://schemas.microsoft.com/office/drawing/2014/main" id="{A962BEAE-7BD1-3904-F045-BDD267A7AB5F}"/>
               </a:ext>
             </a:extLst>
           </p:cNvPr>
@@ -900,7 +895,7 @@
           <p:cNvPr id="6" name="Slide Number Placeholder 5">
             <a:extLst>
               <a:ext uri="{FF2B5EF4-FFF2-40B4-BE49-F238E27FC236}">
-                <a16:creationId xmlns:a16="http://schemas.microsoft.com/office/drawing/2014/main" id="{4262722F-8D8F-B26F-D9A5-D4894689A62B}"/>
+                <a16:creationId xmlns:a16="http://schemas.microsoft.com/office/drawing/2014/main" id="{1FD4FA4C-4B10-09D5-52E2-E7758A99EAF4}"/>
               </a:ext>
             </a:extLst>
           </p:cNvPr>
@@ -916,7 +911,7 @@
           <a:bodyPr/>
           <a:lstStyle/>
           <a:p>
-            <a:fld id="{BD658C21-2D09-4E88-AF00-E69567C0170A}" type="slidenum">
+            <a:fld id="{9A219F65-89E2-4C01-9CB9-1B657DB643AD}" type="slidenum">
               <a:rPr lang="en-US" smtClean="0"/>
               <a:t>‹#›</a:t>
             </a:fld>
@@ -927,7 +922,7 @@
     </p:spTree>
     <p:extLst>
       <p:ext uri="{BB962C8B-B14F-4D97-AF65-F5344CB8AC3E}">
-        <p14:creationId xmlns:p14="http://schemas.microsoft.com/office/powerpoint/2010/main" val="1040008981"/>
+        <p14:creationId xmlns:p14="http://schemas.microsoft.com/office/powerpoint/2010/main" val="20086678"/>
       </p:ext>
     </p:extLst>
   </p:cSld>
@@ -959,7 +954,7 @@
           <p:cNvPr id="2" name="Title 1">
             <a:extLst>
               <a:ext uri="{FF2B5EF4-FFF2-40B4-BE49-F238E27FC236}">
-                <a16:creationId xmlns:a16="http://schemas.microsoft.com/office/drawing/2014/main" id="{3CD1CDD7-54FA-32C9-E0FE-DEFBFF9DFFA3}"/>
+                <a16:creationId xmlns:a16="http://schemas.microsoft.com/office/drawing/2014/main" id="{D7BE173D-2E91-EE58-94C2-8D070160A9B3}"/>
               </a:ext>
             </a:extLst>
           </p:cNvPr>
@@ -996,7 +991,7 @@
           <p:cNvPr id="3" name="Text Placeholder 2">
             <a:extLst>
               <a:ext uri="{FF2B5EF4-FFF2-40B4-BE49-F238E27FC236}">
-                <a16:creationId xmlns:a16="http://schemas.microsoft.com/office/drawing/2014/main" id="{B809C9F4-4793-F22D-ACE9-113DAFD3F333}"/>
+                <a16:creationId xmlns:a16="http://schemas.microsoft.com/office/drawing/2014/main" id="{B115B22F-B412-18C3-0D2C-6BBDB9BF2D2D}"/>
               </a:ext>
             </a:extLst>
           </p:cNvPr>
@@ -1121,7 +1116,7 @@
           <p:cNvPr id="4" name="Date Placeholder 3">
             <a:extLst>
               <a:ext uri="{FF2B5EF4-FFF2-40B4-BE49-F238E27FC236}">
-                <a16:creationId xmlns:a16="http://schemas.microsoft.com/office/drawing/2014/main" id="{0E96E6DE-A422-D317-D78F-E59C5F59396F}"/>
+                <a16:creationId xmlns:a16="http://schemas.microsoft.com/office/drawing/2014/main" id="{FED6E546-EDAA-5F50-0481-1FC9852D5839}"/>
               </a:ext>
             </a:extLst>
           </p:cNvPr>
@@ -1137,7 +1132,7 @@
           <a:bodyPr/>
           <a:lstStyle/>
           <a:p>
-            <a:fld id="{1B861488-9A07-47B0-8A65-547563D70F6D}" type="datetimeFigureOut">
+            <a:fld id="{3AE6D4E1-CC08-42F1-B88F-E048070B7A93}" type="datetimeFigureOut">
               <a:rPr lang="en-US" smtClean="0"/>
               <a:t>6/18/2026</a:t>
             </a:fld>
@@ -1150,7 +1145,7 @@
           <p:cNvPr id="5" name="Footer Placeholder 4">
             <a:extLst>
               <a:ext uri="{FF2B5EF4-FFF2-40B4-BE49-F238E27FC236}">
-                <a16:creationId xmlns:a16="http://schemas.microsoft.com/office/drawing/2014/main" id="{235C5444-DBCF-1BEC-F36B-ED353A6052AC}"/>
+                <a16:creationId xmlns:a16="http://schemas.microsoft.com/office/drawing/2014/main" id="{B151096C-8E51-E663-B8EF-E42F4D9C1514}"/>
               </a:ext>
             </a:extLst>
           </p:cNvPr>
@@ -1175,7 +1170,7 @@
           <p:cNvPr id="6" name="Slide Number Placeholder 5">
             <a:extLst>
               <a:ext uri="{FF2B5EF4-FFF2-40B4-BE49-F238E27FC236}">
-                <a16:creationId xmlns:a16="http://schemas.microsoft.com/office/drawing/2014/main" id="{4058104B-1CB5-DF5F-A09E-F8F31F315DF1}"/>
+                <a16:creationId xmlns:a16="http://schemas.microsoft.com/office/drawing/2014/main" id="{8039D2FF-40C7-11DF-A340-B4BF22572ABA}"/>
               </a:ext>
             </a:extLst>
           </p:cNvPr>
@@ -1191,7 +1186,7 @@
           <a:bodyPr/>
           <a:lstStyle/>
           <a:p>
-            <a:fld id="{BD658C21-2D09-4E88-AF00-E69567C0170A}" type="slidenum">
+            <a:fld id="{9A219F65-89E2-4C01-9CB9-1B657DB643AD}" type="slidenum">
               <a:rPr lang="en-US" smtClean="0"/>
               <a:t>‹#›</a:t>
             </a:fld>
@@ -1202,7 +1197,7 @@
     </p:spTree>
     <p:extLst>
       <p:ext uri="{BB962C8B-B14F-4D97-AF65-F5344CB8AC3E}">
-        <p14:creationId xmlns:p14="http://schemas.microsoft.com/office/powerpoint/2010/main" val="885641306"/>
+        <p14:creationId xmlns:p14="http://schemas.microsoft.com/office/powerpoint/2010/main" val="3133158816"/>
       </p:ext>
     </p:extLst>
   </p:cSld>
@@ -1234,7 +1229,7 @@
           <p:cNvPr id="2" name="Title 1">
             <a:extLst>
               <a:ext uri="{FF2B5EF4-FFF2-40B4-BE49-F238E27FC236}">
-                <a16:creationId xmlns:a16="http://schemas.microsoft.com/office/drawing/2014/main" id="{5C39A91D-F511-02AF-F5A9-C76AE25D1AFC}"/>
+                <a16:creationId xmlns:a16="http://schemas.microsoft.com/office/drawing/2014/main" id="{E3E31FB8-B124-BFBF-D0A9-D330C7F7D95F}"/>
               </a:ext>
             </a:extLst>
           </p:cNvPr>
@@ -1262,7 +1257,7 @@
           <p:cNvPr id="3" name="Content Placeholder 2">
             <a:extLst>
               <a:ext uri="{FF2B5EF4-FFF2-40B4-BE49-F238E27FC236}">
-                <a16:creationId xmlns:a16="http://schemas.microsoft.com/office/drawing/2014/main" id="{37681973-CBAE-4CF8-00AB-C1CEE0910410}"/>
+                <a16:creationId xmlns:a16="http://schemas.microsoft.com/office/drawing/2014/main" id="{CD2A1A0B-DF15-D5A6-10D9-57AC0C5C17F8}"/>
               </a:ext>
             </a:extLst>
           </p:cNvPr>
@@ -1324,7 +1319,7 @@
           <p:cNvPr id="4" name="Content Placeholder 3">
             <a:extLst>
               <a:ext uri="{FF2B5EF4-FFF2-40B4-BE49-F238E27FC236}">
-                <a16:creationId xmlns:a16="http://schemas.microsoft.com/office/drawing/2014/main" id="{6AB7CB23-1C13-4BF3-7823-DDD91C0F23A8}"/>
+                <a16:creationId xmlns:a16="http://schemas.microsoft.com/office/drawing/2014/main" id="{8BA18A0F-4490-2809-9296-792709ABF581}"/>
               </a:ext>
             </a:extLst>
           </p:cNvPr>
@@ -1386,7 +1381,7 @@
           <p:cNvPr id="5" name="Date Placeholder 4">
             <a:extLst>
               <a:ext uri="{FF2B5EF4-FFF2-40B4-BE49-F238E27FC236}">
-                <a16:creationId xmlns:a16="http://schemas.microsoft.com/office/drawing/2014/main" id="{E5FE3B64-E589-B507-E226-DE186BCBB177}"/>
+                <a16:creationId xmlns:a16="http://schemas.microsoft.com/office/drawing/2014/main" id="{E762E695-1CE4-CDDA-38CB-6E5A36861444}"/>
               </a:ext>
             </a:extLst>
           </p:cNvPr>
@@ -1402,7 +1397,7 @@
           <a:bodyPr/>
           <a:lstStyle/>
           <a:p>
-            <a:fld id="{1B861488-9A07-47B0-8A65-547563D70F6D}" type="datetimeFigureOut">
+            <a:fld id="{3AE6D4E1-CC08-42F1-B88F-E048070B7A93}" type="datetimeFigureOut">
               <a:rPr lang="en-US" smtClean="0"/>
               <a:t>6/18/2026</a:t>
             </a:fld>
@@ -1415,7 +1410,7 @@
           <p:cNvPr id="6" name="Footer Placeholder 5">
             <a:extLst>
               <a:ext uri="{FF2B5EF4-FFF2-40B4-BE49-F238E27FC236}">
-                <a16:creationId xmlns:a16="http://schemas.microsoft.com/office/drawing/2014/main" id="{A3D6865E-8FE9-C3DF-EDBC-92B4D1948861}"/>
+                <a16:creationId xmlns:a16="http://schemas.microsoft.com/office/drawing/2014/main" id="{7A9CBD9E-CF89-F12D-C43F-BCFF49200CC7}"/>
               </a:ext>
             </a:extLst>
           </p:cNvPr>
@@ -1440,7 +1435,7 @@
           <p:cNvPr id="7" name="Slide Number Placeholder 6">
             <a:extLst>
               <a:ext uri="{FF2B5EF4-FFF2-40B4-BE49-F238E27FC236}">
-                <a16:creationId xmlns:a16="http://schemas.microsoft.com/office/drawing/2014/main" id="{51BB0267-17D8-8E37-EF8C-AA84614C5303}"/>
+                <a16:creationId xmlns:a16="http://schemas.microsoft.com/office/drawing/2014/main" id="{AF0C8844-2CB3-D157-0391-73421B1B3A96}"/>
               </a:ext>
             </a:extLst>
           </p:cNvPr>
@@ -1456,7 +1451,7 @@
           <a:bodyPr/>
           <a:lstStyle/>
           <a:p>
-            <a:fld id="{BD658C21-2D09-4E88-AF00-E69567C0170A}" type="slidenum">
+            <a:fld id="{9A219F65-89E2-4C01-9CB9-1B657DB643AD}" type="slidenum">
               <a:rPr lang="en-US" smtClean="0"/>
               <a:t>‹#›</a:t>
             </a:fld>
@@ -1467,7 +1462,7 @@
     </p:spTree>
     <p:extLst>
       <p:ext uri="{BB962C8B-B14F-4D97-AF65-F5344CB8AC3E}">
-        <p14:creationId xmlns:p14="http://schemas.microsoft.com/office/powerpoint/2010/main" val="3057557173"/>
+        <p14:creationId xmlns:p14="http://schemas.microsoft.com/office/powerpoint/2010/main" val="2753269138"/>
       </p:ext>
     </p:extLst>
   </p:cSld>
@@ -1499,7 +1494,7 @@
           <p:cNvPr id="2" name="Title 1">
             <a:extLst>
               <a:ext uri="{FF2B5EF4-FFF2-40B4-BE49-F238E27FC236}">
-                <a16:creationId xmlns:a16="http://schemas.microsoft.com/office/drawing/2014/main" id="{A52A4955-B697-7DEF-E3D7-A1C5547AFDB1}"/>
+                <a16:creationId xmlns:a16="http://schemas.microsoft.com/office/drawing/2014/main" id="{4D4FBD5C-108E-4785-0599-50085EC9BE15}"/>
               </a:ext>
             </a:extLst>
           </p:cNvPr>
@@ -1532,7 +1527,7 @@
           <p:cNvPr id="3" name="Text Placeholder 2">
             <a:extLst>
               <a:ext uri="{FF2B5EF4-FFF2-40B4-BE49-F238E27FC236}">
-                <a16:creationId xmlns:a16="http://schemas.microsoft.com/office/drawing/2014/main" id="{C7F0BF3E-2FED-CE24-31AF-F8E1771D420E}"/>
+                <a16:creationId xmlns:a16="http://schemas.microsoft.com/office/drawing/2014/main" id="{EB607ADA-58BC-4730-4117-322EDE458ED9}"/>
               </a:ext>
             </a:extLst>
           </p:cNvPr>
@@ -1603,7 +1598,7 @@
           <p:cNvPr id="4" name="Content Placeholder 3">
             <a:extLst>
               <a:ext uri="{FF2B5EF4-FFF2-40B4-BE49-F238E27FC236}">
-                <a16:creationId xmlns:a16="http://schemas.microsoft.com/office/drawing/2014/main" id="{AE8B7790-A58B-EC28-AB4E-0DA3377078A0}"/>
+                <a16:creationId xmlns:a16="http://schemas.microsoft.com/office/drawing/2014/main" id="{1E048C8D-3188-9077-E768-70FEC73C2F6A}"/>
               </a:ext>
             </a:extLst>
           </p:cNvPr>
@@ -1665,7 +1660,7 @@
           <p:cNvPr id="5" name="Text Placeholder 4">
             <a:extLst>
               <a:ext uri="{FF2B5EF4-FFF2-40B4-BE49-F238E27FC236}">
-                <a16:creationId xmlns:a16="http://schemas.microsoft.com/office/drawing/2014/main" id="{255D48D5-E6C6-84D6-A7C3-0246F681C914}"/>
+                <a16:creationId xmlns:a16="http://schemas.microsoft.com/office/drawing/2014/main" id="{40A964C5-35F4-0F8A-D98F-35BF850599C9}"/>
               </a:ext>
             </a:extLst>
           </p:cNvPr>
@@ -1736,7 +1731,7 @@
           <p:cNvPr id="6" name="Content Placeholder 5">
             <a:extLst>
               <a:ext uri="{FF2B5EF4-FFF2-40B4-BE49-F238E27FC236}">
-                <a16:creationId xmlns:a16="http://schemas.microsoft.com/office/drawing/2014/main" id="{FDDAD1E5-62FE-34FE-4C7C-1FDAD130A739}"/>
+                <a16:creationId xmlns:a16="http://schemas.microsoft.com/office/drawing/2014/main" id="{CC83F4EE-7A48-5C15-382B-5E0B1FEF4407}"/>
               </a:ext>
             </a:extLst>
           </p:cNvPr>
@@ -1798,7 +1793,7 @@
           <p:cNvPr id="7" name="Date Placeholder 6">
             <a:extLst>
               <a:ext uri="{FF2B5EF4-FFF2-40B4-BE49-F238E27FC236}">
-                <a16:creationId xmlns:a16="http://schemas.microsoft.com/office/drawing/2014/main" id="{883A6C05-F953-080E-9217-647EE8121F58}"/>
+                <a16:creationId xmlns:a16="http://schemas.microsoft.com/office/drawing/2014/main" id="{35923E69-29F1-D359-93E4-B4AC2179201F}"/>
               </a:ext>
             </a:extLst>
           </p:cNvPr>
@@ -1814,7 +1809,7 @@
           <a:bodyPr/>
           <a:lstStyle/>
           <a:p>
-            <a:fld id="{1B861488-9A07-47B0-8A65-547563D70F6D}" type="datetimeFigureOut">
+            <a:fld id="{3AE6D4E1-CC08-42F1-B88F-E048070B7A93}" type="datetimeFigureOut">
               <a:rPr lang="en-US" smtClean="0"/>
               <a:t>6/18/2026</a:t>
             </a:fld>
@@ -1827,7 +1822,7 @@
           <p:cNvPr id="8" name="Footer Placeholder 7">
             <a:extLst>
               <a:ext uri="{FF2B5EF4-FFF2-40B4-BE49-F238E27FC236}">
-                <a16:creationId xmlns:a16="http://schemas.microsoft.com/office/drawing/2014/main" id="{E3061415-3EB3-94EF-7F34-DBF3CEC4D179}"/>
+                <a16:creationId xmlns:a16="http://schemas.microsoft.com/office/drawing/2014/main" id="{D9FE8842-FA74-4C2F-C2EA-5C62745B63A8}"/>
               </a:ext>
             </a:extLst>
           </p:cNvPr>
@@ -1852,7 +1847,7 @@
           <p:cNvPr id="9" name="Slide Number Placeholder 8">
             <a:extLst>
               <a:ext uri="{FF2B5EF4-FFF2-40B4-BE49-F238E27FC236}">
-                <a16:creationId xmlns:a16="http://schemas.microsoft.com/office/drawing/2014/main" id="{A968AA47-A56E-0DFA-046A-7A2CB54379DF}"/>
+                <a16:creationId xmlns:a16="http://schemas.microsoft.com/office/drawing/2014/main" id="{2B3E3892-5F72-C6B8-B254-2E18F7DFBFD9}"/>
               </a:ext>
             </a:extLst>
           </p:cNvPr>
@@ -1868,7 +1863,7 @@
           <a:bodyPr/>
           <a:lstStyle/>
           <a:p>
-            <a:fld id="{BD658C21-2D09-4E88-AF00-E69567C0170A}" type="slidenum">
+            <a:fld id="{9A219F65-89E2-4C01-9CB9-1B657DB643AD}" type="slidenum">
               <a:rPr lang="en-US" smtClean="0"/>
               <a:t>‹#›</a:t>
             </a:fld>
@@ -1879,7 +1874,7 @@
     </p:spTree>
     <p:extLst>
       <p:ext uri="{BB962C8B-B14F-4D97-AF65-F5344CB8AC3E}">
-        <p14:creationId xmlns:p14="http://schemas.microsoft.com/office/powerpoint/2010/main" val="2108777887"/>
+        <p14:creationId xmlns:p14="http://schemas.microsoft.com/office/powerpoint/2010/main" val="3953383552"/>
       </p:ext>
     </p:extLst>
   </p:cSld>
@@ -1911,7 +1906,7 @@
           <p:cNvPr id="2" name="Title 1">
             <a:extLst>
               <a:ext uri="{FF2B5EF4-FFF2-40B4-BE49-F238E27FC236}">
-                <a16:creationId xmlns:a16="http://schemas.microsoft.com/office/drawing/2014/main" id="{D49FFF0D-EE6B-84A3-E8EF-2A65A382FA63}"/>
+                <a16:creationId xmlns:a16="http://schemas.microsoft.com/office/drawing/2014/main" id="{D2629410-CAB1-C9B3-5265-A4522E7B302C}"/>
               </a:ext>
             </a:extLst>
           </p:cNvPr>
@@ -1939,7 +1934,7 @@
           <p:cNvPr id="3" name="Date Placeholder 2">
             <a:extLst>
               <a:ext uri="{FF2B5EF4-FFF2-40B4-BE49-F238E27FC236}">
-                <a16:creationId xmlns:a16="http://schemas.microsoft.com/office/drawing/2014/main" id="{D8A6C248-198A-4F3C-911B-E15773B11E76}"/>
+                <a16:creationId xmlns:a16="http://schemas.microsoft.com/office/drawing/2014/main" id="{B160E90E-3713-EC64-23EF-13F2DE14A5FB}"/>
               </a:ext>
             </a:extLst>
           </p:cNvPr>
@@ -1955,7 +1950,7 @@
           <a:bodyPr/>
           <a:lstStyle/>
           <a:p>
-            <a:fld id="{1B861488-9A07-47B0-8A65-547563D70F6D}" type="datetimeFigureOut">
+            <a:fld id="{3AE6D4E1-CC08-42F1-B88F-E048070B7A93}" type="datetimeFigureOut">
               <a:rPr lang="en-US" smtClean="0"/>
               <a:t>6/18/2026</a:t>
             </a:fld>
@@ -1968,7 +1963,7 @@
           <p:cNvPr id="4" name="Footer Placeholder 3">
             <a:extLst>
               <a:ext uri="{FF2B5EF4-FFF2-40B4-BE49-F238E27FC236}">
-                <a16:creationId xmlns:a16="http://schemas.microsoft.com/office/drawing/2014/main" id="{4AEFE174-CC26-C521-2DCA-2FCCE7E303AB}"/>
+                <a16:creationId xmlns:a16="http://schemas.microsoft.com/office/drawing/2014/main" id="{40818C08-B662-29DB-04BB-AB15D59734CB}"/>
               </a:ext>
             </a:extLst>
           </p:cNvPr>
@@ -1993,7 +1988,7 @@
           <p:cNvPr id="5" name="Slide Number Placeholder 4">
             <a:extLst>
               <a:ext uri="{FF2B5EF4-FFF2-40B4-BE49-F238E27FC236}">
-                <a16:creationId xmlns:a16="http://schemas.microsoft.com/office/drawing/2014/main" id="{32B18307-0A35-180F-F085-FDADCF809C8B}"/>
+                <a16:creationId xmlns:a16="http://schemas.microsoft.com/office/drawing/2014/main" id="{0863BF03-25D1-A7A5-DDD1-D35E14A40EDC}"/>
               </a:ext>
             </a:extLst>
           </p:cNvPr>
@@ -2009,7 +2004,7 @@
           <a:bodyPr/>
           <a:lstStyle/>
           <a:p>
-            <a:fld id="{BD658C21-2D09-4E88-AF00-E69567C0170A}" type="slidenum">
+            <a:fld id="{9A219F65-89E2-4C01-9CB9-1B657DB643AD}" type="slidenum">
               <a:rPr lang="en-US" smtClean="0"/>
               <a:t>‹#›</a:t>
             </a:fld>
@@ -2020,7 +2015,7 @@
     </p:spTree>
     <p:extLst>
       <p:ext uri="{BB962C8B-B14F-4D97-AF65-F5344CB8AC3E}">
-        <p14:creationId xmlns:p14="http://schemas.microsoft.com/office/powerpoint/2010/main" val="186127538"/>
+        <p14:creationId xmlns:p14="http://schemas.microsoft.com/office/powerpoint/2010/main" val="1359697335"/>
       </p:ext>
     </p:extLst>
   </p:cSld>
@@ -2052,7 +2047,7 @@
           <p:cNvPr id="2" name="Date Placeholder 1">
             <a:extLst>
               <a:ext uri="{FF2B5EF4-FFF2-40B4-BE49-F238E27FC236}">
-                <a16:creationId xmlns:a16="http://schemas.microsoft.com/office/drawing/2014/main" id="{38926CFC-E1C8-5062-15B9-F20C313D2131}"/>
+                <a16:creationId xmlns:a16="http://schemas.microsoft.com/office/drawing/2014/main" id="{35736049-CE88-35A2-C813-9FB2FDDC48CD}"/>
               </a:ext>
             </a:extLst>
           </p:cNvPr>
@@ -2068,7 +2063,7 @@
           <a:bodyPr/>
           <a:lstStyle/>
           <a:p>
-            <a:fld id="{1B861488-9A07-47B0-8A65-547563D70F6D}" type="datetimeFigureOut">
+            <a:fld id="{3AE6D4E1-CC08-42F1-B88F-E048070B7A93}" type="datetimeFigureOut">
               <a:rPr lang="en-US" smtClean="0"/>
               <a:t>6/18/2026</a:t>
             </a:fld>
@@ -2081,7 +2076,7 @@
           <p:cNvPr id="3" name="Footer Placeholder 2">
             <a:extLst>
               <a:ext uri="{FF2B5EF4-FFF2-40B4-BE49-F238E27FC236}">
-                <a16:creationId xmlns:a16="http://schemas.microsoft.com/office/drawing/2014/main" id="{38EDCB6C-0E59-0214-30E5-ADA7363D3F9D}"/>
+                <a16:creationId xmlns:a16="http://schemas.microsoft.com/office/drawing/2014/main" id="{1E66D45C-829D-3844-9C71-96077340D161}"/>
               </a:ext>
             </a:extLst>
           </p:cNvPr>
@@ -2106,7 +2101,7 @@
           <p:cNvPr id="4" name="Slide Number Placeholder 3">
             <a:extLst>
               <a:ext uri="{FF2B5EF4-FFF2-40B4-BE49-F238E27FC236}">
-                <a16:creationId xmlns:a16="http://schemas.microsoft.com/office/drawing/2014/main" id="{CB616BBA-586D-92BD-E7A2-935AB88CEF18}"/>
+                <a16:creationId xmlns:a16="http://schemas.microsoft.com/office/drawing/2014/main" id="{6DF50D89-63BF-4580-53A2-BF991F4702DA}"/>
               </a:ext>
             </a:extLst>
           </p:cNvPr>
@@ -2122,7 +2117,7 @@
           <a:bodyPr/>
           <a:lstStyle/>
           <a:p>
-            <a:fld id="{BD658C21-2D09-4E88-AF00-E69567C0170A}" type="slidenum">
+            <a:fld id="{9A219F65-89E2-4C01-9CB9-1B657DB643AD}" type="slidenum">
               <a:rPr lang="en-US" smtClean="0"/>
               <a:t>‹#›</a:t>
             </a:fld>
@@ -2133,7 +2128,7 @@
     </p:spTree>
     <p:extLst>
       <p:ext uri="{BB962C8B-B14F-4D97-AF65-F5344CB8AC3E}">
-        <p14:creationId xmlns:p14="http://schemas.microsoft.com/office/powerpoint/2010/main" val="1198954161"/>
+        <p14:creationId xmlns:p14="http://schemas.microsoft.com/office/powerpoint/2010/main" val="2749744934"/>
       </p:ext>
     </p:extLst>
   </p:cSld>
@@ -2165,7 +2160,7 @@
           <p:cNvPr id="2" name="Title 1">
             <a:extLst>
               <a:ext uri="{FF2B5EF4-FFF2-40B4-BE49-F238E27FC236}">
-                <a16:creationId xmlns:a16="http://schemas.microsoft.com/office/drawing/2014/main" id="{703F17BA-CDA1-D767-32A5-2732E720E5E8}"/>
+                <a16:creationId xmlns:a16="http://schemas.microsoft.com/office/drawing/2014/main" id="{DDC350D8-A8AB-1148-98E8-3862D9AC40C4}"/>
               </a:ext>
             </a:extLst>
           </p:cNvPr>
@@ -2202,7 +2197,7 @@
           <p:cNvPr id="3" name="Content Placeholder 2">
             <a:extLst>
               <a:ext uri="{FF2B5EF4-FFF2-40B4-BE49-F238E27FC236}">
-                <a16:creationId xmlns:a16="http://schemas.microsoft.com/office/drawing/2014/main" id="{FC38D29A-416B-40DF-E667-C97BDEE149F3}"/>
+                <a16:creationId xmlns:a16="http://schemas.microsoft.com/office/drawing/2014/main" id="{2FCDB8E1-5F2B-06DE-8F16-90E81677B04C}"/>
               </a:ext>
             </a:extLst>
           </p:cNvPr>
@@ -2292,7 +2287,7 @@
           <p:cNvPr id="4" name="Text Placeholder 3">
             <a:extLst>
               <a:ext uri="{FF2B5EF4-FFF2-40B4-BE49-F238E27FC236}">
-                <a16:creationId xmlns:a16="http://schemas.microsoft.com/office/drawing/2014/main" id="{C51E6E9C-1E50-D4D6-97A9-4915EB1DE70B}"/>
+                <a16:creationId xmlns:a16="http://schemas.microsoft.com/office/drawing/2014/main" id="{85A8DF89-5E9F-7B82-129D-960733BAB1EF}"/>
               </a:ext>
             </a:extLst>
           </p:cNvPr>
@@ -2363,7 +2358,7 @@
           <p:cNvPr id="5" name="Date Placeholder 4">
             <a:extLst>
               <a:ext uri="{FF2B5EF4-FFF2-40B4-BE49-F238E27FC236}">
-                <a16:creationId xmlns:a16="http://schemas.microsoft.com/office/drawing/2014/main" id="{4A2DA2A2-BAAE-58B0-92E3-54BE5FF982CA}"/>
+                <a16:creationId xmlns:a16="http://schemas.microsoft.com/office/drawing/2014/main" id="{54BD7B6D-E094-CC9F-7E25-9650E57301F1}"/>
               </a:ext>
             </a:extLst>
           </p:cNvPr>
@@ -2379,7 +2374,7 @@
           <a:bodyPr/>
           <a:lstStyle/>
           <a:p>
-            <a:fld id="{1B861488-9A07-47B0-8A65-547563D70F6D}" type="datetimeFigureOut">
+            <a:fld id="{3AE6D4E1-CC08-42F1-B88F-E048070B7A93}" type="datetimeFigureOut">
               <a:rPr lang="en-US" smtClean="0"/>
               <a:t>6/18/2026</a:t>
             </a:fld>
@@ -2392,7 +2387,7 @@
           <p:cNvPr id="6" name="Footer Placeholder 5">
             <a:extLst>
               <a:ext uri="{FF2B5EF4-FFF2-40B4-BE49-F238E27FC236}">
-                <a16:creationId xmlns:a16="http://schemas.microsoft.com/office/drawing/2014/main" id="{D7ABAC3A-A68E-1E83-EFB4-A1EB172D1180}"/>
+                <a16:creationId xmlns:a16="http://schemas.microsoft.com/office/drawing/2014/main" id="{B7DFA2D6-55A7-2339-950F-2EBFE599FE72}"/>
               </a:ext>
             </a:extLst>
           </p:cNvPr>
@@ -2417,7 +2412,7 @@
           <p:cNvPr id="7" name="Slide Number Placeholder 6">
             <a:extLst>
               <a:ext uri="{FF2B5EF4-FFF2-40B4-BE49-F238E27FC236}">
-                <a16:creationId xmlns:a16="http://schemas.microsoft.com/office/drawing/2014/main" id="{007599E6-8AF1-B92F-5769-04F48904F082}"/>
+                <a16:creationId xmlns:a16="http://schemas.microsoft.com/office/drawing/2014/main" id="{C0EBFD89-5C12-07C3-3EB3-B7CD8009B1CE}"/>
               </a:ext>
             </a:extLst>
           </p:cNvPr>
@@ -2433,7 +2428,7 @@
           <a:bodyPr/>
           <a:lstStyle/>
           <a:p>
-            <a:fld id="{BD658C21-2D09-4E88-AF00-E69567C0170A}" type="slidenum">
+            <a:fld id="{9A219F65-89E2-4C01-9CB9-1B657DB643AD}" type="slidenum">
               <a:rPr lang="en-US" smtClean="0"/>
               <a:t>‹#›</a:t>
             </a:fld>
@@ -2444,7 +2439,7 @@
     </p:spTree>
     <p:extLst>
       <p:ext uri="{BB962C8B-B14F-4D97-AF65-F5344CB8AC3E}">
-        <p14:creationId xmlns:p14="http://schemas.microsoft.com/office/powerpoint/2010/main" val="2908183421"/>
+        <p14:creationId xmlns:p14="http://schemas.microsoft.com/office/powerpoint/2010/main" val="728989364"/>
       </p:ext>
     </p:extLst>
   </p:cSld>
@@ -2476,7 +2471,7 @@
           <p:cNvPr id="2" name="Title 1">
             <a:extLst>
               <a:ext uri="{FF2B5EF4-FFF2-40B4-BE49-F238E27FC236}">
-                <a16:creationId xmlns:a16="http://schemas.microsoft.com/office/drawing/2014/main" id="{09608B88-D504-8C8A-203F-3196285DF29E}"/>
+                <a16:creationId xmlns:a16="http://schemas.microsoft.com/office/drawing/2014/main" id="{97A86FB4-B09D-756C-10ED-79703F7733F7}"/>
               </a:ext>
             </a:extLst>
           </p:cNvPr>
@@ -2513,7 +2508,7 @@
           <p:cNvPr id="3" name="Picture Placeholder 2">
             <a:extLst>
               <a:ext uri="{FF2B5EF4-FFF2-40B4-BE49-F238E27FC236}">
-                <a16:creationId xmlns:a16="http://schemas.microsoft.com/office/drawing/2014/main" id="{6AA7C00F-B409-A7E0-6EA2-0FA6C17D190F}"/>
+                <a16:creationId xmlns:a16="http://schemas.microsoft.com/office/drawing/2014/main" id="{83DB229A-D60C-ED77-65E5-6AA51558DC5D}"/>
               </a:ext>
             </a:extLst>
           </p:cNvPr>
@@ -2580,7 +2575,7 @@
           <p:cNvPr id="4" name="Text Placeholder 3">
             <a:extLst>
               <a:ext uri="{FF2B5EF4-FFF2-40B4-BE49-F238E27FC236}">
-                <a16:creationId xmlns:a16="http://schemas.microsoft.com/office/drawing/2014/main" id="{847472A7-5095-BFE9-AEB0-EE9B3897213D}"/>
+                <a16:creationId xmlns:a16="http://schemas.microsoft.com/office/drawing/2014/main" id="{DC06568D-CD50-852F-9DD5-7F187A5901D7}"/>
               </a:ext>
             </a:extLst>
           </p:cNvPr>
@@ -2651,7 +2646,7 @@
           <p:cNvPr id="5" name="Date Placeholder 4">
             <a:extLst>
               <a:ext uri="{FF2B5EF4-FFF2-40B4-BE49-F238E27FC236}">
-                <a16:creationId xmlns:a16="http://schemas.microsoft.com/office/drawing/2014/main" id="{23491C71-E993-FE49-D0EA-1DBF2D3D20B9}"/>
+                <a16:creationId xmlns:a16="http://schemas.microsoft.com/office/drawing/2014/main" id="{91DBD52F-CFF7-6F91-3D16-E59E960F86FD}"/>
               </a:ext>
             </a:extLst>
           </p:cNvPr>
@@ -2667,7 +2662,7 @@
           <a:bodyPr/>
           <a:lstStyle/>
           <a:p>
-            <a:fld id="{1B861488-9A07-47B0-8A65-547563D70F6D}" type="datetimeFigureOut">
+            <a:fld id="{3AE6D4E1-CC08-42F1-B88F-E048070B7A93}" type="datetimeFigureOut">
               <a:rPr lang="en-US" smtClean="0"/>
               <a:t>6/18/2026</a:t>
             </a:fld>
@@ -2680,7 +2675,7 @@
           <p:cNvPr id="6" name="Footer Placeholder 5">
             <a:extLst>
               <a:ext uri="{FF2B5EF4-FFF2-40B4-BE49-F238E27FC236}">
-                <a16:creationId xmlns:a16="http://schemas.microsoft.com/office/drawing/2014/main" id="{F8E4CF76-C4DF-73B7-46C0-42AE56A37395}"/>
+                <a16:creationId xmlns:a16="http://schemas.microsoft.com/office/drawing/2014/main" id="{6DC5705F-5B1C-D9B1-A21B-350DC86D7675}"/>
               </a:ext>
             </a:extLst>
           </p:cNvPr>
@@ -2705,7 +2700,7 @@
           <p:cNvPr id="7" name="Slide Number Placeholder 6">
             <a:extLst>
               <a:ext uri="{FF2B5EF4-FFF2-40B4-BE49-F238E27FC236}">
-                <a16:creationId xmlns:a16="http://schemas.microsoft.com/office/drawing/2014/main" id="{725D4D8E-987F-E4C9-D2DF-EA48A6979721}"/>
+                <a16:creationId xmlns:a16="http://schemas.microsoft.com/office/drawing/2014/main" id="{C64205B1-C5B0-6A41-6287-948A877E9202}"/>
               </a:ext>
             </a:extLst>
           </p:cNvPr>
@@ -2721,7 +2716,7 @@
           <a:bodyPr/>
           <a:lstStyle/>
           <a:p>
-            <a:fld id="{BD658C21-2D09-4E88-AF00-E69567C0170A}" type="slidenum">
+            <a:fld id="{9A219F65-89E2-4C01-9CB9-1B657DB643AD}" type="slidenum">
               <a:rPr lang="en-US" smtClean="0"/>
               <a:t>‹#›</a:t>
             </a:fld>
@@ -2732,7 +2727,7 @@
     </p:spTree>
     <p:extLst>
       <p:ext uri="{BB962C8B-B14F-4D97-AF65-F5344CB8AC3E}">
-        <p14:creationId xmlns:p14="http://schemas.microsoft.com/office/powerpoint/2010/main" val="3630507058"/>
+        <p14:creationId xmlns:p14="http://schemas.microsoft.com/office/powerpoint/2010/main" val="551773766"/>
       </p:ext>
     </p:extLst>
   </p:cSld>
@@ -2769,7 +2764,7 @@
           <p:cNvPr id="2" name="Title Placeholder 1">
             <a:extLst>
               <a:ext uri="{FF2B5EF4-FFF2-40B4-BE49-F238E27FC236}">
-                <a16:creationId xmlns:a16="http://schemas.microsoft.com/office/drawing/2014/main" id="{E1C1F316-5595-6FF2-55CE-04D642DEDB1E}"/>
+                <a16:creationId xmlns:a16="http://schemas.microsoft.com/office/drawing/2014/main" id="{FBB67751-338B-0562-FF0E-889CD1E6375E}"/>
               </a:ext>
             </a:extLst>
           </p:cNvPr>
@@ -2807,7 +2802,7 @@
           <p:cNvPr id="3" name="Text Placeholder 2">
             <a:extLst>
               <a:ext uri="{FF2B5EF4-FFF2-40B4-BE49-F238E27FC236}">
-                <a16:creationId xmlns:a16="http://schemas.microsoft.com/office/drawing/2014/main" id="{ABF13EEF-0A94-5F95-71AD-ED108B59D0DA}"/>
+                <a16:creationId xmlns:a16="http://schemas.microsoft.com/office/drawing/2014/main" id="{2C34B572-1FD0-BAA7-B5AC-E8C6415C26A0}"/>
               </a:ext>
             </a:extLst>
           </p:cNvPr>
@@ -2874,7 +2869,7 @@
           <p:cNvPr id="4" name="Date Placeholder 3">
             <a:extLst>
               <a:ext uri="{FF2B5EF4-FFF2-40B4-BE49-F238E27FC236}">
-                <a16:creationId xmlns:a16="http://schemas.microsoft.com/office/drawing/2014/main" id="{ACE1523D-23A0-AFF0-0665-45C548CAAE0B}"/>
+                <a16:creationId xmlns:a16="http://schemas.microsoft.com/office/drawing/2014/main" id="{C11236E9-86D9-568E-53ED-2C2B2C047FB0}"/>
               </a:ext>
             </a:extLst>
           </p:cNvPr>
@@ -2908,7 +2903,7 @@
             </a:lvl1pPr>
           </a:lstStyle>
           <a:p>
-            <a:fld id="{1B861488-9A07-47B0-8A65-547563D70F6D}" type="datetimeFigureOut">
+            <a:fld id="{3AE6D4E1-CC08-42F1-B88F-E048070B7A93}" type="datetimeFigureOut">
               <a:rPr lang="en-US" smtClean="0"/>
               <a:t>6/18/2026</a:t>
             </a:fld>
@@ -2921,7 +2916,7 @@
           <p:cNvPr id="5" name="Footer Placeholder 4">
             <a:extLst>
               <a:ext uri="{FF2B5EF4-FFF2-40B4-BE49-F238E27FC236}">
-                <a16:creationId xmlns:a16="http://schemas.microsoft.com/office/drawing/2014/main" id="{D459011B-AF4D-BFE1-09A3-D3B7C83175E5}"/>
+                <a16:creationId xmlns:a16="http://schemas.microsoft.com/office/drawing/2014/main" id="{CAA45C3A-D196-65DE-1644-E901899E5B32}"/>
               </a:ext>
             </a:extLst>
           </p:cNvPr>
@@ -2964,7 +2959,7 @@
           <p:cNvPr id="6" name="Slide Number Placeholder 5">
             <a:extLst>
               <a:ext uri="{FF2B5EF4-FFF2-40B4-BE49-F238E27FC236}">
-                <a16:creationId xmlns:a16="http://schemas.microsoft.com/office/drawing/2014/main" id="{B838A95A-2886-034C-7662-579511EF82FE}"/>
+                <a16:creationId xmlns:a16="http://schemas.microsoft.com/office/drawing/2014/main" id="{F437E6C1-6A34-2194-6F59-0399E48080CF}"/>
               </a:ext>
             </a:extLst>
           </p:cNvPr>
@@ -2998,7 +2993,7 @@
             </a:lvl1pPr>
           </a:lstStyle>
           <a:p>
-            <a:fld id="{BD658C21-2D09-4E88-AF00-E69567C0170A}" type="slidenum">
+            <a:fld id="{9A219F65-89E2-4C01-9CB9-1B657DB643AD}" type="slidenum">
               <a:rPr lang="en-US" smtClean="0"/>
               <a:t>‹#›</a:t>
             </a:fld>
@@ -3009,7 +3004,7 @@
     </p:spTree>
     <p:extLst>
       <p:ext uri="{BB962C8B-B14F-4D97-AF65-F5344CB8AC3E}">
-        <p14:creationId xmlns:p14="http://schemas.microsoft.com/office/powerpoint/2010/main" val="1840548751"/>
+        <p14:creationId xmlns:p14="http://schemas.microsoft.com/office/powerpoint/2010/main" val="1194321956"/>
       </p:ext>
     </p:extLst>
   </p:cSld>
@@ -3312,7 +3307,7 @@
 
 <file path=ppt/slides/slide1.xml><?xml version="1.0" encoding="utf-8"?>
 <p:sld xmlns:a="http://schemas.openxmlformats.org/drawingml/2006/main" xmlns:r="http://schemas.openxmlformats.org/officeDocument/2006/relationships" xmlns:p="http://schemas.openxmlformats.org/presentationml/2006/main">
-  <p:cSld name="group-transform">
+  <p:cSld>
     <p:spTree>
       <p:nvGrpSpPr>
         <p:cNvPr id="1" name=""/>
@@ -3329,10 +3324,10 @@
       </p:grpSpPr>
       <p:sp>
         <p:nvSpPr>
-          <p:cNvPr id="2" name="TextBox 1">
-            <a:extLst>
-              <a:ext uri="{FF2B5EF4-FFF2-40B4-BE49-F238E27FC236}">
-                <a16:creationId xmlns:a16="http://schemas.microsoft.com/office/drawing/2014/main" id="{65E2148E-E34D-70F4-F3C6-5BA4B5CEC6B7}"/>
+          <p:cNvPr id="2" name="label Grouped PowerPoint transforms; slide 2 is duplicated and ungrouped in PowerPoint">
+            <a:extLst>
+              <a:ext uri="{FF2B5EF4-FFF2-40B4-BE49-F238E27FC236}">
+                <a16:creationId xmlns:a16="http://schemas.microsoft.com/office/drawing/2014/main" id="{B0C0AF6F-B9CB-6633-E8E1-8A099E7740E5}"/>
               </a:ext>
             </a:extLst>
           </p:cNvPr>
@@ -3342,7 +3337,7 @@
         <p:spPr>
           <a:xfrm>
             <a:off x="304800" y="203200"/>
-            <a:ext cx="11430000" cy="338554"/>
+            <a:ext cx="11430000" cy="230832"/>
           </a:xfrm>
           <a:prstGeom prst="rect">
             <a:avLst/>
@@ -3356,20 +3351,22 @@
           <a:lstStyle/>
           <a:p>
             <a:r>
-              <a:rPr lang="en-US" sz="1600">
-                <a:latin typeface="Aptos" panose="020B0004020202020204" pitchFamily="34" charset="0"/>
+              <a:rPr lang="en-US" sz="900">
+                <a:solidFill>
+                  <a:srgbClr val="282828"/>
+                </a:solidFill>
               </a:rPr>
-              <a:t>PowerPoint-authored group transform fixture: rotation and flip on p:grpSpPr xfrm</a:t>
-            </a:r>
-          </a:p>
-        </p:txBody>
-      </p:sp>
-      <p:sp>
-        <p:nvSpPr>
-          <p:cNvPr id="3" name="TextBox 2">
-            <a:extLst>
-              <a:ext uri="{FF2B5EF4-FFF2-40B4-BE49-F238E27FC236}">
-                <a16:creationId xmlns:a16="http://schemas.microsoft.com/office/drawing/2014/main" id="{C855E3B3-D906-3AFA-FC15-F98A633D147B}"/>
+              <a:t>Grouped PowerPoint transforms; slide 2 is duplicated and ungrouped in PowerPoint</a:t>
+            </a:r>
+          </a:p>
+        </p:txBody>
+      </p:sp>
+      <p:sp>
+        <p:nvSpPr>
+          <p:cNvPr id="3" name="label rot30">
+            <a:extLst>
+              <a:ext uri="{FF2B5EF4-FFF2-40B4-BE49-F238E27FC236}">
+                <a16:creationId xmlns:a16="http://schemas.microsoft.com/office/drawing/2014/main" id="{D2D0F98B-66FD-5AED-F280-DE247191E08B}"/>
               </a:ext>
             </a:extLst>
           </p:cNvPr>
@@ -3378,8 +3375,8 @@
         </p:nvSpPr>
         <p:spPr>
           <a:xfrm>
-            <a:off x="889000" y="850900"/>
-            <a:ext cx="2667000" cy="246221"/>
+            <a:off x="889000" y="889000"/>
+            <a:ext cx="2603500" cy="230832"/>
           </a:xfrm>
           <a:prstGeom prst="rect">
             <a:avLst/>
@@ -3393,8 +3390,10 @@
           <a:lstStyle/>
           <a:p>
             <a:r>
-              <a:rPr lang="en-US" sz="1000">
-                <a:latin typeface="Aptos" panose="020B0004020202020204" pitchFamily="34" charset="0"/>
+              <a:rPr lang="en-US" sz="900">
+                <a:solidFill>
+                  <a:srgbClr val="282828"/>
+                </a:solidFill>
               </a:rPr>
               <a:t>rot30</a:t>
             </a:r>
@@ -3406,18 +3405,20 @@
           <p:cNvPr id="7" name="rot30">
             <a:extLst>
               <a:ext uri="{FF2B5EF4-FFF2-40B4-BE49-F238E27FC236}">
-                <a16:creationId xmlns:a16="http://schemas.microsoft.com/office/drawing/2014/main" id="{11974217-C816-D0E1-25B6-1DF810F7A959}"/>
-              </a:ext>
-            </a:extLst>
-          </p:cNvPr>
-          <p:cNvGrpSpPr/>
+                <a16:creationId xmlns:a16="http://schemas.microsoft.com/office/drawing/2014/main" id="{0394D20F-FC68-CCF7-A1EB-489CE7CF6CBA}"/>
+              </a:ext>
+            </a:extLst>
+          </p:cNvPr>
+          <p:cNvGrpSpPr>
+            <a:grpSpLocks/>
+          </p:cNvGrpSpPr>
           <p:nvPr/>
         </p:nvGrpSpPr>
         <p:grpSpPr>
           <a:xfrm rot="1800000">
-            <a:off x="889000" y="1206500"/>
+            <a:off x="889000" y="1219200"/>
             <a:ext cx="2336800" cy="1955800"/>
-            <a:chOff x="889000" y="1206500"/>
+            <a:chOff x="889000" y="1219200"/>
             <a:chExt cx="2336800" cy="1955800"/>
           </a:xfrm>
         </p:grpSpPr>
@@ -3426,7 +3427,7 @@
             <p:cNvPr id="4" name="rot30 child blue rect">
               <a:extLst>
                 <a:ext uri="{FF2B5EF4-FFF2-40B4-BE49-F238E27FC236}">
-                  <a16:creationId xmlns:a16="http://schemas.microsoft.com/office/drawing/2014/main" id="{26E23C0F-C529-A01B-802A-2DFA1202F33E}"/>
+                  <a16:creationId xmlns:a16="http://schemas.microsoft.com/office/drawing/2014/main" id="{30C2C588-F61C-72D1-E8CB-E0233C312860}"/>
                 </a:ext>
               </a:extLst>
             </p:cNvPr>
@@ -3435,18 +3436,18 @@
           </p:nvSpPr>
           <p:spPr>
             <a:xfrm>
-              <a:off x="889000" y="1206500"/>
+              <a:off x="889000" y="1219200"/>
               <a:ext cx="1219200" cy="609600"/>
             </a:xfrm>
             <a:prstGeom prst="rect">
               <a:avLst/>
             </a:prstGeom>
             <a:solidFill>
-              <a:srgbClr val="3F95D9"/>
+              <a:srgbClr val="4375CD"/>
             </a:solidFill>
-            <a:ln>
+            <a:ln w="12700">
               <a:solidFill>
-                <a:srgbClr val="004B7A"/>
+                <a:srgbClr val="323232"/>
               </a:solidFill>
             </a:ln>
           </p:spPr>
@@ -3471,10 +3472,7 @@
             <a:lstStyle/>
             <a:p>
               <a:pPr algn="ctr"/>
-              <a:r>
-                <a:rPr lang="en-US" sz="1400"/>
-                <a:t>A</a:t>
-              </a:r>
+              <a:endParaRPr lang="en-US"/>
             </a:p>
           </p:txBody>
         </p:sp>
@@ -3483,7 +3481,7 @@
             <p:cNvPr id="5" name="rot30 child green oval">
               <a:extLst>
                 <a:ext uri="{FF2B5EF4-FFF2-40B4-BE49-F238E27FC236}">
-                  <a16:creationId xmlns:a16="http://schemas.microsoft.com/office/drawing/2014/main" id="{E79BE68F-B5BA-730A-F387-77E645AFCB4F}"/>
+                  <a16:creationId xmlns:a16="http://schemas.microsoft.com/office/drawing/2014/main" id="{04594D0F-94DC-5AEC-C64C-89B754D1891B}"/>
                 </a:ext>
               </a:extLst>
             </p:cNvPr>
@@ -3492,18 +3490,18 @@
           </p:nvSpPr>
           <p:spPr>
             <a:xfrm>
-              <a:off x="2489200" y="1689100"/>
+              <a:off x="2489200" y="1701800"/>
               <a:ext cx="736600" cy="736600"/>
             </a:xfrm>
             <a:prstGeom prst="ellipse">
               <a:avLst/>
             </a:prstGeom>
             <a:solidFill>
-              <a:srgbClr val="32A865"/>
+              <a:srgbClr val="50A05A"/>
             </a:solidFill>
-            <a:ln>
+            <a:ln w="12700">
               <a:solidFill>
-                <a:srgbClr val="225522"/>
+                <a:srgbClr val="323232"/>
               </a:solidFill>
             </a:ln>
           </p:spPr>
@@ -3528,10 +3526,7 @@
             <a:lstStyle/>
             <a:p>
               <a:pPr algn="ctr"/>
-              <a:r>
-                <a:rPr lang="en-US" sz="1400"/>
-                <a:t>B</a:t>
-              </a:r>
+              <a:endParaRPr lang="en-US"/>
             </a:p>
           </p:txBody>
         </p:sp>
@@ -3540,7 +3535,7 @@
             <p:cNvPr id="6" name="rot30 child purple triangle">
               <a:extLst>
                 <a:ext uri="{FF2B5EF4-FFF2-40B4-BE49-F238E27FC236}">
-                  <a16:creationId xmlns:a16="http://schemas.microsoft.com/office/drawing/2014/main" id="{76B87BD2-A84C-382B-82E8-926AB585440A}"/>
+                  <a16:creationId xmlns:a16="http://schemas.microsoft.com/office/drawing/2014/main" id="{858E5148-BC63-7F95-196F-169BB06E100A}"/>
                 </a:ext>
               </a:extLst>
             </p:cNvPr>
@@ -3549,18 +3544,18 @@
           </p:nvSpPr>
           <p:spPr>
             <a:xfrm>
-              <a:off x="1447800" y="2374900"/>
+              <a:off x="1447800" y="2387600"/>
               <a:ext cx="1168400" cy="787400"/>
             </a:xfrm>
             <a:prstGeom prst="triangle">
               <a:avLst/>
             </a:prstGeom>
             <a:solidFill>
-              <a:srgbClr val="C25FB1"/>
+              <a:srgbClr val="7D50AA"/>
             </a:solidFill>
-            <a:ln>
+            <a:ln w="12700">
               <a:solidFill>
-                <a:srgbClr val="69215E"/>
+                <a:srgbClr val="323232"/>
               </a:solidFill>
             </a:ln>
           </p:spPr>
@@ -3585,20 +3580,17 @@
             <a:lstStyle/>
             <a:p>
               <a:pPr algn="ctr"/>
-              <a:r>
-                <a:rPr lang="en-US" sz="1400"/>
-                <a:t>C</a:t>
-              </a:r>
+              <a:endParaRPr lang="en-US"/>
             </a:p>
           </p:txBody>
         </p:sp>
       </p:grpSp>
       <p:sp>
         <p:nvSpPr>
-          <p:cNvPr id="8" name="TextBox 7">
-            <a:extLst>
-              <a:ext uri="{FF2B5EF4-FFF2-40B4-BE49-F238E27FC236}">
-                <a16:creationId xmlns:a16="http://schemas.microsoft.com/office/drawing/2014/main" id="{D2311652-763A-1754-2EEA-5812C3FD6550}"/>
+          <p:cNvPr id="8" name="label flipH">
+            <a:extLst>
+              <a:ext uri="{FF2B5EF4-FFF2-40B4-BE49-F238E27FC236}">
+                <a16:creationId xmlns:a16="http://schemas.microsoft.com/office/drawing/2014/main" id="{B72C9FD3-A108-B497-8C52-2524BA65E9F6}"/>
               </a:ext>
             </a:extLst>
           </p:cNvPr>
@@ -3607,8 +3599,8 @@
         </p:nvSpPr>
         <p:spPr>
           <a:xfrm>
-            <a:off x="4635500" y="850900"/>
-            <a:ext cx="2667000" cy="246221"/>
+            <a:off x="3810000" y="889000"/>
+            <a:ext cx="2603500" cy="230832"/>
           </a:xfrm>
           <a:prstGeom prst="rect">
             <a:avLst/>
@@ -3622,8 +3614,10 @@
           <a:lstStyle/>
           <a:p>
             <a:r>
-              <a:rPr lang="en-US" sz="1000">
-                <a:latin typeface="Aptos" panose="020B0004020202020204" pitchFamily="34" charset="0"/>
+              <a:rPr lang="en-US" sz="900">
+                <a:solidFill>
+                  <a:srgbClr val="282828"/>
+                </a:solidFill>
               </a:rPr>
               <a:t>flipH</a:t>
             </a:r>
@@ -3635,18 +3629,20 @@
           <p:cNvPr id="12" name="flipH">
             <a:extLst>
               <a:ext uri="{FF2B5EF4-FFF2-40B4-BE49-F238E27FC236}">
-                <a16:creationId xmlns:a16="http://schemas.microsoft.com/office/drawing/2014/main" id="{542DEFC9-5B83-0E6C-587D-E748CDE2FD24}"/>
-              </a:ext>
-            </a:extLst>
-          </p:cNvPr>
-          <p:cNvGrpSpPr/>
+                <a16:creationId xmlns:a16="http://schemas.microsoft.com/office/drawing/2014/main" id="{C58F42F5-628B-7D7D-B22B-4F3B79B46719}"/>
+              </a:ext>
+            </a:extLst>
+          </p:cNvPr>
+          <p:cNvGrpSpPr>
+            <a:grpSpLocks/>
+          </p:cNvGrpSpPr>
           <p:nvPr/>
         </p:nvGrpSpPr>
         <p:grpSpPr>
           <a:xfrm flipH="1">
-            <a:off x="4635500" y="1206500"/>
+            <a:off x="3810000" y="1219200"/>
             <a:ext cx="2336800" cy="1955800"/>
-            <a:chOff x="4635500" y="1206500"/>
+            <a:chOff x="3810000" y="1219200"/>
             <a:chExt cx="2336800" cy="1955800"/>
           </a:xfrm>
         </p:grpSpPr>
@@ -3655,7 +3651,7 @@
             <p:cNvPr id="9" name="flipH child blue rect">
               <a:extLst>
                 <a:ext uri="{FF2B5EF4-FFF2-40B4-BE49-F238E27FC236}">
-                  <a16:creationId xmlns:a16="http://schemas.microsoft.com/office/drawing/2014/main" id="{ACEDDEF8-39ED-A7D9-79C2-D5492BEFFDCF}"/>
+                  <a16:creationId xmlns:a16="http://schemas.microsoft.com/office/drawing/2014/main" id="{0AA89AC1-4103-9665-C6E2-310AE4E4B8D7}"/>
                 </a:ext>
               </a:extLst>
             </p:cNvPr>
@@ -3664,18 +3660,18 @@
           </p:nvSpPr>
           <p:spPr>
             <a:xfrm>
-              <a:off x="4635500" y="1206500"/>
+              <a:off x="3810000" y="1219200"/>
               <a:ext cx="1219200" cy="609600"/>
             </a:xfrm>
             <a:prstGeom prst="rect">
               <a:avLst/>
             </a:prstGeom>
             <a:solidFill>
-              <a:srgbClr val="3F95D9"/>
+              <a:srgbClr val="4375CD"/>
             </a:solidFill>
-            <a:ln>
+            <a:ln w="12700">
               <a:solidFill>
-                <a:srgbClr val="004B7A"/>
+                <a:srgbClr val="323232"/>
               </a:solidFill>
             </a:ln>
           </p:spPr>
@@ -3700,10 +3696,7 @@
             <a:lstStyle/>
             <a:p>
               <a:pPr algn="ctr"/>
-              <a:r>
-                <a:rPr lang="en-US" sz="1400"/>
-                <a:t>A</a:t>
-              </a:r>
+              <a:endParaRPr lang="en-US"/>
             </a:p>
           </p:txBody>
         </p:sp>
@@ -3712,7 +3705,7 @@
             <p:cNvPr id="10" name="flipH child green oval">
               <a:extLst>
                 <a:ext uri="{FF2B5EF4-FFF2-40B4-BE49-F238E27FC236}">
-                  <a16:creationId xmlns:a16="http://schemas.microsoft.com/office/drawing/2014/main" id="{22AB09C7-B29B-7312-BCFC-863E141B1E5E}"/>
+                  <a16:creationId xmlns:a16="http://schemas.microsoft.com/office/drawing/2014/main" id="{6F51633F-7E9A-8D8E-FC8F-00F57122A7D8}"/>
                 </a:ext>
               </a:extLst>
             </p:cNvPr>
@@ -3721,18 +3714,18 @@
           </p:nvSpPr>
           <p:spPr>
             <a:xfrm>
-              <a:off x="6235700" y="1689100"/>
+              <a:off x="5410200" y="1701800"/>
               <a:ext cx="736600" cy="736600"/>
             </a:xfrm>
             <a:prstGeom prst="ellipse">
               <a:avLst/>
             </a:prstGeom>
             <a:solidFill>
-              <a:srgbClr val="32A865"/>
+              <a:srgbClr val="50A05A"/>
             </a:solidFill>
-            <a:ln>
+            <a:ln w="12700">
               <a:solidFill>
-                <a:srgbClr val="225522"/>
+                <a:srgbClr val="323232"/>
               </a:solidFill>
             </a:ln>
           </p:spPr>
@@ -3757,10 +3750,7 @@
             <a:lstStyle/>
             <a:p>
               <a:pPr algn="ctr"/>
-              <a:r>
-                <a:rPr lang="en-US" sz="1400"/>
-                <a:t>B</a:t>
-              </a:r>
+              <a:endParaRPr lang="en-US"/>
             </a:p>
           </p:txBody>
         </p:sp>
@@ -3769,7 +3759,7 @@
             <p:cNvPr id="11" name="flipH child purple triangle">
               <a:extLst>
                 <a:ext uri="{FF2B5EF4-FFF2-40B4-BE49-F238E27FC236}">
-                  <a16:creationId xmlns:a16="http://schemas.microsoft.com/office/drawing/2014/main" id="{E67ACAE3-F74C-B9AD-2372-F58E589AEB55}"/>
+                  <a16:creationId xmlns:a16="http://schemas.microsoft.com/office/drawing/2014/main" id="{86C8A514-BE8A-4854-4321-C9DB10E1B333}"/>
                 </a:ext>
               </a:extLst>
             </p:cNvPr>
@@ -3778,18 +3768,18 @@
           </p:nvSpPr>
           <p:spPr>
             <a:xfrm>
-              <a:off x="5194300" y="2374900"/>
+              <a:off x="4368800" y="2387600"/>
               <a:ext cx="1168400" cy="787400"/>
             </a:xfrm>
             <a:prstGeom prst="triangle">
               <a:avLst/>
             </a:prstGeom>
             <a:solidFill>
-              <a:srgbClr val="C25FB1"/>
+              <a:srgbClr val="7D50AA"/>
             </a:solidFill>
-            <a:ln>
+            <a:ln w="12700">
               <a:solidFill>
-                <a:srgbClr val="69215E"/>
+                <a:srgbClr val="323232"/>
               </a:solidFill>
             </a:ln>
           </p:spPr>
@@ -3814,20 +3804,17 @@
             <a:lstStyle/>
             <a:p>
               <a:pPr algn="ctr"/>
-              <a:r>
-                <a:rPr lang="en-US" sz="1400"/>
-                <a:t>C</a:t>
-              </a:r>
+              <a:endParaRPr lang="en-US"/>
             </a:p>
           </p:txBody>
         </p:sp>
       </p:grpSp>
       <p:sp>
         <p:nvSpPr>
-          <p:cNvPr id="13" name="TextBox 12">
-            <a:extLst>
-              <a:ext uri="{FF2B5EF4-FFF2-40B4-BE49-F238E27FC236}">
-                <a16:creationId xmlns:a16="http://schemas.microsoft.com/office/drawing/2014/main" id="{0DBDF40C-2CC2-7F90-6D09-BD5A33C85E56}"/>
+          <p:cNvPr id="13" name="label flipV">
+            <a:extLst>
+              <a:ext uri="{FF2B5EF4-FFF2-40B4-BE49-F238E27FC236}">
+                <a16:creationId xmlns:a16="http://schemas.microsoft.com/office/drawing/2014/main" id="{F04B2CDB-70BF-A16E-B916-2A0ECB185E95}"/>
               </a:ext>
             </a:extLst>
           </p:cNvPr>
@@ -3836,8 +3823,8 @@
         </p:nvSpPr>
         <p:spPr>
           <a:xfrm>
-            <a:off x="8382000" y="850900"/>
-            <a:ext cx="2667000" cy="246221"/>
+            <a:off x="6731000" y="889000"/>
+            <a:ext cx="2603500" cy="230832"/>
           </a:xfrm>
           <a:prstGeom prst="rect">
             <a:avLst/>
@@ -3851,8 +3838,10 @@
           <a:lstStyle/>
           <a:p>
             <a:r>
-              <a:rPr lang="en-US" sz="1000">
-                <a:latin typeface="Aptos" panose="020B0004020202020204" pitchFamily="34" charset="0"/>
+              <a:rPr lang="en-US" sz="900">
+                <a:solidFill>
+                  <a:srgbClr val="282828"/>
+                </a:solidFill>
               </a:rPr>
               <a:t>flipV</a:t>
             </a:r>
@@ -3864,18 +3853,20 @@
           <p:cNvPr id="17" name="flipV">
             <a:extLst>
               <a:ext uri="{FF2B5EF4-FFF2-40B4-BE49-F238E27FC236}">
-                <a16:creationId xmlns:a16="http://schemas.microsoft.com/office/drawing/2014/main" id="{BCE22EB4-138D-90DC-6C9B-E825DCB1D793}"/>
-              </a:ext>
-            </a:extLst>
-          </p:cNvPr>
-          <p:cNvGrpSpPr/>
+                <a16:creationId xmlns:a16="http://schemas.microsoft.com/office/drawing/2014/main" id="{BAA7EE35-0147-1973-402E-8FEF469B9ECC}"/>
+              </a:ext>
+            </a:extLst>
+          </p:cNvPr>
+          <p:cNvGrpSpPr>
+            <a:grpSpLocks/>
+          </p:cNvGrpSpPr>
           <p:nvPr/>
         </p:nvGrpSpPr>
         <p:grpSpPr>
           <a:xfrm flipV="1">
-            <a:off x="8382000" y="1206500"/>
+            <a:off x="6731000" y="1219200"/>
             <a:ext cx="2336800" cy="1955800"/>
-            <a:chOff x="8382000" y="1206500"/>
+            <a:chOff x="6731000" y="1219200"/>
             <a:chExt cx="2336800" cy="1955800"/>
           </a:xfrm>
         </p:grpSpPr>
@@ -3884,7 +3875,7 @@
             <p:cNvPr id="14" name="flipV child blue rect">
               <a:extLst>
                 <a:ext uri="{FF2B5EF4-FFF2-40B4-BE49-F238E27FC236}">
-                  <a16:creationId xmlns:a16="http://schemas.microsoft.com/office/drawing/2014/main" id="{97411D60-6256-9DBC-A401-C54153057FDB}"/>
+                  <a16:creationId xmlns:a16="http://schemas.microsoft.com/office/drawing/2014/main" id="{9B90309D-1264-C229-D815-67A954FA6E96}"/>
                 </a:ext>
               </a:extLst>
             </p:cNvPr>
@@ -3893,18 +3884,18 @@
           </p:nvSpPr>
           <p:spPr>
             <a:xfrm>
-              <a:off x="8382000" y="1206500"/>
+              <a:off x="6731000" y="1219200"/>
               <a:ext cx="1219200" cy="609600"/>
             </a:xfrm>
             <a:prstGeom prst="rect">
               <a:avLst/>
             </a:prstGeom>
             <a:solidFill>
-              <a:srgbClr val="3F95D9"/>
+              <a:srgbClr val="4375CD"/>
             </a:solidFill>
-            <a:ln>
+            <a:ln w="12700">
               <a:solidFill>
-                <a:srgbClr val="004B7A"/>
+                <a:srgbClr val="323232"/>
               </a:solidFill>
             </a:ln>
           </p:spPr>
@@ -3929,10 +3920,7 @@
             <a:lstStyle/>
             <a:p>
               <a:pPr algn="ctr"/>
-              <a:r>
-                <a:rPr lang="en-US" sz="1400"/>
-                <a:t>A</a:t>
-              </a:r>
+              <a:endParaRPr lang="en-US"/>
             </a:p>
           </p:txBody>
         </p:sp>
@@ -3941,7 +3929,7 @@
             <p:cNvPr id="15" name="flipV child green oval">
               <a:extLst>
                 <a:ext uri="{FF2B5EF4-FFF2-40B4-BE49-F238E27FC236}">
-                  <a16:creationId xmlns:a16="http://schemas.microsoft.com/office/drawing/2014/main" id="{7FA854AB-946A-137D-6E09-BAF668F9DB6D}"/>
+                  <a16:creationId xmlns:a16="http://schemas.microsoft.com/office/drawing/2014/main" id="{0521ED0D-EA86-6594-EEBA-BD245765A6B8}"/>
                 </a:ext>
               </a:extLst>
             </p:cNvPr>
@@ -3950,18 +3938,18 @@
           </p:nvSpPr>
           <p:spPr>
             <a:xfrm>
-              <a:off x="9982200" y="1689100"/>
+              <a:off x="8331200" y="1701800"/>
               <a:ext cx="736600" cy="736600"/>
             </a:xfrm>
             <a:prstGeom prst="ellipse">
               <a:avLst/>
             </a:prstGeom>
             <a:solidFill>
-              <a:srgbClr val="32A865"/>
+              <a:srgbClr val="50A05A"/>
             </a:solidFill>
-            <a:ln>
+            <a:ln w="12700">
               <a:solidFill>
-                <a:srgbClr val="225522"/>
+                <a:srgbClr val="323232"/>
               </a:solidFill>
             </a:ln>
           </p:spPr>
@@ -3986,10 +3974,7 @@
             <a:lstStyle/>
             <a:p>
               <a:pPr algn="ctr"/>
-              <a:r>
-                <a:rPr lang="en-US" sz="1400"/>
-                <a:t>B</a:t>
-              </a:r>
+              <a:endParaRPr lang="en-US"/>
             </a:p>
           </p:txBody>
         </p:sp>
@@ -3998,7 +3983,7 @@
             <p:cNvPr id="16" name="flipV child purple triangle">
               <a:extLst>
                 <a:ext uri="{FF2B5EF4-FFF2-40B4-BE49-F238E27FC236}">
-                  <a16:creationId xmlns:a16="http://schemas.microsoft.com/office/drawing/2014/main" id="{5E25060E-D50D-8F9A-DF57-393ACA1C57C9}"/>
+                  <a16:creationId xmlns:a16="http://schemas.microsoft.com/office/drawing/2014/main" id="{9EE54A7A-23DA-E5A9-F0ED-3443D26F25B2}"/>
                 </a:ext>
               </a:extLst>
             </p:cNvPr>
@@ -4007,18 +3992,18 @@
           </p:nvSpPr>
           <p:spPr>
             <a:xfrm>
-              <a:off x="8940800" y="2374900"/>
+              <a:off x="7289800" y="2387600"/>
               <a:ext cx="1168400" cy="787400"/>
             </a:xfrm>
             <a:prstGeom prst="triangle">
               <a:avLst/>
             </a:prstGeom>
             <a:solidFill>
-              <a:srgbClr val="C25FB1"/>
+              <a:srgbClr val="7D50AA"/>
             </a:solidFill>
-            <a:ln>
+            <a:ln w="12700">
               <a:solidFill>
-                <a:srgbClr val="69215E"/>
+                <a:srgbClr val="323232"/>
               </a:solidFill>
             </a:ln>
           </p:spPr>
@@ -4043,20 +4028,17 @@
             <a:lstStyle/>
             <a:p>
               <a:pPr algn="ctr"/>
-              <a:r>
-                <a:rPr lang="en-US" sz="1400"/>
-                <a:t>C</a:t>
-              </a:r>
+              <a:endParaRPr lang="en-US"/>
             </a:p>
           </p:txBody>
         </p:sp>
       </p:grpSp>
       <p:sp>
         <p:nvSpPr>
-          <p:cNvPr id="18" name="TextBox 17">
-            <a:extLst>
-              <a:ext uri="{FF2B5EF4-FFF2-40B4-BE49-F238E27FC236}">
-                <a16:creationId xmlns:a16="http://schemas.microsoft.com/office/drawing/2014/main" id="{E00AC11B-92EF-CDCF-A447-560552FBA89D}"/>
+          <p:cNvPr id="18" name="label rot330-flipHV">
+            <a:extLst>
+              <a:ext uri="{FF2B5EF4-FFF2-40B4-BE49-F238E27FC236}">
+                <a16:creationId xmlns:a16="http://schemas.microsoft.com/office/drawing/2014/main" id="{4DFACB0D-65DE-2A9B-ED1B-BE3E0215B97C}"/>
               </a:ext>
             </a:extLst>
           </p:cNvPr>
@@ -4065,8 +4047,8 @@
         </p:nvSpPr>
         <p:spPr>
           <a:xfrm>
-            <a:off x="4445000" y="3898900"/>
-            <a:ext cx="2667000" cy="246221"/>
+            <a:off x="9525000" y="889000"/>
+            <a:ext cx="2603500" cy="230832"/>
           </a:xfrm>
           <a:prstGeom prst="rect">
             <a:avLst/>
@@ -4080,8 +4062,10 @@
           <a:lstStyle/>
           <a:p>
             <a:r>
-              <a:rPr lang="en-US" sz="1000">
-                <a:latin typeface="Aptos" panose="020B0004020202020204" pitchFamily="34" charset="0"/>
+              <a:rPr lang="en-US" sz="900">
+                <a:solidFill>
+                  <a:srgbClr val="282828"/>
+                </a:solidFill>
               </a:rPr>
               <a:t>rot330-flipHV</a:t>
             </a:r>
@@ -4093,18 +4077,20 @@
           <p:cNvPr id="22" name="rot330-flipHV">
             <a:extLst>
               <a:ext uri="{FF2B5EF4-FFF2-40B4-BE49-F238E27FC236}">
-                <a16:creationId xmlns:a16="http://schemas.microsoft.com/office/drawing/2014/main" id="{2FB2423B-93B6-AB4B-0E66-646367B4956E}"/>
-              </a:ext>
-            </a:extLst>
-          </p:cNvPr>
-          <p:cNvGrpSpPr/>
+                <a16:creationId xmlns:a16="http://schemas.microsoft.com/office/drawing/2014/main" id="{45F2F034-2479-BEC1-77D4-7D90884FEAF7}"/>
+              </a:ext>
+            </a:extLst>
+          </p:cNvPr>
+          <p:cNvGrpSpPr>
+            <a:grpSpLocks/>
+          </p:cNvGrpSpPr>
           <p:nvPr/>
         </p:nvGrpSpPr>
         <p:grpSpPr>
           <a:xfrm rot="19800000" flipH="1" flipV="1">
-            <a:off x="4445000" y="4254500"/>
+            <a:off x="9525000" y="1219200"/>
             <a:ext cx="2336800" cy="1955800"/>
-            <a:chOff x="4445000" y="4254500"/>
+            <a:chOff x="9525000" y="1219200"/>
             <a:chExt cx="2336800" cy="1955800"/>
           </a:xfrm>
         </p:grpSpPr>
@@ -4113,7 +4099,7 @@
             <p:cNvPr id="19" name="rot330-flipHV child blue rect">
               <a:extLst>
                 <a:ext uri="{FF2B5EF4-FFF2-40B4-BE49-F238E27FC236}">
-                  <a16:creationId xmlns:a16="http://schemas.microsoft.com/office/drawing/2014/main" id="{9BB0E20F-8E09-A14A-3C87-94382C0102D0}"/>
+                  <a16:creationId xmlns:a16="http://schemas.microsoft.com/office/drawing/2014/main" id="{9BFE9F96-61F5-90B6-23CA-B0D8573C13A5}"/>
                 </a:ext>
               </a:extLst>
             </p:cNvPr>
@@ -4122,18 +4108,18 @@
           </p:nvSpPr>
           <p:spPr>
             <a:xfrm>
-              <a:off x="4445000" y="4254500"/>
+              <a:off x="9525000" y="1219200"/>
               <a:ext cx="1219200" cy="609600"/>
             </a:xfrm>
             <a:prstGeom prst="rect">
               <a:avLst/>
             </a:prstGeom>
             <a:solidFill>
-              <a:srgbClr val="3F95D9"/>
+              <a:srgbClr val="4375CD"/>
             </a:solidFill>
-            <a:ln>
+            <a:ln w="12700">
               <a:solidFill>
-                <a:srgbClr val="004B7A"/>
+                <a:srgbClr val="323232"/>
               </a:solidFill>
             </a:ln>
           </p:spPr>
@@ -4158,10 +4144,7 @@
             <a:lstStyle/>
             <a:p>
               <a:pPr algn="ctr"/>
-              <a:r>
-                <a:rPr lang="en-US" sz="1400"/>
-                <a:t>A</a:t>
-              </a:r>
+              <a:endParaRPr lang="en-US"/>
             </a:p>
           </p:txBody>
         </p:sp>
@@ -4170,7 +4153,7 @@
             <p:cNvPr id="20" name="rot330-flipHV child green oval">
               <a:extLst>
                 <a:ext uri="{FF2B5EF4-FFF2-40B4-BE49-F238E27FC236}">
-                  <a16:creationId xmlns:a16="http://schemas.microsoft.com/office/drawing/2014/main" id="{A72FCF45-C0B9-2C0A-3ACC-8C7AB6C790AB}"/>
+                  <a16:creationId xmlns:a16="http://schemas.microsoft.com/office/drawing/2014/main" id="{62FAE74A-29BA-CCBE-F0A3-B7A7E53354D8}"/>
                 </a:ext>
               </a:extLst>
             </p:cNvPr>
@@ -4179,18 +4162,18 @@
           </p:nvSpPr>
           <p:spPr>
             <a:xfrm>
-              <a:off x="6045200" y="4737100"/>
+              <a:off x="11125200" y="1701800"/>
               <a:ext cx="736600" cy="736600"/>
             </a:xfrm>
             <a:prstGeom prst="ellipse">
               <a:avLst/>
             </a:prstGeom>
             <a:solidFill>
-              <a:srgbClr val="32A865"/>
+              <a:srgbClr val="50A05A"/>
             </a:solidFill>
-            <a:ln>
+            <a:ln w="12700">
               <a:solidFill>
-                <a:srgbClr val="225522"/>
+                <a:srgbClr val="323232"/>
               </a:solidFill>
             </a:ln>
           </p:spPr>
@@ -4215,10 +4198,7 @@
             <a:lstStyle/>
             <a:p>
               <a:pPr algn="ctr"/>
-              <a:r>
-                <a:rPr lang="en-US" sz="1400"/>
-                <a:t>B</a:t>
-              </a:r>
+              <a:endParaRPr lang="en-US"/>
             </a:p>
           </p:txBody>
         </p:sp>
@@ -4227,7 +4207,7 @@
             <p:cNvPr id="21" name="rot330-flipHV child purple triangle">
               <a:extLst>
                 <a:ext uri="{FF2B5EF4-FFF2-40B4-BE49-F238E27FC236}">
-                  <a16:creationId xmlns:a16="http://schemas.microsoft.com/office/drawing/2014/main" id="{5B171739-31EC-00B3-18FF-8C6AF2B3BC36}"/>
+                  <a16:creationId xmlns:a16="http://schemas.microsoft.com/office/drawing/2014/main" id="{7AA0752B-C840-7284-8B99-DD8B3636A1C7}"/>
                 </a:ext>
               </a:extLst>
             </p:cNvPr>
@@ -4236,18 +4216,18 @@
           </p:nvSpPr>
           <p:spPr>
             <a:xfrm>
-              <a:off x="5003800" y="5422900"/>
+              <a:off x="10083800" y="2387600"/>
               <a:ext cx="1168400" cy="787400"/>
             </a:xfrm>
             <a:prstGeom prst="triangle">
               <a:avLst/>
             </a:prstGeom>
             <a:solidFill>
-              <a:srgbClr val="C25FB1"/>
+              <a:srgbClr val="7D50AA"/>
             </a:solidFill>
-            <a:ln>
+            <a:ln w="12700">
               <a:solidFill>
-                <a:srgbClr val="69215E"/>
+                <a:srgbClr val="323232"/>
               </a:solidFill>
             </a:ln>
           </p:spPr>
@@ -4272,20 +4252,17 @@
             <a:lstStyle/>
             <a:p>
               <a:pPr algn="ctr"/>
-              <a:r>
-                <a:rPr lang="en-US" sz="1400"/>
-                <a:t>C</a:t>
-              </a:r>
+              <a:endParaRPr lang="en-US"/>
             </a:p>
           </p:txBody>
         </p:sp>
       </p:grpSp>
       <p:sp>
         <p:nvSpPr>
-          <p:cNvPr id="23" name="TextBox 22">
-            <a:extLst>
-              <a:ext uri="{FF2B5EF4-FFF2-40B4-BE49-F238E27FC236}">
-                <a16:creationId xmlns:a16="http://schemas.microsoft.com/office/drawing/2014/main" id="{6D0936B8-8BA1-5BC4-E1A9-4FB54E5A9B3D}"/>
+          <p:cNvPr id="23" name="label scale-rot">
+            <a:extLst>
+              <a:ext uri="{FF2B5EF4-FFF2-40B4-BE49-F238E27FC236}">
+                <a16:creationId xmlns:a16="http://schemas.microsoft.com/office/drawing/2014/main" id="{DFCFFC2E-E95A-5059-3B3F-E3C1122099EC}"/>
               </a:ext>
             </a:extLst>
           </p:cNvPr>
@@ -4294,8 +4271,8 @@
         </p:nvSpPr>
         <p:spPr>
           <a:xfrm>
-            <a:off x="304800" y="6350000"/>
-            <a:ext cx="11176000" cy="230832"/>
+            <a:off x="889000" y="4051300"/>
+            <a:ext cx="2603500" cy="230832"/>
           </a:xfrm>
           <a:prstGeom prst="rect">
             <a:avLst/>
@@ -4310,17 +4287,671 @@
           <a:p>
             <a:r>
               <a:rPr lang="en-US" sz="900">
-                <a:latin typeface="Aptos" panose="020B0004020202020204" pitchFamily="34" charset="0"/>
+                <a:solidFill>
+                  <a:srgbClr val="282828"/>
+                </a:solidFill>
               </a:rPr>
-              <a:t>Fixture intent: child absolute frames must account for enclosing group rot/flipH/flipV, not only off/ext scaling.</a:t>
-            </a:r>
-          </a:p>
-        </p:txBody>
-      </p:sp>
+              <a:t>scale-rot</a:t>
+            </a:r>
+          </a:p>
+        </p:txBody>
+      </p:sp>
+      <p:grpSp>
+        <p:nvGrpSpPr>
+          <p:cNvPr id="27" name="scale-rot">
+            <a:extLst>
+              <a:ext uri="{FF2B5EF4-FFF2-40B4-BE49-F238E27FC236}">
+                <a16:creationId xmlns:a16="http://schemas.microsoft.com/office/drawing/2014/main" id="{A1ACE517-32AB-FBB1-A67B-13D56E7842CA}"/>
+              </a:ext>
+            </a:extLst>
+          </p:cNvPr>
+          <p:cNvGrpSpPr>
+            <a:grpSpLocks/>
+          </p:cNvGrpSpPr>
+          <p:nvPr/>
+        </p:nvGrpSpPr>
+        <p:grpSpPr>
+          <a:xfrm rot="1500000">
+            <a:off x="889000" y="4381500"/>
+            <a:ext cx="3084576" cy="1603756"/>
+            <a:chOff x="889000" y="4381500"/>
+            <a:chExt cx="2336800" cy="1955800"/>
+          </a:xfrm>
+        </p:grpSpPr>
+        <p:sp>
+          <p:nvSpPr>
+            <p:cNvPr id="24" name="scale-rot child blue rect">
+              <a:extLst>
+                <a:ext uri="{FF2B5EF4-FFF2-40B4-BE49-F238E27FC236}">
+                  <a16:creationId xmlns:a16="http://schemas.microsoft.com/office/drawing/2014/main" id="{4F8AD937-4934-A584-4443-F539EF7C46CC}"/>
+                </a:ext>
+              </a:extLst>
+            </p:cNvPr>
+            <p:cNvSpPr/>
+            <p:nvPr/>
+          </p:nvSpPr>
+          <p:spPr>
+            <a:xfrm>
+              <a:off x="889000" y="4381500"/>
+              <a:ext cx="1219200" cy="609600"/>
+            </a:xfrm>
+            <a:prstGeom prst="rect">
+              <a:avLst/>
+            </a:prstGeom>
+            <a:solidFill>
+              <a:srgbClr val="4375CD"/>
+            </a:solidFill>
+            <a:ln w="12700">
+              <a:solidFill>
+                <a:srgbClr val="323232"/>
+              </a:solidFill>
+            </a:ln>
+          </p:spPr>
+          <p:style>
+            <a:lnRef idx="2">
+              <a:schemeClr val="accent1">
+                <a:shade val="15000"/>
+              </a:schemeClr>
+            </a:lnRef>
+            <a:fillRef idx="1">
+              <a:schemeClr val="accent1"/>
+            </a:fillRef>
+            <a:effectRef idx="0">
+              <a:schemeClr val="accent1"/>
+            </a:effectRef>
+            <a:fontRef idx="minor">
+              <a:schemeClr val="lt1"/>
+            </a:fontRef>
+          </p:style>
+          <p:txBody>
+            <a:bodyPr rtlCol="0" anchor="ctr"/>
+            <a:lstStyle/>
+            <a:p>
+              <a:pPr algn="ctr"/>
+              <a:endParaRPr lang="en-US"/>
+            </a:p>
+          </p:txBody>
+        </p:sp>
+        <p:sp>
+          <p:nvSpPr>
+            <p:cNvPr id="25" name="scale-rot child green oval">
+              <a:extLst>
+                <a:ext uri="{FF2B5EF4-FFF2-40B4-BE49-F238E27FC236}">
+                  <a16:creationId xmlns:a16="http://schemas.microsoft.com/office/drawing/2014/main" id="{ECD1D6BC-1F80-8D59-3B62-D8461EB94BA3}"/>
+                </a:ext>
+              </a:extLst>
+            </p:cNvPr>
+            <p:cNvSpPr/>
+            <p:nvPr/>
+          </p:nvSpPr>
+          <p:spPr>
+            <a:xfrm>
+              <a:off x="2489200" y="4864100"/>
+              <a:ext cx="736600" cy="736600"/>
+            </a:xfrm>
+            <a:prstGeom prst="ellipse">
+              <a:avLst/>
+            </a:prstGeom>
+            <a:solidFill>
+              <a:srgbClr val="50A05A"/>
+            </a:solidFill>
+            <a:ln w="12700">
+              <a:solidFill>
+                <a:srgbClr val="323232"/>
+              </a:solidFill>
+            </a:ln>
+          </p:spPr>
+          <p:style>
+            <a:lnRef idx="2">
+              <a:schemeClr val="accent1">
+                <a:shade val="15000"/>
+              </a:schemeClr>
+            </a:lnRef>
+            <a:fillRef idx="1">
+              <a:schemeClr val="accent1"/>
+            </a:fillRef>
+            <a:effectRef idx="0">
+              <a:schemeClr val="accent1"/>
+            </a:effectRef>
+            <a:fontRef idx="minor">
+              <a:schemeClr val="lt1"/>
+            </a:fontRef>
+          </p:style>
+          <p:txBody>
+            <a:bodyPr rtlCol="0" anchor="ctr"/>
+            <a:lstStyle/>
+            <a:p>
+              <a:pPr algn="ctr"/>
+              <a:endParaRPr lang="en-US"/>
+            </a:p>
+          </p:txBody>
+        </p:sp>
+        <p:sp>
+          <p:nvSpPr>
+            <p:cNvPr id="26" name="scale-rot child purple triangle">
+              <a:extLst>
+                <a:ext uri="{FF2B5EF4-FFF2-40B4-BE49-F238E27FC236}">
+                  <a16:creationId xmlns:a16="http://schemas.microsoft.com/office/drawing/2014/main" id="{6D4FFC17-E5A1-FB07-15B4-847426ED6572}"/>
+                </a:ext>
+              </a:extLst>
+            </p:cNvPr>
+            <p:cNvSpPr/>
+            <p:nvPr/>
+          </p:nvSpPr>
+          <p:spPr>
+            <a:xfrm>
+              <a:off x="1447800" y="5549900"/>
+              <a:ext cx="1168400" cy="787400"/>
+            </a:xfrm>
+            <a:prstGeom prst="triangle">
+              <a:avLst/>
+            </a:prstGeom>
+            <a:solidFill>
+              <a:srgbClr val="7D50AA"/>
+            </a:solidFill>
+            <a:ln w="12700">
+              <a:solidFill>
+                <a:srgbClr val="323232"/>
+              </a:solidFill>
+            </a:ln>
+          </p:spPr>
+          <p:style>
+            <a:lnRef idx="2">
+              <a:schemeClr val="accent1">
+                <a:shade val="15000"/>
+              </a:schemeClr>
+            </a:lnRef>
+            <a:fillRef idx="1">
+              <a:schemeClr val="accent1"/>
+            </a:fillRef>
+            <a:effectRef idx="0">
+              <a:schemeClr val="accent1"/>
+            </a:effectRef>
+            <a:fontRef idx="minor">
+              <a:schemeClr val="lt1"/>
+            </a:fontRef>
+          </p:style>
+          <p:txBody>
+            <a:bodyPr rtlCol="0" anchor="ctr"/>
+            <a:lstStyle/>
+            <a:p>
+              <a:pPr algn="ctr"/>
+              <a:endParaRPr lang="en-US"/>
+            </a:p>
+          </p:txBody>
+        </p:sp>
+      </p:grpSp>
+      <p:sp>
+        <p:nvSpPr>
+          <p:cNvPr id="28" name="label childrot-in-rot">
+            <a:extLst>
+              <a:ext uri="{FF2B5EF4-FFF2-40B4-BE49-F238E27FC236}">
+                <a16:creationId xmlns:a16="http://schemas.microsoft.com/office/drawing/2014/main" id="{A8A48389-5D98-D065-BB9D-590BA4790173}"/>
+              </a:ext>
+            </a:extLst>
+          </p:cNvPr>
+          <p:cNvSpPr txBox="1"/>
+          <p:nvPr/>
+        </p:nvSpPr>
+        <p:spPr>
+          <a:xfrm>
+            <a:off x="4000500" y="4051300"/>
+            <a:ext cx="2603500" cy="230832"/>
+          </a:xfrm>
+          <a:prstGeom prst="rect">
+            <a:avLst/>
+          </a:prstGeom>
+          <a:noFill/>
+        </p:spPr>
+        <p:txBody>
+          <a:bodyPr vert="horz" rtlCol="0">
+            <a:spAutoFit/>
+          </a:bodyPr>
+          <a:lstStyle/>
+          <a:p>
+            <a:r>
+              <a:rPr lang="en-US" sz="900">
+                <a:solidFill>
+                  <a:srgbClr val="282828"/>
+                </a:solidFill>
+              </a:rPr>
+              <a:t>childrot-in-rot</a:t>
+            </a:r>
+          </a:p>
+        </p:txBody>
+      </p:sp>
+      <p:grpSp>
+        <p:nvGrpSpPr>
+          <p:cNvPr id="32" name="childrot-in-rot">
+            <a:extLst>
+              <a:ext uri="{FF2B5EF4-FFF2-40B4-BE49-F238E27FC236}">
+                <a16:creationId xmlns:a16="http://schemas.microsoft.com/office/drawing/2014/main" id="{AEC4EE4D-D0A0-435D-E387-43E2CBE0363E}"/>
+              </a:ext>
+            </a:extLst>
+          </p:cNvPr>
+          <p:cNvGrpSpPr/>
+          <p:nvPr/>
+        </p:nvGrpSpPr>
+        <p:grpSpPr>
+          <a:xfrm rot="2100000" flipV="1">
+            <a:off x="4000500" y="4381500"/>
+            <a:ext cx="2311400" cy="1930400"/>
+            <a:chOff x="4000500" y="4381500"/>
+            <a:chExt cx="2311400" cy="1930400"/>
+          </a:xfrm>
+        </p:grpSpPr>
+        <p:sp>
+          <p:nvSpPr>
+            <p:cNvPr id="29" name="childrot-in-rot child rot20 rect">
+              <a:extLst>
+                <a:ext uri="{FF2B5EF4-FFF2-40B4-BE49-F238E27FC236}">
+                  <a16:creationId xmlns:a16="http://schemas.microsoft.com/office/drawing/2014/main" id="{EA116F3B-DE3F-0684-412E-EBC045E784F2}"/>
+                </a:ext>
+              </a:extLst>
+            </p:cNvPr>
+            <p:cNvSpPr/>
+            <p:nvPr/>
+          </p:nvSpPr>
+          <p:spPr>
+            <a:xfrm rot="1200000">
+              <a:off x="4000500" y="4381500"/>
+              <a:ext cx="1143000" cy="609600"/>
+            </a:xfrm>
+            <a:prstGeom prst="rect">
+              <a:avLst/>
+            </a:prstGeom>
+            <a:solidFill>
+              <a:srgbClr val="DE7337"/>
+            </a:solidFill>
+            <a:ln w="12700">
+              <a:solidFill>
+                <a:srgbClr val="323232"/>
+              </a:solidFill>
+            </a:ln>
+          </p:spPr>
+          <p:style>
+            <a:lnRef idx="2">
+              <a:schemeClr val="accent1">
+                <a:shade val="15000"/>
+              </a:schemeClr>
+            </a:lnRef>
+            <a:fillRef idx="1">
+              <a:schemeClr val="accent1"/>
+            </a:fillRef>
+            <a:effectRef idx="0">
+              <a:schemeClr val="accent1"/>
+            </a:effectRef>
+            <a:fontRef idx="minor">
+              <a:schemeClr val="lt1"/>
+            </a:fontRef>
+          </p:style>
+          <p:txBody>
+            <a:bodyPr rtlCol="0" anchor="ctr"/>
+            <a:lstStyle/>
+            <a:p>
+              <a:pPr algn="ctr"/>
+              <a:endParaRPr lang="en-US"/>
+            </a:p>
+          </p:txBody>
+        </p:sp>
+        <p:sp>
+          <p:nvSpPr>
+            <p:cNvPr id="30" name="childrot-in-rot child flipH oval">
+              <a:extLst>
+                <a:ext uri="{FF2B5EF4-FFF2-40B4-BE49-F238E27FC236}">
+                  <a16:creationId xmlns:a16="http://schemas.microsoft.com/office/drawing/2014/main" id="{60CB8F02-EAC5-9869-19E0-8D5DFA390798}"/>
+                </a:ext>
+              </a:extLst>
+            </p:cNvPr>
+            <p:cNvSpPr/>
+            <p:nvPr/>
+          </p:nvSpPr>
+          <p:spPr>
+            <a:xfrm flipH="1">
+              <a:off x="5549900" y="4838700"/>
+              <a:ext cx="762000" cy="762000"/>
+            </a:xfrm>
+            <a:prstGeom prst="ellipse">
+              <a:avLst/>
+            </a:prstGeom>
+            <a:solidFill>
+              <a:srgbClr val="50A05A"/>
+            </a:solidFill>
+            <a:ln w="12700">
+              <a:solidFill>
+                <a:srgbClr val="323232"/>
+              </a:solidFill>
+            </a:ln>
+          </p:spPr>
+          <p:style>
+            <a:lnRef idx="2">
+              <a:schemeClr val="accent1">
+                <a:shade val="15000"/>
+              </a:schemeClr>
+            </a:lnRef>
+            <a:fillRef idx="1">
+              <a:schemeClr val="accent1"/>
+            </a:fillRef>
+            <a:effectRef idx="0">
+              <a:schemeClr val="accent1"/>
+            </a:effectRef>
+            <a:fontRef idx="minor">
+              <a:schemeClr val="lt1"/>
+            </a:fontRef>
+          </p:style>
+          <p:txBody>
+            <a:bodyPr rtlCol="0" anchor="ctr"/>
+            <a:lstStyle/>
+            <a:p>
+              <a:pPr algn="ctr"/>
+              <a:endParaRPr lang="en-US"/>
+            </a:p>
+          </p:txBody>
+        </p:sp>
+        <p:sp>
+          <p:nvSpPr>
+            <p:cNvPr id="31" name="childrot-in-rot child baseline triangle">
+              <a:extLst>
+                <a:ext uri="{FF2B5EF4-FFF2-40B4-BE49-F238E27FC236}">
+                  <a16:creationId xmlns:a16="http://schemas.microsoft.com/office/drawing/2014/main" id="{E0E77724-1483-6C18-9439-FFF942ED0024}"/>
+                </a:ext>
+              </a:extLst>
+            </p:cNvPr>
+            <p:cNvSpPr/>
+            <p:nvPr/>
+          </p:nvSpPr>
+          <p:spPr>
+            <a:xfrm>
+              <a:off x="4610100" y="5549900"/>
+              <a:ext cx="1143000" cy="762000"/>
+            </a:xfrm>
+            <a:prstGeom prst="triangle">
+              <a:avLst/>
+            </a:prstGeom>
+            <a:solidFill>
+              <a:srgbClr val="7D50AA"/>
+            </a:solidFill>
+            <a:ln w="12700">
+              <a:solidFill>
+                <a:srgbClr val="323232"/>
+              </a:solidFill>
+            </a:ln>
+          </p:spPr>
+          <p:style>
+            <a:lnRef idx="2">
+              <a:schemeClr val="accent1">
+                <a:shade val="15000"/>
+              </a:schemeClr>
+            </a:lnRef>
+            <a:fillRef idx="1">
+              <a:schemeClr val="accent1"/>
+            </a:fillRef>
+            <a:effectRef idx="0">
+              <a:schemeClr val="accent1"/>
+            </a:effectRef>
+            <a:fontRef idx="minor">
+              <a:schemeClr val="lt1"/>
+            </a:fontRef>
+          </p:style>
+          <p:txBody>
+            <a:bodyPr rtlCol="0" anchor="ctr"/>
+            <a:lstStyle/>
+            <a:p>
+              <a:pPr algn="ctr"/>
+              <a:endParaRPr lang="en-US"/>
+            </a:p>
+          </p:txBody>
+        </p:sp>
+      </p:grpSp>
+      <p:sp>
+        <p:nvSpPr>
+          <p:cNvPr id="33" name="label nested-rot-in-scale">
+            <a:extLst>
+              <a:ext uri="{FF2B5EF4-FFF2-40B4-BE49-F238E27FC236}">
+                <a16:creationId xmlns:a16="http://schemas.microsoft.com/office/drawing/2014/main" id="{B72DEC12-7232-8B4B-AC24-B6CF95B48B88}"/>
+              </a:ext>
+            </a:extLst>
+          </p:cNvPr>
+          <p:cNvSpPr txBox="1"/>
+          <p:nvPr/>
+        </p:nvSpPr>
+        <p:spPr>
+          <a:xfrm>
+            <a:off x="7429500" y="4051300"/>
+            <a:ext cx="2794000" cy="230832"/>
+          </a:xfrm>
+          <a:prstGeom prst="rect">
+            <a:avLst/>
+          </a:prstGeom>
+          <a:noFill/>
+        </p:spPr>
+        <p:txBody>
+          <a:bodyPr vert="horz" rtlCol="0">
+            <a:spAutoFit/>
+          </a:bodyPr>
+          <a:lstStyle/>
+          <a:p>
+            <a:r>
+              <a:rPr lang="en-US" sz="900">
+                <a:solidFill>
+                  <a:srgbClr val="282828"/>
+                </a:solidFill>
+              </a:rPr>
+              <a:t>nested-rot-in-scale</a:t>
+            </a:r>
+          </a:p>
+        </p:txBody>
+      </p:sp>
+      <p:grpSp>
+        <p:nvGrpSpPr>
+          <p:cNvPr id="38" name="nested-rot-in-scale">
+            <a:extLst>
+              <a:ext uri="{FF2B5EF4-FFF2-40B4-BE49-F238E27FC236}">
+                <a16:creationId xmlns:a16="http://schemas.microsoft.com/office/drawing/2014/main" id="{B5B2F344-ACB8-C003-F5DD-B4EBF3E1416B}"/>
+              </a:ext>
+            </a:extLst>
+          </p:cNvPr>
+          <p:cNvGrpSpPr>
+            <a:grpSpLocks/>
+          </p:cNvGrpSpPr>
+          <p:nvPr/>
+        </p:nvGrpSpPr>
+        <p:grpSpPr>
+          <a:xfrm rot="900000">
+            <a:off x="7429500" y="4381500"/>
+            <a:ext cx="2381250" cy="1603756"/>
+            <a:chOff x="7429500" y="4381500"/>
+            <a:chExt cx="1905000" cy="1955800"/>
+          </a:xfrm>
+        </p:grpSpPr>
+        <p:grpSp>
+          <p:nvGrpSpPr>
+            <p:cNvPr id="36" name="nested-rot-in-scale inner">
+              <a:extLst>
+                <a:ext uri="{FF2B5EF4-FFF2-40B4-BE49-F238E27FC236}">
+                  <a16:creationId xmlns:a16="http://schemas.microsoft.com/office/drawing/2014/main" id="{DA756E86-9D00-AD3B-D4F3-9C2858C56C02}"/>
+                </a:ext>
+              </a:extLst>
+            </p:cNvPr>
+            <p:cNvGrpSpPr/>
+            <p:nvPr/>
+          </p:nvGrpSpPr>
+          <p:grpSpPr>
+            <a:xfrm rot="1500000">
+              <a:off x="7429500" y="4381500"/>
+              <a:ext cx="1905000" cy="1092200"/>
+              <a:chOff x="7429500" y="4381500"/>
+              <a:chExt cx="1905000" cy="1092200"/>
+            </a:xfrm>
+          </p:grpSpPr>
+          <p:sp>
+            <p:nvSpPr>
+              <p:cNvPr id="34" name="nested-rot-in-scale child inner blue rect">
+                <a:extLst>
+                  <a:ext uri="{FF2B5EF4-FFF2-40B4-BE49-F238E27FC236}">
+                    <a16:creationId xmlns:a16="http://schemas.microsoft.com/office/drawing/2014/main" id="{8F25FB3D-B442-AABC-79EA-3CBF32D51DBC}"/>
+                  </a:ext>
+                </a:extLst>
+              </p:cNvPr>
+              <p:cNvSpPr/>
+              <p:nvPr/>
+            </p:nvSpPr>
+            <p:spPr>
+              <a:xfrm>
+                <a:off x="7429500" y="4381500"/>
+                <a:ext cx="1016000" cy="533400"/>
+              </a:xfrm>
+              <a:prstGeom prst="rect">
+                <a:avLst/>
+              </a:prstGeom>
+              <a:solidFill>
+                <a:srgbClr val="4375CD"/>
+              </a:solidFill>
+              <a:ln w="12700">
+                <a:solidFill>
+                  <a:srgbClr val="323232"/>
+                </a:solidFill>
+              </a:ln>
+            </p:spPr>
+            <p:style>
+              <a:lnRef idx="2">
+                <a:schemeClr val="accent1">
+                  <a:shade val="15000"/>
+                </a:schemeClr>
+              </a:lnRef>
+              <a:fillRef idx="1">
+                <a:schemeClr val="accent1"/>
+              </a:fillRef>
+              <a:effectRef idx="0">
+                <a:schemeClr val="accent1"/>
+              </a:effectRef>
+              <a:fontRef idx="minor">
+                <a:schemeClr val="lt1"/>
+              </a:fontRef>
+            </p:style>
+            <p:txBody>
+              <a:bodyPr rtlCol="0" anchor="ctr"/>
+              <a:lstStyle/>
+              <a:p>
+                <a:pPr algn="ctr"/>
+                <a:endParaRPr lang="en-US"/>
+              </a:p>
+            </p:txBody>
+          </p:sp>
+          <p:sp>
+            <p:nvSpPr>
+              <p:cNvPr id="35" name="nested-rot-in-scale child inner green oval">
+                <a:extLst>
+                  <a:ext uri="{FF2B5EF4-FFF2-40B4-BE49-F238E27FC236}">
+                    <a16:creationId xmlns:a16="http://schemas.microsoft.com/office/drawing/2014/main" id="{D5D1847A-102C-5101-5B2A-C4867C8510D7}"/>
+                  </a:ext>
+                </a:extLst>
+              </p:cNvPr>
+              <p:cNvSpPr/>
+              <p:nvPr/>
+            </p:nvSpPr>
+            <p:spPr>
+              <a:xfrm>
+                <a:off x="8648700" y="4787900"/>
+                <a:ext cx="685800" cy="685800"/>
+              </a:xfrm>
+              <a:prstGeom prst="ellipse">
+                <a:avLst/>
+              </a:prstGeom>
+              <a:solidFill>
+                <a:srgbClr val="50A05A"/>
+              </a:solidFill>
+              <a:ln w="12700">
+                <a:solidFill>
+                  <a:srgbClr val="323232"/>
+                </a:solidFill>
+              </a:ln>
+            </p:spPr>
+            <p:style>
+              <a:lnRef idx="2">
+                <a:schemeClr val="accent1">
+                  <a:shade val="15000"/>
+                </a:schemeClr>
+              </a:lnRef>
+              <a:fillRef idx="1">
+                <a:schemeClr val="accent1"/>
+              </a:fillRef>
+              <a:effectRef idx="0">
+                <a:schemeClr val="accent1"/>
+              </a:effectRef>
+              <a:fontRef idx="minor">
+                <a:schemeClr val="lt1"/>
+              </a:fontRef>
+            </p:style>
+            <p:txBody>
+              <a:bodyPr rtlCol="0" anchor="ctr"/>
+              <a:lstStyle/>
+              <a:p>
+                <a:pPr algn="ctr"/>
+                <a:endParaRPr lang="en-US"/>
+              </a:p>
+            </p:txBody>
+          </p:sp>
+        </p:grpSp>
+        <p:sp>
+          <p:nvSpPr>
+            <p:cNvPr id="37" name="nested-rot-in-scale child outer purple triangle">
+              <a:extLst>
+                <a:ext uri="{FF2B5EF4-FFF2-40B4-BE49-F238E27FC236}">
+                  <a16:creationId xmlns:a16="http://schemas.microsoft.com/office/drawing/2014/main" id="{48616D2D-1F5E-37EC-31B1-8C3F41B08110}"/>
+                </a:ext>
+              </a:extLst>
+            </p:cNvPr>
+            <p:cNvSpPr/>
+            <p:nvPr/>
+          </p:nvSpPr>
+          <p:spPr>
+            <a:xfrm>
+              <a:off x="8089900" y="5600700"/>
+              <a:ext cx="1066800" cy="736600"/>
+            </a:xfrm>
+            <a:prstGeom prst="triangle">
+              <a:avLst/>
+            </a:prstGeom>
+            <a:solidFill>
+              <a:srgbClr val="7D50AA"/>
+            </a:solidFill>
+            <a:ln w="12700">
+              <a:solidFill>
+                <a:srgbClr val="323232"/>
+              </a:solidFill>
+            </a:ln>
+          </p:spPr>
+          <p:style>
+            <a:lnRef idx="2">
+              <a:schemeClr val="accent1">
+                <a:shade val="15000"/>
+              </a:schemeClr>
+            </a:lnRef>
+            <a:fillRef idx="1">
+              <a:schemeClr val="accent1"/>
+            </a:fillRef>
+            <a:effectRef idx="0">
+              <a:schemeClr val="accent1"/>
+            </a:effectRef>
+            <a:fontRef idx="minor">
+              <a:schemeClr val="lt1"/>
+            </a:fontRef>
+          </p:style>
+          <p:txBody>
+            <a:bodyPr rtlCol="0" anchor="ctr"/>
+            <a:lstStyle/>
+            <a:p>
+              <a:pPr algn="ctr"/>
+              <a:endParaRPr lang="en-US"/>
+            </a:p>
+          </p:txBody>
+        </p:sp>
+      </p:grpSp>
     </p:spTree>
     <p:extLst>
       <p:ext uri="{BB962C8B-B14F-4D97-AF65-F5344CB8AC3E}">
-        <p14:creationId xmlns:p14="http://schemas.microsoft.com/office/powerpoint/2010/main" val="2349191783"/>
+        <p14:creationId xmlns:p14="http://schemas.microsoft.com/office/powerpoint/2010/main" val="4153882864"/>
       </p:ext>
     </p:extLst>
   </p:cSld>
@@ -4332,7 +4963,7 @@
 
 <file path=ppt/slides/slide2.xml><?xml version="1.0" encoding="utf-8"?>
 <p:sld xmlns:a="http://schemas.openxmlformats.org/drawingml/2006/main" xmlns:r="http://schemas.openxmlformats.org/officeDocument/2006/relationships" xmlns:p="http://schemas.openxmlformats.org/presentationml/2006/main">
-  <p:cSld name="group-transform-ungrouped">
+  <p:cSld>
     <p:spTree>
       <p:nvGrpSpPr>
         <p:cNvPr id="1" name=""/>
@@ -4349,10 +4980,10 @@
       </p:grpSpPr>
       <p:sp>
         <p:nvSpPr>
-          <p:cNvPr id="2" name="TextBox 1">
-            <a:extLst>
-              <a:ext uri="{FF2B5EF4-FFF2-40B4-BE49-F238E27FC236}">
-                <a16:creationId xmlns:a16="http://schemas.microsoft.com/office/drawing/2014/main" id="{65E2148E-E34D-70F4-F3C6-5BA4B5CEC6B7}"/>
+          <p:cNvPr id="2" name="label Grouped PowerPoint transforms; slide 2 is duplicated and ungrouped in PowerPoint">
+            <a:extLst>
+              <a:ext uri="{FF2B5EF4-FFF2-40B4-BE49-F238E27FC236}">
+                <a16:creationId xmlns:a16="http://schemas.microsoft.com/office/drawing/2014/main" id="{B0C0AF6F-B9CB-6633-E8E1-8A099E7740E5}"/>
               </a:ext>
             </a:extLst>
           </p:cNvPr>
@@ -4362,7 +4993,7 @@
         <p:spPr>
           <a:xfrm>
             <a:off x="304800" y="203200"/>
-            <a:ext cx="11430000" cy="338554"/>
+            <a:ext cx="11430000" cy="230832"/>
           </a:xfrm>
           <a:prstGeom prst="rect">
             <a:avLst/>
@@ -4376,20 +5007,22 @@
           <a:lstStyle/>
           <a:p>
             <a:r>
-              <a:rPr lang="en-US" sz="1600">
-                <a:latin typeface="Aptos" panose="020B0004020202020204" pitchFamily="34" charset="0"/>
+              <a:rPr lang="en-US" sz="900">
+                <a:solidFill>
+                  <a:srgbClr val="282828"/>
+                </a:solidFill>
               </a:rPr>
-              <a:t>PowerPoint-authored group transform fixture: same shapes ungrouped by PowerPoint</a:t>
-            </a:r>
-          </a:p>
-        </p:txBody>
-      </p:sp>
-      <p:sp>
-        <p:nvSpPr>
-          <p:cNvPr id="3" name="TextBox 2">
-            <a:extLst>
-              <a:ext uri="{FF2B5EF4-FFF2-40B4-BE49-F238E27FC236}">
-                <a16:creationId xmlns:a16="http://schemas.microsoft.com/office/drawing/2014/main" id="{C855E3B3-D906-3AFA-FC15-F98A633D147B}"/>
+              <a:t>Grouped PowerPoint transforms; slide 2 is duplicated and ungrouped in PowerPoint</a:t>
+            </a:r>
+          </a:p>
+        </p:txBody>
+      </p:sp>
+      <p:sp>
+        <p:nvSpPr>
+          <p:cNvPr id="3" name="label rot30">
+            <a:extLst>
+              <a:ext uri="{FF2B5EF4-FFF2-40B4-BE49-F238E27FC236}">
+                <a16:creationId xmlns:a16="http://schemas.microsoft.com/office/drawing/2014/main" id="{D2D0F98B-66FD-5AED-F280-DE247191E08B}"/>
               </a:ext>
             </a:extLst>
           </p:cNvPr>
@@ -4398,8 +5031,8 @@
         </p:nvSpPr>
         <p:spPr>
           <a:xfrm>
-            <a:off x="889000" y="850900"/>
-            <a:ext cx="2667000" cy="246221"/>
+            <a:off x="889000" y="889000"/>
+            <a:ext cx="2603500" cy="230832"/>
           </a:xfrm>
           <a:prstGeom prst="rect">
             <a:avLst/>
@@ -4413,8 +5046,10 @@
           <a:lstStyle/>
           <a:p>
             <a:r>
-              <a:rPr lang="en-US" sz="1000">
-                <a:latin typeface="Aptos" panose="020B0004020202020204" pitchFamily="34" charset="0"/>
+              <a:rPr lang="en-US" sz="900">
+                <a:solidFill>
+                  <a:srgbClr val="282828"/>
+                </a:solidFill>
               </a:rPr>
               <a:t>rot30</a:t>
             </a:r>
@@ -4426,7 +5061,7 @@
           <p:cNvPr id="4" name="rot30-ungrouped child blue rect">
             <a:extLst>
               <a:ext uri="{FF2B5EF4-FFF2-40B4-BE49-F238E27FC236}">
-                <a16:creationId xmlns:a16="http://schemas.microsoft.com/office/drawing/2014/main" id="{26E23C0F-C529-A01B-802A-2DFA1202F33E}"/>
+                <a16:creationId xmlns:a16="http://schemas.microsoft.com/office/drawing/2014/main" id="{30C2C588-F61C-72D1-E8CB-E0233C312860}"/>
               </a:ext>
             </a:extLst>
           </p:cNvPr>
@@ -4435,18 +5070,18 @@
         </p:nvSpPr>
         <p:spPr>
           <a:xfrm rot="1800000">
-            <a:off x="1300415" y="1017278"/>
+            <a:off x="1300415" y="1029978"/>
             <a:ext cx="1219200" cy="609600"/>
           </a:xfrm>
           <a:prstGeom prst="rect">
             <a:avLst/>
           </a:prstGeom>
           <a:solidFill>
-            <a:srgbClr val="3F95D9"/>
+            <a:srgbClr val="4375CD"/>
           </a:solidFill>
-          <a:ln>
+          <a:ln w="12700">
             <a:solidFill>
-              <a:srgbClr val="004B7A"/>
+              <a:srgbClr val="323232"/>
             </a:solidFill>
           </a:ln>
         </p:spPr>
@@ -4471,10 +5106,7 @@
           <a:lstStyle/>
           <a:p>
             <a:pPr algn="ctr"/>
-            <a:r>
-              <a:rPr lang="en-US" sz="1400"/>
-              <a:t>A</a:t>
-            </a:r>
+            <a:endParaRPr lang="en-US"/>
           </a:p>
         </p:txBody>
       </p:sp>
@@ -4483,7 +5115,7 @@
           <p:cNvPr id="5" name="rot30-ungrouped child green oval">
             <a:extLst>
               <a:ext uri="{FF2B5EF4-FFF2-40B4-BE49-F238E27FC236}">
-                <a16:creationId xmlns:a16="http://schemas.microsoft.com/office/drawing/2014/main" id="{E79BE68F-B5BA-730A-F387-77E645AFCB4F}"/>
+                <a16:creationId xmlns:a16="http://schemas.microsoft.com/office/drawing/2014/main" id="{04594D0F-94DC-5AEC-C64C-89B754D1891B}"/>
               </a:ext>
             </a:extLst>
           </p:cNvPr>
@@ -4492,18 +5124,18 @@
         </p:nvSpPr>
         <p:spPr>
           <a:xfrm rot="1800000">
-            <a:off x="2445507" y="2106165"/>
+            <a:off x="2445507" y="2118865"/>
             <a:ext cx="736600" cy="736600"/>
           </a:xfrm>
           <a:prstGeom prst="ellipse">
             <a:avLst/>
           </a:prstGeom>
           <a:solidFill>
-            <a:srgbClr val="32A865"/>
+            <a:srgbClr val="50A05A"/>
           </a:solidFill>
-          <a:ln>
+          <a:ln w="12700">
             <a:solidFill>
-              <a:srgbClr val="225522"/>
+              <a:srgbClr val="323232"/>
             </a:solidFill>
           </a:ln>
         </p:spPr>
@@ -4528,10 +5160,7 @@
           <a:lstStyle/>
           <a:p>
             <a:pPr algn="ctr"/>
-            <a:r>
-              <a:rPr lang="en-US" sz="1400"/>
-              <a:t>B</a:t>
-            </a:r>
+            <a:endParaRPr lang="en-US"/>
           </a:p>
         </p:txBody>
       </p:sp>
@@ -4540,7 +5169,7 @@
           <p:cNvPr id="6" name="rot30-ungrouped child purple triangle">
             <a:extLst>
               <a:ext uri="{FF2B5EF4-FFF2-40B4-BE49-F238E27FC236}">
-                <a16:creationId xmlns:a16="http://schemas.microsoft.com/office/drawing/2014/main" id="{76B87BD2-A84C-382B-82E8-926AB585440A}"/>
+                <a16:creationId xmlns:a16="http://schemas.microsoft.com/office/drawing/2014/main" id="{858E5148-BC63-7F95-196F-169BB06E100A}"/>
               </a:ext>
             </a:extLst>
           </p:cNvPr>
@@ -4549,18 +5178,18 @@
         </p:nvSpPr>
         <p:spPr>
           <a:xfrm rot="1800000">
-            <a:off x="1159103" y="2283932"/>
+            <a:off x="1159103" y="2296632"/>
             <a:ext cx="1168400" cy="787400"/>
           </a:xfrm>
           <a:prstGeom prst="triangle">
             <a:avLst/>
           </a:prstGeom>
           <a:solidFill>
-            <a:srgbClr val="C25FB1"/>
+            <a:srgbClr val="7D50AA"/>
           </a:solidFill>
-          <a:ln>
+          <a:ln w="12700">
             <a:solidFill>
-              <a:srgbClr val="69215E"/>
+              <a:srgbClr val="323232"/>
             </a:solidFill>
           </a:ln>
         </p:spPr>
@@ -4585,19 +5214,16 @@
           <a:lstStyle/>
           <a:p>
             <a:pPr algn="ctr"/>
-            <a:r>
-              <a:rPr lang="en-US" sz="1400"/>
-              <a:t>C</a:t>
-            </a:r>
-          </a:p>
-        </p:txBody>
-      </p:sp>
-      <p:sp>
-        <p:nvSpPr>
-          <p:cNvPr id="8" name="TextBox 7">
-            <a:extLst>
-              <a:ext uri="{FF2B5EF4-FFF2-40B4-BE49-F238E27FC236}">
-                <a16:creationId xmlns:a16="http://schemas.microsoft.com/office/drawing/2014/main" id="{D2311652-763A-1754-2EEA-5812C3FD6550}"/>
+            <a:endParaRPr lang="en-US"/>
+          </a:p>
+        </p:txBody>
+      </p:sp>
+      <p:sp>
+        <p:nvSpPr>
+          <p:cNvPr id="8" name="label flipH">
+            <a:extLst>
+              <a:ext uri="{FF2B5EF4-FFF2-40B4-BE49-F238E27FC236}">
+                <a16:creationId xmlns:a16="http://schemas.microsoft.com/office/drawing/2014/main" id="{B72C9FD3-A108-B497-8C52-2524BA65E9F6}"/>
               </a:ext>
             </a:extLst>
           </p:cNvPr>
@@ -4606,8 +5232,8 @@
         </p:nvSpPr>
         <p:spPr>
           <a:xfrm>
-            <a:off x="4635500" y="850900"/>
-            <a:ext cx="2667000" cy="246221"/>
+            <a:off x="3810000" y="889000"/>
+            <a:ext cx="2603500" cy="230832"/>
           </a:xfrm>
           <a:prstGeom prst="rect">
             <a:avLst/>
@@ -4621,8 +5247,10 @@
           <a:lstStyle/>
           <a:p>
             <a:r>
-              <a:rPr lang="en-US" sz="1000">
-                <a:latin typeface="Aptos" panose="020B0004020202020204" pitchFamily="34" charset="0"/>
+              <a:rPr lang="en-US" sz="900">
+                <a:solidFill>
+                  <a:srgbClr val="282828"/>
+                </a:solidFill>
               </a:rPr>
               <a:t>flipH</a:t>
             </a:r>
@@ -4634,7 +5262,7 @@
           <p:cNvPr id="9" name="flipH-ungrouped child blue rect">
             <a:extLst>
               <a:ext uri="{FF2B5EF4-FFF2-40B4-BE49-F238E27FC236}">
-                <a16:creationId xmlns:a16="http://schemas.microsoft.com/office/drawing/2014/main" id="{ACEDDEF8-39ED-A7D9-79C2-D5492BEFFDCF}"/>
+                <a16:creationId xmlns:a16="http://schemas.microsoft.com/office/drawing/2014/main" id="{0AA89AC1-4103-9665-C6E2-310AE4E4B8D7}"/>
               </a:ext>
             </a:extLst>
           </p:cNvPr>
@@ -4643,18 +5271,18 @@
         </p:nvSpPr>
         <p:spPr>
           <a:xfrm flipH="1">
-            <a:off x="5753100" y="1206500"/>
+            <a:off x="4927600" y="1219200"/>
             <a:ext cx="1219200" cy="609600"/>
           </a:xfrm>
           <a:prstGeom prst="rect">
             <a:avLst/>
           </a:prstGeom>
           <a:solidFill>
-            <a:srgbClr val="3F95D9"/>
+            <a:srgbClr val="4375CD"/>
           </a:solidFill>
-          <a:ln>
+          <a:ln w="12700">
             <a:solidFill>
-              <a:srgbClr val="004B7A"/>
+              <a:srgbClr val="323232"/>
             </a:solidFill>
           </a:ln>
         </p:spPr>
@@ -4679,10 +5307,7 @@
           <a:lstStyle/>
           <a:p>
             <a:pPr algn="ctr"/>
-            <a:r>
-              <a:rPr lang="en-US" sz="1400"/>
-              <a:t>A</a:t>
-            </a:r>
+            <a:endParaRPr lang="en-US"/>
           </a:p>
         </p:txBody>
       </p:sp>
@@ -4691,7 +5316,7 @@
           <p:cNvPr id="10" name="flipH-ungrouped child green oval">
             <a:extLst>
               <a:ext uri="{FF2B5EF4-FFF2-40B4-BE49-F238E27FC236}">
-                <a16:creationId xmlns:a16="http://schemas.microsoft.com/office/drawing/2014/main" id="{22AB09C7-B29B-7312-BCFC-863E141B1E5E}"/>
+                <a16:creationId xmlns:a16="http://schemas.microsoft.com/office/drawing/2014/main" id="{6F51633F-7E9A-8D8E-FC8F-00F57122A7D8}"/>
               </a:ext>
             </a:extLst>
           </p:cNvPr>
@@ -4700,18 +5325,18 @@
         </p:nvSpPr>
         <p:spPr>
           <a:xfrm flipH="1">
-            <a:off x="4635500" y="1689100"/>
+            <a:off x="3810000" y="1701800"/>
             <a:ext cx="736600" cy="736600"/>
           </a:xfrm>
           <a:prstGeom prst="ellipse">
             <a:avLst/>
           </a:prstGeom>
           <a:solidFill>
-            <a:srgbClr val="32A865"/>
+            <a:srgbClr val="50A05A"/>
           </a:solidFill>
-          <a:ln>
+          <a:ln w="12700">
             <a:solidFill>
-              <a:srgbClr val="225522"/>
+              <a:srgbClr val="323232"/>
             </a:solidFill>
           </a:ln>
         </p:spPr>
@@ -4736,10 +5361,7 @@
           <a:lstStyle/>
           <a:p>
             <a:pPr algn="ctr"/>
-            <a:r>
-              <a:rPr lang="en-US" sz="1400"/>
-              <a:t>B</a:t>
-            </a:r>
+            <a:endParaRPr lang="en-US"/>
           </a:p>
         </p:txBody>
       </p:sp>
@@ -4748,7 +5370,7 @@
           <p:cNvPr id="11" name="flipH-ungrouped child purple triangle">
             <a:extLst>
               <a:ext uri="{FF2B5EF4-FFF2-40B4-BE49-F238E27FC236}">
-                <a16:creationId xmlns:a16="http://schemas.microsoft.com/office/drawing/2014/main" id="{E67ACAE3-F74C-B9AD-2372-F58E589AEB55}"/>
+                <a16:creationId xmlns:a16="http://schemas.microsoft.com/office/drawing/2014/main" id="{86C8A514-BE8A-4854-4321-C9DB10E1B333}"/>
               </a:ext>
             </a:extLst>
           </p:cNvPr>
@@ -4757,18 +5379,18 @@
         </p:nvSpPr>
         <p:spPr>
           <a:xfrm flipH="1">
-            <a:off x="5245100" y="2374900"/>
+            <a:off x="4419600" y="2387600"/>
             <a:ext cx="1168400" cy="787400"/>
           </a:xfrm>
           <a:prstGeom prst="triangle">
             <a:avLst/>
           </a:prstGeom>
           <a:solidFill>
-            <a:srgbClr val="C25FB1"/>
+            <a:srgbClr val="7D50AA"/>
           </a:solidFill>
-          <a:ln>
+          <a:ln w="12700">
             <a:solidFill>
-              <a:srgbClr val="69215E"/>
+              <a:srgbClr val="323232"/>
             </a:solidFill>
           </a:ln>
         </p:spPr>
@@ -4793,19 +5415,16 @@
           <a:lstStyle/>
           <a:p>
             <a:pPr algn="ctr"/>
-            <a:r>
-              <a:rPr lang="en-US" sz="1400"/>
-              <a:t>C</a:t>
-            </a:r>
-          </a:p>
-        </p:txBody>
-      </p:sp>
-      <p:sp>
-        <p:nvSpPr>
-          <p:cNvPr id="13" name="TextBox 12">
-            <a:extLst>
-              <a:ext uri="{FF2B5EF4-FFF2-40B4-BE49-F238E27FC236}">
-                <a16:creationId xmlns:a16="http://schemas.microsoft.com/office/drawing/2014/main" id="{0DBDF40C-2CC2-7F90-6D09-BD5A33C85E56}"/>
+            <a:endParaRPr lang="en-US"/>
+          </a:p>
+        </p:txBody>
+      </p:sp>
+      <p:sp>
+        <p:nvSpPr>
+          <p:cNvPr id="13" name="label flipV">
+            <a:extLst>
+              <a:ext uri="{FF2B5EF4-FFF2-40B4-BE49-F238E27FC236}">
+                <a16:creationId xmlns:a16="http://schemas.microsoft.com/office/drawing/2014/main" id="{F04B2CDB-70BF-A16E-B916-2A0ECB185E95}"/>
               </a:ext>
             </a:extLst>
           </p:cNvPr>
@@ -4814,8 +5433,8 @@
         </p:nvSpPr>
         <p:spPr>
           <a:xfrm>
-            <a:off x="8382000" y="850900"/>
-            <a:ext cx="2667000" cy="246221"/>
+            <a:off x="6731000" y="889000"/>
+            <a:ext cx="2603500" cy="230832"/>
           </a:xfrm>
           <a:prstGeom prst="rect">
             <a:avLst/>
@@ -4829,8 +5448,10 @@
           <a:lstStyle/>
           <a:p>
             <a:r>
-              <a:rPr lang="en-US" sz="1000">
-                <a:latin typeface="Aptos" panose="020B0004020202020204" pitchFamily="34" charset="0"/>
+              <a:rPr lang="en-US" sz="900">
+                <a:solidFill>
+                  <a:srgbClr val="282828"/>
+                </a:solidFill>
               </a:rPr>
               <a:t>flipV</a:t>
             </a:r>
@@ -4842,7 +5463,7 @@
           <p:cNvPr id="14" name="flipV-ungrouped child blue rect">
             <a:extLst>
               <a:ext uri="{FF2B5EF4-FFF2-40B4-BE49-F238E27FC236}">
-                <a16:creationId xmlns:a16="http://schemas.microsoft.com/office/drawing/2014/main" id="{97411D60-6256-9DBC-A401-C54153057FDB}"/>
+                <a16:creationId xmlns:a16="http://schemas.microsoft.com/office/drawing/2014/main" id="{9B90309D-1264-C229-D815-67A954FA6E96}"/>
               </a:ext>
             </a:extLst>
           </p:cNvPr>
@@ -4851,18 +5472,18 @@
         </p:nvSpPr>
         <p:spPr>
           <a:xfrm flipV="1">
-            <a:off x="8382000" y="2552700"/>
+            <a:off x="6731000" y="2565400"/>
             <a:ext cx="1219200" cy="609600"/>
           </a:xfrm>
           <a:prstGeom prst="rect">
             <a:avLst/>
           </a:prstGeom>
           <a:solidFill>
-            <a:srgbClr val="3F95D9"/>
+            <a:srgbClr val="4375CD"/>
           </a:solidFill>
-          <a:ln>
+          <a:ln w="12700">
             <a:solidFill>
-              <a:srgbClr val="004B7A"/>
+              <a:srgbClr val="323232"/>
             </a:solidFill>
           </a:ln>
         </p:spPr>
@@ -4887,10 +5508,7 @@
           <a:lstStyle/>
           <a:p>
             <a:pPr algn="ctr"/>
-            <a:r>
-              <a:rPr lang="en-US" sz="1400"/>
-              <a:t>A</a:t>
-            </a:r>
+            <a:endParaRPr lang="en-US"/>
           </a:p>
         </p:txBody>
       </p:sp>
@@ -4899,7 +5517,7 @@
           <p:cNvPr id="15" name="flipV-ungrouped child green oval">
             <a:extLst>
               <a:ext uri="{FF2B5EF4-FFF2-40B4-BE49-F238E27FC236}">
-                <a16:creationId xmlns:a16="http://schemas.microsoft.com/office/drawing/2014/main" id="{7FA854AB-946A-137D-6E09-BAF668F9DB6D}"/>
+                <a16:creationId xmlns:a16="http://schemas.microsoft.com/office/drawing/2014/main" id="{0521ED0D-EA86-6594-EEBA-BD245765A6B8}"/>
               </a:ext>
             </a:extLst>
           </p:cNvPr>
@@ -4908,18 +5526,18 @@
         </p:nvSpPr>
         <p:spPr>
           <a:xfrm flipV="1">
-            <a:off x="9982200" y="1943100"/>
+            <a:off x="8331200" y="1955800"/>
             <a:ext cx="736600" cy="736600"/>
           </a:xfrm>
           <a:prstGeom prst="ellipse">
             <a:avLst/>
           </a:prstGeom>
           <a:solidFill>
-            <a:srgbClr val="32A865"/>
+            <a:srgbClr val="50A05A"/>
           </a:solidFill>
-          <a:ln>
+          <a:ln w="12700">
             <a:solidFill>
-              <a:srgbClr val="225522"/>
+              <a:srgbClr val="323232"/>
             </a:solidFill>
           </a:ln>
         </p:spPr>
@@ -4944,10 +5562,7 @@
           <a:lstStyle/>
           <a:p>
             <a:pPr algn="ctr"/>
-            <a:r>
-              <a:rPr lang="en-US" sz="1400"/>
-              <a:t>B</a:t>
-            </a:r>
+            <a:endParaRPr lang="en-US"/>
           </a:p>
         </p:txBody>
       </p:sp>
@@ -4956,7 +5571,7 @@
           <p:cNvPr id="16" name="flipV-ungrouped child purple triangle">
             <a:extLst>
               <a:ext uri="{FF2B5EF4-FFF2-40B4-BE49-F238E27FC236}">
-                <a16:creationId xmlns:a16="http://schemas.microsoft.com/office/drawing/2014/main" id="{5E25060E-D50D-8F9A-DF57-393ACA1C57C9}"/>
+                <a16:creationId xmlns:a16="http://schemas.microsoft.com/office/drawing/2014/main" id="{9EE54A7A-23DA-E5A9-F0ED-3443D26F25B2}"/>
               </a:ext>
             </a:extLst>
           </p:cNvPr>
@@ -4965,18 +5580,18 @@
         </p:nvSpPr>
         <p:spPr>
           <a:xfrm flipV="1">
-            <a:off x="8940800" y="1206500"/>
+            <a:off x="7289800" y="1219200"/>
             <a:ext cx="1168400" cy="787400"/>
           </a:xfrm>
           <a:prstGeom prst="triangle">
             <a:avLst/>
           </a:prstGeom>
           <a:solidFill>
-            <a:srgbClr val="C25FB1"/>
+            <a:srgbClr val="7D50AA"/>
           </a:solidFill>
-          <a:ln>
+          <a:ln w="12700">
             <a:solidFill>
-              <a:srgbClr val="69215E"/>
+              <a:srgbClr val="323232"/>
             </a:solidFill>
           </a:ln>
         </p:spPr>
@@ -5001,19 +5616,16 @@
           <a:lstStyle/>
           <a:p>
             <a:pPr algn="ctr"/>
-            <a:r>
-              <a:rPr lang="en-US" sz="1400"/>
-              <a:t>C</a:t>
-            </a:r>
-          </a:p>
-        </p:txBody>
-      </p:sp>
-      <p:sp>
-        <p:nvSpPr>
-          <p:cNvPr id="18" name="TextBox 17">
-            <a:extLst>
-              <a:ext uri="{FF2B5EF4-FFF2-40B4-BE49-F238E27FC236}">
-                <a16:creationId xmlns:a16="http://schemas.microsoft.com/office/drawing/2014/main" id="{E00AC11B-92EF-CDCF-A447-560552FBA89D}"/>
+            <a:endParaRPr lang="en-US"/>
+          </a:p>
+        </p:txBody>
+      </p:sp>
+      <p:sp>
+        <p:nvSpPr>
+          <p:cNvPr id="18" name="label rot330-flipHV">
+            <a:extLst>
+              <a:ext uri="{FF2B5EF4-FFF2-40B4-BE49-F238E27FC236}">
+                <a16:creationId xmlns:a16="http://schemas.microsoft.com/office/drawing/2014/main" id="{4DFACB0D-65DE-2A9B-ED1B-BE3E0215B97C}"/>
               </a:ext>
             </a:extLst>
           </p:cNvPr>
@@ -5022,8 +5634,8 @@
         </p:nvSpPr>
         <p:spPr>
           <a:xfrm>
-            <a:off x="4445000" y="3898900"/>
-            <a:ext cx="2667000" cy="246221"/>
+            <a:off x="9525000" y="889000"/>
+            <a:ext cx="2603500" cy="230832"/>
           </a:xfrm>
           <a:prstGeom prst="rect">
             <a:avLst/>
@@ -5037,8 +5649,10 @@
           <a:lstStyle/>
           <a:p>
             <a:r>
-              <a:rPr lang="en-US" sz="1000">
-                <a:latin typeface="Aptos" panose="020B0004020202020204" pitchFamily="34" charset="0"/>
+              <a:rPr lang="en-US" sz="900">
+                <a:solidFill>
+                  <a:srgbClr val="282828"/>
+                </a:solidFill>
               </a:rPr>
               <a:t>rot330-flipHV</a:t>
             </a:r>
@@ -5050,7 +5664,7 @@
           <p:cNvPr id="19" name="rot330-flipHV-ungrouped child blue rect">
             <a:extLst>
               <a:ext uri="{FF2B5EF4-FFF2-40B4-BE49-F238E27FC236}">
-                <a16:creationId xmlns:a16="http://schemas.microsoft.com/office/drawing/2014/main" id="{9BB0E20F-8E09-A14A-3C87-94382C0102D0}"/>
+                <a16:creationId xmlns:a16="http://schemas.microsoft.com/office/drawing/2014/main" id="{9BFE9F96-61F5-90B6-23CA-B0D8573C13A5}"/>
               </a:ext>
             </a:extLst>
           </p:cNvPr>
@@ -5059,18 +5673,18 @@
         </p:nvSpPr>
         <p:spPr>
           <a:xfrm rot="19800000" flipH="1" flipV="1">
-            <a:off x="5824285" y="5231122"/>
+            <a:off x="10904285" y="2195822"/>
             <a:ext cx="1219200" cy="609600"/>
           </a:xfrm>
           <a:prstGeom prst="rect">
             <a:avLst/>
           </a:prstGeom>
           <a:solidFill>
-            <a:srgbClr val="3F95D9"/>
+            <a:srgbClr val="4375CD"/>
           </a:solidFill>
-          <a:ln>
+          <a:ln w="12700">
             <a:solidFill>
-              <a:srgbClr val="004B7A"/>
+              <a:srgbClr val="323232"/>
             </a:solidFill>
           </a:ln>
         </p:spPr>
@@ -5095,10 +5709,7 @@
           <a:lstStyle/>
           <a:p>
             <a:pPr algn="ctr"/>
-            <a:r>
-              <a:rPr lang="en-US" sz="1400"/>
-              <a:t>A</a:t>
-            </a:r>
+            <a:endParaRPr lang="en-US"/>
           </a:p>
         </p:txBody>
       </p:sp>
@@ -5107,7 +5718,7 @@
           <p:cNvPr id="20" name="rot330-flipHV-ungrouped child green oval">
             <a:extLst>
               <a:ext uri="{FF2B5EF4-FFF2-40B4-BE49-F238E27FC236}">
-                <a16:creationId xmlns:a16="http://schemas.microsoft.com/office/drawing/2014/main" id="{A72FCF45-C0B9-2C0A-3ACC-8C7AB6C790AB}"/>
+                <a16:creationId xmlns:a16="http://schemas.microsoft.com/office/drawing/2014/main" id="{62FAE74A-29BA-CCBE-F0A3-B7A7E53354D8}"/>
               </a:ext>
             </a:extLst>
           </p:cNvPr>
@@ -5116,18 +5727,18 @@
         </p:nvSpPr>
         <p:spPr>
           <a:xfrm rot="19800000" flipH="1" flipV="1">
-            <a:off x="4615693" y="5374135"/>
+            <a:off x="9695693" y="2338835"/>
             <a:ext cx="736600" cy="736600"/>
           </a:xfrm>
           <a:prstGeom prst="ellipse">
             <a:avLst/>
           </a:prstGeom>
           <a:solidFill>
-            <a:srgbClr val="32A865"/>
+            <a:srgbClr val="50A05A"/>
           </a:solidFill>
-          <a:ln>
+          <a:ln w="12700">
             <a:solidFill>
-              <a:srgbClr val="225522"/>
+              <a:srgbClr val="323232"/>
             </a:solidFill>
           </a:ln>
         </p:spPr>
@@ -5152,10 +5763,7 @@
           <a:lstStyle/>
           <a:p>
             <a:pPr algn="ctr"/>
-            <a:r>
-              <a:rPr lang="en-US" sz="1400"/>
-              <a:t>B</a:t>
-            </a:r>
+            <a:endParaRPr lang="en-US"/>
           </a:p>
         </p:txBody>
       </p:sp>
@@ -5164,7 +5772,7 @@
           <p:cNvPr id="21" name="rot330-flipHV-ungrouped child purple triangle">
             <a:extLst>
               <a:ext uri="{FF2B5EF4-FFF2-40B4-BE49-F238E27FC236}">
-                <a16:creationId xmlns:a16="http://schemas.microsoft.com/office/drawing/2014/main" id="{5B171739-31EC-00B3-18FF-8C6AF2B3BC36}"/>
+                <a16:creationId xmlns:a16="http://schemas.microsoft.com/office/drawing/2014/main" id="{7AA0752B-C840-7284-8B99-DD8B3636A1C7}"/>
               </a:ext>
             </a:extLst>
           </p:cNvPr>
@@ -5173,18 +5781,18 @@
         </p:nvSpPr>
         <p:spPr>
           <a:xfrm rot="19800000" flipH="1" flipV="1">
-            <a:off x="4759097" y="4320068"/>
+            <a:off x="9839097" y="1284768"/>
             <a:ext cx="1168400" cy="787400"/>
           </a:xfrm>
           <a:prstGeom prst="triangle">
             <a:avLst/>
           </a:prstGeom>
           <a:solidFill>
-            <a:srgbClr val="C25FB1"/>
+            <a:srgbClr val="7D50AA"/>
           </a:solidFill>
-          <a:ln>
+          <a:ln w="12700">
             <a:solidFill>
-              <a:srgbClr val="69215E"/>
+              <a:srgbClr val="323232"/>
             </a:solidFill>
           </a:ln>
         </p:spPr>
@@ -5209,19 +5817,16 @@
           <a:lstStyle/>
           <a:p>
             <a:pPr algn="ctr"/>
-            <a:r>
-              <a:rPr lang="en-US" sz="1400"/>
-              <a:t>C</a:t>
-            </a:r>
-          </a:p>
-        </p:txBody>
-      </p:sp>
-      <p:sp>
-        <p:nvSpPr>
-          <p:cNvPr id="23" name="TextBox 22">
-            <a:extLst>
-              <a:ext uri="{FF2B5EF4-FFF2-40B4-BE49-F238E27FC236}">
-                <a16:creationId xmlns:a16="http://schemas.microsoft.com/office/drawing/2014/main" id="{6D0936B8-8BA1-5BC4-E1A9-4FB54E5A9B3D}"/>
+            <a:endParaRPr lang="en-US"/>
+          </a:p>
+        </p:txBody>
+      </p:sp>
+      <p:sp>
+        <p:nvSpPr>
+          <p:cNvPr id="23" name="label scale-rot">
+            <a:extLst>
+              <a:ext uri="{FF2B5EF4-FFF2-40B4-BE49-F238E27FC236}">
+                <a16:creationId xmlns:a16="http://schemas.microsoft.com/office/drawing/2014/main" id="{DFCFFC2E-E95A-5059-3B3F-E3C1122099EC}"/>
               </a:ext>
             </a:extLst>
           </p:cNvPr>
@@ -5230,8 +5835,8 @@
         </p:nvSpPr>
         <p:spPr>
           <a:xfrm>
-            <a:off x="304800" y="6350000"/>
-            <a:ext cx="11176000" cy="230832"/>
+            <a:off x="889000" y="4051300"/>
+            <a:ext cx="2603500" cy="230832"/>
           </a:xfrm>
           <a:prstGeom prst="rect">
             <a:avLst/>
@@ -5246,17 +5851,583 @@
           <a:p>
             <a:r>
               <a:rPr lang="en-US" sz="900">
-                <a:latin typeface="Aptos" panose="020B0004020202020204" pitchFamily="34" charset="0"/>
+                <a:solidFill>
+                  <a:srgbClr val="282828"/>
+                </a:solidFill>
               </a:rPr>
-              <a:t>Fixture intent: child absolute frames must account for enclosing group rot/flipH/flipV, not only off/ext scaling.</a:t>
-            </a:r>
+              <a:t>scale-rot</a:t>
+            </a:r>
+          </a:p>
+        </p:txBody>
+      </p:sp>
+      <p:sp>
+        <p:nvSpPr>
+          <p:cNvPr id="24" name="scale-rot-ungrouped child blue rect">
+            <a:extLst>
+              <a:ext uri="{FF2B5EF4-FFF2-40B4-BE49-F238E27FC236}">
+                <a16:creationId xmlns:a16="http://schemas.microsoft.com/office/drawing/2014/main" id="{4F8AD937-4934-A584-4443-F539EF7C46CC}"/>
+              </a:ext>
+            </a:extLst>
+          </p:cNvPr>
+          <p:cNvSpPr/>
+          <p:nvPr/>
+        </p:nvSpPr>
+        <p:spPr>
+          <a:xfrm rot="1500000">
+            <a:off x="1191370" y="4121483"/>
+            <a:ext cx="1609344" cy="499872"/>
+          </a:xfrm>
+          <a:prstGeom prst="rect">
+            <a:avLst/>
+          </a:prstGeom>
+          <a:solidFill>
+            <a:srgbClr val="4375CD"/>
+          </a:solidFill>
+          <a:ln w="12700">
+            <a:solidFill>
+              <a:srgbClr val="323232"/>
+            </a:solidFill>
+          </a:ln>
+        </p:spPr>
+        <p:style>
+          <a:lnRef idx="2">
+            <a:schemeClr val="accent1">
+              <a:shade val="15000"/>
+            </a:schemeClr>
+          </a:lnRef>
+          <a:fillRef idx="1">
+            <a:schemeClr val="accent1"/>
+          </a:fillRef>
+          <a:effectRef idx="0">
+            <a:schemeClr val="accent1"/>
+          </a:effectRef>
+          <a:fontRef idx="minor">
+            <a:schemeClr val="lt1"/>
+          </a:fontRef>
+        </p:style>
+        <p:txBody>
+          <a:bodyPr rtlCol="0" anchor="ctr"/>
+          <a:lstStyle/>
+          <a:p>
+            <a:pPr algn="ctr"/>
+            <a:endParaRPr lang="en-US"/>
+          </a:p>
+        </p:txBody>
+      </p:sp>
+      <p:sp>
+        <p:nvSpPr>
+          <p:cNvPr id="25" name="scale-rot-ungrouped child green oval">
+            <a:extLst>
+              <a:ext uri="{FF2B5EF4-FFF2-40B4-BE49-F238E27FC236}">
+                <a16:creationId xmlns:a16="http://schemas.microsoft.com/office/drawing/2014/main" id="{ECD1D6BC-1F80-8D59-3B62-D8461EB94BA3}"/>
+              </a:ext>
+            </a:extLst>
+          </p:cNvPr>
+          <p:cNvSpPr/>
+          <p:nvPr/>
+        </p:nvSpPr>
+        <p:spPr>
+          <a:xfrm rot="1500000">
+            <a:off x="2946324" y="5233330"/>
+            <a:ext cx="972312" cy="604012"/>
+          </a:xfrm>
+          <a:prstGeom prst="ellipse">
+            <a:avLst/>
+          </a:prstGeom>
+          <a:solidFill>
+            <a:srgbClr val="50A05A"/>
+          </a:solidFill>
+          <a:ln w="12700">
+            <a:solidFill>
+              <a:srgbClr val="323232"/>
+            </a:solidFill>
+          </a:ln>
+        </p:spPr>
+        <p:style>
+          <a:lnRef idx="2">
+            <a:schemeClr val="accent1">
+              <a:shade val="15000"/>
+            </a:schemeClr>
+          </a:lnRef>
+          <a:fillRef idx="1">
+            <a:schemeClr val="accent1"/>
+          </a:fillRef>
+          <a:effectRef idx="0">
+            <a:schemeClr val="accent1"/>
+          </a:effectRef>
+          <a:fontRef idx="minor">
+            <a:schemeClr val="lt1"/>
+          </a:fontRef>
+        </p:style>
+        <p:txBody>
+          <a:bodyPr rtlCol="0" anchor="ctr"/>
+          <a:lstStyle/>
+          <a:p>
+            <a:pPr algn="ctr"/>
+            <a:endParaRPr lang="en-US"/>
+          </a:p>
+        </p:txBody>
+      </p:sp>
+      <p:sp>
+        <p:nvSpPr>
+          <p:cNvPr id="26" name="scale-rot-ungrouped child purple triangle">
+            <a:extLst>
+              <a:ext uri="{FF2B5EF4-FFF2-40B4-BE49-F238E27FC236}">
+                <a16:creationId xmlns:a16="http://schemas.microsoft.com/office/drawing/2014/main" id="{6D4FFC17-E5A1-FB07-15B4-847426ED6572}"/>
+              </a:ext>
+            </a:extLst>
+          </p:cNvPr>
+          <p:cNvSpPr/>
+          <p:nvPr/>
+        </p:nvSpPr>
+        <p:spPr>
+          <a:xfrm rot="1500000">
+            <a:off x="1427305" y="5280536"/>
+            <a:ext cx="1542288" cy="645668"/>
+          </a:xfrm>
+          <a:prstGeom prst="triangle">
+            <a:avLst/>
+          </a:prstGeom>
+          <a:solidFill>
+            <a:srgbClr val="7D50AA"/>
+          </a:solidFill>
+          <a:ln w="12700">
+            <a:solidFill>
+              <a:srgbClr val="323232"/>
+            </a:solidFill>
+          </a:ln>
+        </p:spPr>
+        <p:style>
+          <a:lnRef idx="2">
+            <a:schemeClr val="accent1">
+              <a:shade val="15000"/>
+            </a:schemeClr>
+          </a:lnRef>
+          <a:fillRef idx="1">
+            <a:schemeClr val="accent1"/>
+          </a:fillRef>
+          <a:effectRef idx="0">
+            <a:schemeClr val="accent1"/>
+          </a:effectRef>
+          <a:fontRef idx="minor">
+            <a:schemeClr val="lt1"/>
+          </a:fontRef>
+        </p:style>
+        <p:txBody>
+          <a:bodyPr rtlCol="0" anchor="ctr"/>
+          <a:lstStyle/>
+          <a:p>
+            <a:pPr algn="ctr"/>
+            <a:endParaRPr lang="en-US"/>
+          </a:p>
+        </p:txBody>
+      </p:sp>
+      <p:sp>
+        <p:nvSpPr>
+          <p:cNvPr id="28" name="label childrot-in-rot">
+            <a:extLst>
+              <a:ext uri="{FF2B5EF4-FFF2-40B4-BE49-F238E27FC236}">
+                <a16:creationId xmlns:a16="http://schemas.microsoft.com/office/drawing/2014/main" id="{A8A48389-5D98-D065-BB9D-590BA4790173}"/>
+              </a:ext>
+            </a:extLst>
+          </p:cNvPr>
+          <p:cNvSpPr txBox="1"/>
+          <p:nvPr/>
+        </p:nvSpPr>
+        <p:spPr>
+          <a:xfrm>
+            <a:off x="4000500" y="4051300"/>
+            <a:ext cx="2603500" cy="230832"/>
+          </a:xfrm>
+          <a:prstGeom prst="rect">
+            <a:avLst/>
+          </a:prstGeom>
+          <a:noFill/>
+        </p:spPr>
+        <p:txBody>
+          <a:bodyPr vert="horz" rtlCol="0">
+            <a:spAutoFit/>
+          </a:bodyPr>
+          <a:lstStyle/>
+          <a:p>
+            <a:r>
+              <a:rPr lang="en-US" sz="900">
+                <a:solidFill>
+                  <a:srgbClr val="282828"/>
+                </a:solidFill>
+              </a:rPr>
+              <a:t>childrot-in-rot</a:t>
+            </a:r>
+          </a:p>
+        </p:txBody>
+      </p:sp>
+      <p:sp>
+        <p:nvSpPr>
+          <p:cNvPr id="29" name="childrot-in-rot-ungrouped child rot20 rect">
+            <a:extLst>
+              <a:ext uri="{FF2B5EF4-FFF2-40B4-BE49-F238E27FC236}">
+                <a16:creationId xmlns:a16="http://schemas.microsoft.com/office/drawing/2014/main" id="{EA116F3B-DE3F-0684-412E-EBC045E784F2}"/>
+              </a:ext>
+            </a:extLst>
+          </p:cNvPr>
+          <p:cNvSpPr/>
+          <p:nvPr/>
+        </p:nvSpPr>
+        <p:spPr>
+          <a:xfrm rot="900000" flipV="1">
+            <a:off x="3727361" y="5247785"/>
+            <a:ext cx="1143000" cy="609600"/>
+          </a:xfrm>
+          <a:prstGeom prst="rect">
+            <a:avLst/>
+          </a:prstGeom>
+          <a:solidFill>
+            <a:srgbClr val="DE7337"/>
+          </a:solidFill>
+          <a:ln w="12700">
+            <a:solidFill>
+              <a:srgbClr val="323232"/>
+            </a:solidFill>
+          </a:ln>
+        </p:spPr>
+        <p:style>
+          <a:lnRef idx="2">
+            <a:schemeClr val="accent1">
+              <a:shade val="15000"/>
+            </a:schemeClr>
+          </a:lnRef>
+          <a:fillRef idx="1">
+            <a:schemeClr val="accent1"/>
+          </a:fillRef>
+          <a:effectRef idx="0">
+            <a:schemeClr val="accent1"/>
+          </a:effectRef>
+          <a:fontRef idx="minor">
+            <a:schemeClr val="lt1"/>
+          </a:fontRef>
+        </p:style>
+        <p:txBody>
+          <a:bodyPr rtlCol="0" anchor="ctr"/>
+          <a:lstStyle/>
+          <a:p>
+            <a:pPr algn="ctr"/>
+            <a:endParaRPr lang="en-US"/>
+          </a:p>
+        </p:txBody>
+      </p:sp>
+      <p:sp>
+        <p:nvSpPr>
+          <p:cNvPr id="30" name="childrot-in-rot-ungrouped child flipH oval">
+            <a:extLst>
+              <a:ext uri="{FF2B5EF4-FFF2-40B4-BE49-F238E27FC236}">
+                <a16:creationId xmlns:a16="http://schemas.microsoft.com/office/drawing/2014/main" id="{60CB8F02-EAC5-9869-19E0-8D5DFA390798}"/>
+              </a:ext>
+            </a:extLst>
+          </p:cNvPr>
+          <p:cNvSpPr/>
+          <p:nvPr/>
+        </p:nvSpPr>
+        <p:spPr>
+          <a:xfrm rot="2100000" flipH="1" flipV="1">
+            <a:off x="5336953" y="5514082"/>
+            <a:ext cx="762000" cy="762000"/>
+          </a:xfrm>
+          <a:prstGeom prst="ellipse">
+            <a:avLst/>
+          </a:prstGeom>
+          <a:solidFill>
+            <a:srgbClr val="50A05A"/>
+          </a:solidFill>
+          <a:ln w="12700">
+            <a:solidFill>
+              <a:srgbClr val="323232"/>
+            </a:solidFill>
+          </a:ln>
+        </p:spPr>
+        <p:style>
+          <a:lnRef idx="2">
+            <a:schemeClr val="accent1">
+              <a:shade val="15000"/>
+            </a:schemeClr>
+          </a:lnRef>
+          <a:fillRef idx="1">
+            <a:schemeClr val="accent1"/>
+          </a:fillRef>
+          <a:effectRef idx="0">
+            <a:schemeClr val="accent1"/>
+          </a:effectRef>
+          <a:fontRef idx="minor">
+            <a:schemeClr val="lt1"/>
+          </a:fontRef>
+        </p:style>
+        <p:txBody>
+          <a:bodyPr rtlCol="0" anchor="ctr"/>
+          <a:lstStyle/>
+          <a:p>
+            <a:pPr algn="ctr"/>
+            <a:endParaRPr lang="en-US"/>
+          </a:p>
+        </p:txBody>
+      </p:sp>
+      <p:sp>
+        <p:nvSpPr>
+          <p:cNvPr id="31" name="childrot-in-rot-ungrouped child baseline triangle">
+            <a:extLst>
+              <a:ext uri="{FF2B5EF4-FFF2-40B4-BE49-F238E27FC236}">
+                <a16:creationId xmlns:a16="http://schemas.microsoft.com/office/drawing/2014/main" id="{E0E77724-1483-6C18-9439-FFF942ED0024}"/>
+              </a:ext>
+            </a:extLst>
+          </p:cNvPr>
+          <p:cNvSpPr/>
+          <p:nvPr/>
+        </p:nvSpPr>
+        <p:spPr>
+          <a:xfrm rot="2100000" flipV="1">
+            <a:off x="4940590" y="4501720"/>
+            <a:ext cx="1143000" cy="762000"/>
+          </a:xfrm>
+          <a:prstGeom prst="triangle">
+            <a:avLst/>
+          </a:prstGeom>
+          <a:solidFill>
+            <a:srgbClr val="7D50AA"/>
+          </a:solidFill>
+          <a:ln w="12700">
+            <a:solidFill>
+              <a:srgbClr val="323232"/>
+            </a:solidFill>
+          </a:ln>
+        </p:spPr>
+        <p:style>
+          <a:lnRef idx="2">
+            <a:schemeClr val="accent1">
+              <a:shade val="15000"/>
+            </a:schemeClr>
+          </a:lnRef>
+          <a:fillRef idx="1">
+            <a:schemeClr val="accent1"/>
+          </a:fillRef>
+          <a:effectRef idx="0">
+            <a:schemeClr val="accent1"/>
+          </a:effectRef>
+          <a:fontRef idx="minor">
+            <a:schemeClr val="lt1"/>
+          </a:fontRef>
+        </p:style>
+        <p:txBody>
+          <a:bodyPr rtlCol="0" anchor="ctr"/>
+          <a:lstStyle/>
+          <a:p>
+            <a:pPr algn="ctr"/>
+            <a:endParaRPr lang="en-US"/>
+          </a:p>
+        </p:txBody>
+      </p:sp>
+      <p:sp>
+        <p:nvSpPr>
+          <p:cNvPr id="33" name="label nested-rot-in-scale">
+            <a:extLst>
+              <a:ext uri="{FF2B5EF4-FFF2-40B4-BE49-F238E27FC236}">
+                <a16:creationId xmlns:a16="http://schemas.microsoft.com/office/drawing/2014/main" id="{B72DEC12-7232-8B4B-AC24-B6CF95B48B88}"/>
+              </a:ext>
+            </a:extLst>
+          </p:cNvPr>
+          <p:cNvSpPr txBox="1"/>
+          <p:nvPr/>
+        </p:nvSpPr>
+        <p:spPr>
+          <a:xfrm>
+            <a:off x="7429500" y="4051300"/>
+            <a:ext cx="2794000" cy="230832"/>
+          </a:xfrm>
+          <a:prstGeom prst="rect">
+            <a:avLst/>
+          </a:prstGeom>
+          <a:noFill/>
+        </p:spPr>
+        <p:txBody>
+          <a:bodyPr vert="horz" rtlCol="0">
+            <a:spAutoFit/>
+          </a:bodyPr>
+          <a:lstStyle/>
+          <a:p>
+            <a:r>
+              <a:rPr lang="en-US" sz="900">
+                <a:solidFill>
+                  <a:srgbClr val="282828"/>
+                </a:solidFill>
+              </a:rPr>
+              <a:t>nested-rot-in-scale</a:t>
+            </a:r>
+          </a:p>
+        </p:txBody>
+      </p:sp>
+      <p:sp>
+        <p:nvSpPr>
+          <p:cNvPr id="34" name="nested-rot-in-scale-ungrouped child inner blue rect">
+            <a:extLst>
+              <a:ext uri="{FF2B5EF4-FFF2-40B4-BE49-F238E27FC236}">
+                <a16:creationId xmlns:a16="http://schemas.microsoft.com/office/drawing/2014/main" id="{8F25FB3D-B442-AABC-79EA-3CBF32D51DBC}"/>
+              </a:ext>
+            </a:extLst>
+          </p:cNvPr>
+          <p:cNvSpPr/>
+          <p:nvPr/>
+        </p:nvSpPr>
+        <p:spPr>
+          <a:xfrm rot="2400000">
+            <a:off x="7798401" y="4090017"/>
+            <a:ext cx="1270000" cy="437388"/>
+          </a:xfrm>
+          <a:prstGeom prst="rect">
+            <a:avLst/>
+          </a:prstGeom>
+          <a:solidFill>
+            <a:srgbClr val="4375CD"/>
+          </a:solidFill>
+          <a:ln w="12700">
+            <a:solidFill>
+              <a:srgbClr val="323232"/>
+            </a:solidFill>
+          </a:ln>
+        </p:spPr>
+        <p:style>
+          <a:lnRef idx="2">
+            <a:schemeClr val="accent1">
+              <a:shade val="15000"/>
+            </a:schemeClr>
+          </a:lnRef>
+          <a:fillRef idx="1">
+            <a:schemeClr val="accent1"/>
+          </a:fillRef>
+          <a:effectRef idx="0">
+            <a:schemeClr val="accent1"/>
+          </a:effectRef>
+          <a:fontRef idx="minor">
+            <a:schemeClr val="lt1"/>
+          </a:fontRef>
+        </p:style>
+        <p:txBody>
+          <a:bodyPr rtlCol="0" anchor="ctr"/>
+          <a:lstStyle/>
+          <a:p>
+            <a:pPr algn="ctr"/>
+            <a:endParaRPr lang="en-US"/>
+          </a:p>
+        </p:txBody>
+      </p:sp>
+      <p:sp>
+        <p:nvSpPr>
+          <p:cNvPr id="35" name="nested-rot-in-scale-ungrouped child inner green oval">
+            <a:extLst>
+              <a:ext uri="{FF2B5EF4-FFF2-40B4-BE49-F238E27FC236}">
+                <a16:creationId xmlns:a16="http://schemas.microsoft.com/office/drawing/2014/main" id="{D5D1847A-102C-5101-5B2A-C4867C8510D7}"/>
+              </a:ext>
+            </a:extLst>
+          </p:cNvPr>
+          <p:cNvSpPr/>
+          <p:nvPr/>
+        </p:nvSpPr>
+        <p:spPr>
+          <a:xfrm rot="2400000">
+            <a:off x="8759764" y="5177635"/>
+            <a:ext cx="857250" cy="562356"/>
+          </a:xfrm>
+          <a:prstGeom prst="ellipse">
+            <a:avLst/>
+          </a:prstGeom>
+          <a:solidFill>
+            <a:srgbClr val="50A05A"/>
+          </a:solidFill>
+          <a:ln w="12700">
+            <a:solidFill>
+              <a:srgbClr val="323232"/>
+            </a:solidFill>
+          </a:ln>
+        </p:spPr>
+        <p:style>
+          <a:lnRef idx="2">
+            <a:schemeClr val="accent1">
+              <a:shade val="15000"/>
+            </a:schemeClr>
+          </a:lnRef>
+          <a:fillRef idx="1">
+            <a:schemeClr val="accent1"/>
+          </a:fillRef>
+          <a:effectRef idx="0">
+            <a:schemeClr val="accent1"/>
+          </a:effectRef>
+          <a:fontRef idx="minor">
+            <a:schemeClr val="lt1"/>
+          </a:fontRef>
+        </p:style>
+        <p:txBody>
+          <a:bodyPr rtlCol="0" anchor="ctr"/>
+          <a:lstStyle/>
+          <a:p>
+            <a:pPr algn="ctr"/>
+            <a:endParaRPr lang="en-US"/>
+          </a:p>
+        </p:txBody>
+      </p:sp>
+      <p:sp>
+        <p:nvSpPr>
+          <p:cNvPr id="37" name="nested-rot-in-scale-ungrouped child outer purple triangle">
+            <a:extLst>
+              <a:ext uri="{FF2B5EF4-FFF2-40B4-BE49-F238E27FC236}">
+                <a16:creationId xmlns:a16="http://schemas.microsoft.com/office/drawing/2014/main" id="{48616D2D-1F5E-37EC-31B1-8C3F41B08110}"/>
+              </a:ext>
+            </a:extLst>
+          </p:cNvPr>
+          <p:cNvSpPr/>
+          <p:nvPr/>
+        </p:nvSpPr>
+        <p:spPr>
+          <a:xfrm rot="900000">
+            <a:off x="8115346" y="5442278"/>
+            <a:ext cx="1333500" cy="604012"/>
+          </a:xfrm>
+          <a:prstGeom prst="triangle">
+            <a:avLst/>
+          </a:prstGeom>
+          <a:solidFill>
+            <a:srgbClr val="7D50AA"/>
+          </a:solidFill>
+          <a:ln w="12700">
+            <a:solidFill>
+              <a:srgbClr val="323232"/>
+            </a:solidFill>
+          </a:ln>
+        </p:spPr>
+        <p:style>
+          <a:lnRef idx="2">
+            <a:schemeClr val="accent1">
+              <a:shade val="15000"/>
+            </a:schemeClr>
+          </a:lnRef>
+          <a:fillRef idx="1">
+            <a:schemeClr val="accent1"/>
+          </a:fillRef>
+          <a:effectRef idx="0">
+            <a:schemeClr val="accent1"/>
+          </a:effectRef>
+          <a:fontRef idx="minor">
+            <a:schemeClr val="lt1"/>
+          </a:fontRef>
+        </p:style>
+        <p:txBody>
+          <a:bodyPr rtlCol="0" anchor="ctr"/>
+          <a:lstStyle/>
+          <a:p>
+            <a:pPr algn="ctr"/>
+            <a:endParaRPr lang="en-US"/>
           </a:p>
         </p:txBody>
       </p:sp>
     </p:spTree>
     <p:extLst>
       <p:ext uri="{BB962C8B-B14F-4D97-AF65-F5344CB8AC3E}">
-        <p14:creationId xmlns:p14="http://schemas.microsoft.com/office/powerpoint/2010/main" val="123277934"/>
+        <p14:creationId xmlns:p14="http://schemas.microsoft.com/office/powerpoint/2010/main" val="3261693292"/>
       </p:ext>
     </p:extLst>
   </p:cSld>

</xml_diff>